<commit_message>
updated in terms of font
</commit_message>
<xml_diff>
--- a/presentations/0519_Stablecoin_Exorbitant_Privilege.pptx
+++ b/presentations/0519_Stablecoin_Exorbitant_Privilege.pptx
@@ -5,18 +5,18 @@
     <p:sldMasterId id="2147483648" r:id="rId1"/>
   </p:sldMasterIdLst>
   <p:notesMasterIdLst>
-    <p:notesMasterId r:id="rId11"/>
+    <p:notesMasterId r:id="rId4"/>
   </p:notesMasterIdLst>
   <p:sldIdLst>
-    <p:sldId id="256" r:id="rId2"/>
-    <p:sldId id="257" r:id="rId3"/>
-    <p:sldId id="258" r:id="rId4"/>
-    <p:sldId id="263" r:id="rId5"/>
-    <p:sldId id="259" r:id="rId6"/>
-    <p:sldId id="260" r:id="rId7"/>
-    <p:sldId id="261" r:id="rId8"/>
-    <p:sldId id="262" r:id="rId9"/>
-    <p:sldId id="265" r:id="rId10"/>
+    <p:sldId id="256" r:id="rId3"/>
+    <p:sldId id="257" r:id="rId5"/>
+    <p:sldId id="258" r:id="rId6"/>
+    <p:sldId id="263" r:id="rId7"/>
+    <p:sldId id="259" r:id="rId8"/>
+    <p:sldId id="260" r:id="rId9"/>
+    <p:sldId id="261" r:id="rId10"/>
+    <p:sldId id="262" r:id="rId11"/>
+    <p:sldId id="265" r:id="rId12"/>
   </p:sldIdLst>
   <p:sldSz cx="12188825" cy="6858000"/>
   <p:notesSz cx="6858000" cy="9144000"/>
@@ -118,7 +118,7 @@
   <p:extLst>
     <p:ext uri="{EFAFB233-063F-42B5-8137-9DF3F51BA10A}">
       <p15:sldGuideLst xmlns:p15="http://schemas.microsoft.com/office/powerpoint/2012/main">
-        <p15:guide id="1" orient="horz" pos="2159" userDrawn="1">
+        <p15:guide id="1" orient="horz" pos="2160" userDrawn="1">
           <p15:clr>
             <a:srgbClr val="A4A3A4"/>
           </p15:clr>
@@ -310,6 +310,7 @@
               <a:rPr dirty="0"/>
               <a:t> — Title Slide]</a:t>
             </a:r>
+            <a:endParaRPr dirty="0"/>
           </a:p>
           <a:p>
             <a:endParaRPr dirty="0"/>
@@ -327,6 +328,7 @@
               <a:rPr dirty="0"/>
               <a:t>e are presenting the second part of our research on stablecoins and the exorbitant privilege.</a:t>
             </a:r>
+            <a:endParaRPr dirty="0"/>
           </a:p>
           <a:p>
             <a:endParaRPr dirty="0"/>
@@ -414,6 +416,7 @@
               <a:rPr dirty="0"/>
               <a:t>[ALEXANDRE — Roadmap]</a:t>
             </a:r>
+            <a:endParaRPr dirty="0"/>
           </a:p>
           <a:p>
             <a:endParaRPr dirty="0"/>
@@ -423,6 +426,7 @@
               <a:rPr dirty="0"/>
               <a:t>This slide gives you a quick map of today's presentation.</a:t>
             </a:r>
+            <a:endParaRPr dirty="0"/>
           </a:p>
           <a:p>
             <a:endParaRPr dirty="0"/>
@@ -444,6 +448,7 @@
               <a:rPr lang="en-US" dirty="0"/>
               <a:t>.</a:t>
             </a:r>
+            <a:endParaRPr lang="en-US" dirty="0"/>
           </a:p>
           <a:p>
             <a:endParaRPr dirty="0"/>
@@ -453,6 +458,7 @@
               <a:rPr dirty="0"/>
               <a:t>Today we add three new things.</a:t>
             </a:r>
+            <a:endParaRPr dirty="0"/>
           </a:p>
           <a:p>
             <a:endParaRPr dirty="0"/>
@@ -462,6 +468,7 @@
               <a:rPr dirty="0"/>
               <a:t>First, a Literature Gap slide — we will show exactly where our paper fits in the existing academic literature and why what we do has not been done before.</a:t>
             </a:r>
+            <a:endParaRPr dirty="0"/>
           </a:p>
           <a:p>
             <a:endParaRPr dirty="0"/>
@@ -471,6 +478,7 @@
               <a:rPr dirty="0"/>
               <a:t>Second, Result 3 — the buffer-conditioned event study. This is where we move from monthly correlations to specific crisis events to show that our mechanism is not just statistical but actually causal.</a:t>
             </a:r>
+            <a:endParaRPr dirty="0"/>
           </a:p>
           <a:p>
             <a:endParaRPr dirty="0"/>
@@ -480,6 +488,7 @@
               <a:rPr dirty="0"/>
               <a:t>Third, two new contributions responding directly to our professor's feedback: an asymmetric effects analysis that splits supply growth from supply contraction, and a reframed policy implication that is more intellectually honest about what our data can and cannot claim.</a:t>
             </a:r>
+            <a:endParaRPr dirty="0"/>
           </a:p>
         </p:txBody>
       </p:sp>
@@ -559,6 +568,7 @@
               <a:rPr dirty="0"/>
               <a:t>— Literature Gap]</a:t>
             </a:r>
+            <a:endParaRPr dirty="0"/>
           </a:p>
           <a:p>
             <a:endParaRPr dirty="0"/>
@@ -568,6 +578,7 @@
               <a:rPr dirty="0"/>
               <a:t>This slide answers the question: what does the existing literature do, and where exactly does our paper add something new?</a:t>
             </a:r>
+            <a:endParaRPr dirty="0"/>
           </a:p>
           <a:p>
             <a:endParaRPr dirty="0"/>
@@ -577,6 +588,7 @@
               <a:rPr dirty="0"/>
               <a:t>On the left panel, you see three papers.</a:t>
             </a:r>
+            <a:endParaRPr dirty="0"/>
           </a:p>
           <a:p>
             <a:endParaRPr dirty="0"/>
@@ -594,6 +606,7 @@
               <a:rPr dirty="0"/>
               <a:t> and Ahmed — a Bank for International Settlements working paper published in 2025. This is the closest paper to ours. They find that stablecoin inflows compress 3-month Treasury bill yields by about 2.5 to 3.5 basis points. They also have a state-dependent interaction term — but their conditioning variable is the supply of Treasury bills in the market, not the liquid reserves held by stablecoin issuers. They also use yield levels as their dependent variable. We use the OIS-Treasury spread, which is a cleaner measure because it isolates demand-side effects from supply-side noise.</a:t>
             </a:r>
+            <a:endParaRPr dirty="0"/>
           </a:p>
           <a:p>
             <a:endParaRPr dirty="0"/>
@@ -603,6 +616,7 @@
               <a:rPr dirty="0"/>
               <a:t>The second paper is Gorton and Zhang, 2023. They draw the analogy between stablecoins and the wildcat banks of the nineteenth century — unregulated private banks that issued their own notes. They document run risk thoroughly, but they do not connect reserve composition to Treasury market dynamics. They do not run the regression we run.</a:t>
             </a:r>
+            <a:endParaRPr dirty="0"/>
           </a:p>
           <a:p>
             <a:endParaRPr dirty="0"/>
@@ -612,6 +626,7 @@
               <a:rPr dirty="0"/>
               <a:t>The third paper is Lyons and Viswanath-Natraj, 2023. They study how stablecoin pegs are maintained through arbitrage — it's a paper about the exchange rate mechanics. They do not connect to sovereign debt markets at all.</a:t>
             </a:r>
+            <a:endParaRPr dirty="0"/>
           </a:p>
           <a:p>
             <a:endParaRPr dirty="0"/>
@@ -621,6 +636,7 @@
               <a:rPr dirty="0"/>
               <a:t>On the right panel, you see what we contribute that none of these papers do. We are the first to jointly include the stablecoin issuance variable AND the issuer's liquid buffer as a moderating variable AND use the OIS-Treasury spread as the outcome. We are also the first to estimate a nonlinear threshold — L* equals 13% — using the Hansen 2000 method. And we are the first to test whether the effect is asymmetric between growth and contraction periods.</a:t>
             </a:r>
+            <a:endParaRPr dirty="0"/>
           </a:p>
           <a:p>
             <a:endParaRPr dirty="0"/>
@@ -630,6 +646,7 @@
               <a:rPr dirty="0"/>
               <a:t>The quote at the bottom summarizes the gap in one sentence.</a:t>
             </a:r>
+            <a:endParaRPr dirty="0"/>
           </a:p>
         </p:txBody>
       </p:sp>
@@ -709,6 +726,7 @@
               <a:rPr dirty="0"/>
               <a:t> — Literature Gap]</a:t>
             </a:r>
+            <a:endParaRPr dirty="0"/>
           </a:p>
           <a:p>
             <a:endParaRPr dirty="0"/>
@@ -718,6 +736,7 @@
               <a:rPr dirty="0"/>
               <a:t>This slide answers the question: what does the existing literature do, and where exactly does our paper add something new?</a:t>
             </a:r>
+            <a:endParaRPr dirty="0"/>
           </a:p>
           <a:p>
             <a:endParaRPr dirty="0"/>
@@ -727,6 +746,7 @@
               <a:rPr dirty="0"/>
               <a:t>On the left panel, you see three papers.</a:t>
             </a:r>
+            <a:endParaRPr dirty="0"/>
           </a:p>
           <a:p>
             <a:endParaRPr dirty="0"/>
@@ -744,6 +764,7 @@
               <a:rPr dirty="0"/>
               <a:t> and Ahmed — a Bank for International Settlements working paper published in 2025. This is the closest paper to ours. They find that stablecoin inflows compress 3-month Treasury bill yields by about 2.5 to 3.5 basis points. They also have a state-dependent interaction term — but their conditioning variable is the supply of Treasury bills in the market, not the liquid reserves held by stablecoin issuers. They also use yield levels as their dependent variable. We use the OIS-Treasury spread, which is a cleaner measure because it isolates demand-side effects from supply-side noise.</a:t>
             </a:r>
+            <a:endParaRPr dirty="0"/>
           </a:p>
           <a:p>
             <a:endParaRPr dirty="0"/>
@@ -753,6 +774,7 @@
               <a:rPr dirty="0"/>
               <a:t>The second paper is Gorton and Zhang, 2023. They draw the analogy between stablecoins and the wildcat banks of the nineteenth century — unregulated private banks that issued their own notes. They document run risk thoroughly, but they do not connect reserve composition to Treasury market dynamics. They do not run the regression we run.</a:t>
             </a:r>
+            <a:endParaRPr dirty="0"/>
           </a:p>
           <a:p>
             <a:endParaRPr dirty="0"/>
@@ -762,6 +784,7 @@
               <a:rPr dirty="0"/>
               <a:t>The third paper is Lyons and Viswanath-Natraj, 2023. They study how stablecoin pegs are maintained through arbitrage — it's a paper about the exchange rate mechanics. They do not connect to sovereign debt markets at all.</a:t>
             </a:r>
+            <a:endParaRPr dirty="0"/>
           </a:p>
           <a:p>
             <a:endParaRPr dirty="0"/>
@@ -771,6 +794,7 @@
               <a:rPr dirty="0"/>
               <a:t>On the right panel, you see what we contribute that none of these papers do. We are the first to jointly include the stablecoin issuance variable AND the issuer's liquid buffer as a moderating variable AND use the OIS-Treasury spread as the outcome. We are also the first to estimate a nonlinear threshold — L* equals 13% — using the Hansen 2000 method. And we are the first to test whether the effect is asymmetric between growth and contraction periods.</a:t>
             </a:r>
+            <a:endParaRPr dirty="0"/>
           </a:p>
           <a:p>
             <a:endParaRPr dirty="0"/>
@@ -780,6 +804,7 @@
               <a:rPr dirty="0"/>
               <a:t>The quote at the bottom summarizes the gap in one sentence.</a:t>
             </a:r>
+            <a:endParaRPr dirty="0"/>
           </a:p>
         </p:txBody>
       </p:sp>
@@ -851,6 +876,7 @@
               <a:rPr dirty="0"/>
               <a:t>[JADE — Result 3: Buffer-Conditioned Event Study]</a:t>
             </a:r>
+            <a:endParaRPr dirty="0"/>
           </a:p>
           <a:p>
             <a:endParaRPr dirty="0"/>
@@ -860,6 +886,7 @@
               <a:rPr dirty="0"/>
               <a:t>Thank you Alexandre. I will now present Result 3 — the event study.</a:t>
             </a:r>
+            <a:endParaRPr dirty="0"/>
           </a:p>
           <a:p>
             <a:endParaRPr dirty="0"/>
@@ -869,6 +896,7 @@
               <a:rPr dirty="0"/>
               <a:t>Up until now, our results have been based on monthly regressions across the full sample. That tells us about average relationships. But it does not tell us whether the buffer mechanism actually works in the moments that matter most — during a crisis.</a:t>
             </a:r>
+            <a:endParaRPr dirty="0"/>
           </a:p>
           <a:p>
             <a:endParaRPr dirty="0"/>
@@ -878,6 +906,7 @@
               <a:rPr dirty="0"/>
               <a:t>The event study fixes that. We take three real-world stress episodes and ask: what happened to the OIS-Treasury spread in the days immediately following each event? And does the answer depend on how large the liquid buffer was at the time?</a:t>
             </a:r>
+            <a:endParaRPr dirty="0"/>
           </a:p>
           <a:p>
             <a:endParaRPr dirty="0"/>
@@ -887,6 +916,7 @@
               <a:rPr dirty="0"/>
               <a:t>We measure the Cumulative Abnormal Return — or CAR — on the spread. A positive CAR means the spread spiked upward, which means Treasury yields rose relative to overnight rates — a sign that stablecoin issuers were forced to sell T-bills, increasing their supply and pushing prices down.</a:t>
             </a:r>
+            <a:endParaRPr dirty="0"/>
           </a:p>
           <a:p>
             <a:endParaRPr dirty="0"/>
@@ -896,6 +926,7 @@
               <a:rPr dirty="0"/>
               <a:t>Now look at the table on the right.</a:t>
             </a:r>
+            <a:endParaRPr dirty="0"/>
           </a:p>
           <a:p>
             <a:endParaRPr dirty="0"/>
@@ -913,6 +944,7 @@
               <a:rPr dirty="0"/>
               <a:t> shortly after — both happened when the liquid buffer was LOW. The CAR in both cases is strongly positive: plus 8.9 and plus 8.8 basis points, both significant at the 1% level with t-statistics above 30. This is a large and unambiguous effect. Issuers did not have enough cash to absorb redemptions, so they sold T-bills, and the spread spiked.</a:t>
             </a:r>
+            <a:endParaRPr dirty="0"/>
           </a:p>
           <a:p>
             <a:endParaRPr dirty="0"/>
@@ -922,6 +954,7 @@
               <a:rPr dirty="0"/>
               <a:t>The third event — the USDC and SVB failure in March 2023 — is where the result becomes really interesting. By early 2023, the liquid buffer had recovered above the 13% threshold. The CAR is NEGATIVE: minus 18 basis points. The spread compressed instead of spiking. Why? Because Circle had enough cash to absorb redemptions without touching its T-bill holdings. What investors saw instead was a flight-to-safety into Treasuries — the usual response to a financial shock when the stablecoin system is not forced to liquidate.</a:t>
             </a:r>
+            <a:endParaRPr dirty="0"/>
           </a:p>
           <a:p>
             <a:endParaRPr dirty="0"/>
@@ -931,6 +964,7 @@
               <a:rPr dirty="0"/>
               <a:t>The difference between these two regimes is statistically confirmed: t-statistic of 15.22, p-value below 0.001.</a:t>
             </a:r>
+            <a:endParaRPr dirty="0"/>
           </a:p>
           <a:p>
             <a:endParaRPr dirty="0"/>
@@ -940,6 +974,7 @@
               <a:rPr dirty="0"/>
               <a:t>This is the cleanest evidence we have that the buffer is not just a number — it is what separates a crisis that spreads to sovereign debt markets from one that does not.</a:t>
             </a:r>
+            <a:endParaRPr dirty="0"/>
           </a:p>
         </p:txBody>
       </p:sp>
@@ -1011,6 +1046,7 @@
               <a:rPr dirty="0"/>
               <a:t>[JADE — Asymmetric Effects]</a:t>
             </a:r>
+            <a:endParaRPr dirty="0"/>
           </a:p>
           <a:p>
             <a:endParaRPr dirty="0"/>
@@ -1020,6 +1056,7 @@
               <a:rPr dirty="0"/>
               <a:t>This slide presents a new result that responds directly to our professor's question from last week: why is the buffer interaction term positive?</a:t>
             </a:r>
+            <a:endParaRPr dirty="0"/>
           </a:p>
           <a:p>
             <a:endParaRPr dirty="0"/>
@@ -1037,6 +1074,7 @@
               <a:rPr dirty="0"/>
               <a:t> is positive and equal to 49.17. The intuition our professor questioned was: if a higher buffer means the issuer holds more cash and fewer T-bills, shouldn't a bigger buffer reduce the spread compression during supply growth — because they are buying fewer T-bills? So why is the sign positive?</a:t>
             </a:r>
+            <a:endParaRPr dirty="0"/>
           </a:p>
           <a:p>
             <a:endParaRPr dirty="0"/>
@@ -1046,6 +1084,7 @@
               <a:rPr dirty="0"/>
               <a:t>The answer comes from separating supply growth from supply contraction. That is what this slide shows.</a:t>
             </a:r>
+            <a:endParaRPr dirty="0"/>
           </a:p>
           <a:p>
             <a:endParaRPr dirty="0"/>
@@ -1055,6 +1094,7 @@
               <a:rPr dirty="0"/>
               <a:t>On the left, in red, are the 32 months in our sample when stablecoin supply was growing. The effect of supply growth on the spread is negative — more supply means more T-bill buying, which compresses spreads — but the coefficient is only minus 1.79 and it is not statistically significant. The R-squared is 0.33. During growth periods, the buffer does not matter much because the dynamic is orderly. Issuers buy T-bills gradually as they mint new tokens.</a:t>
             </a:r>
+            <a:endParaRPr dirty="0"/>
           </a:p>
           <a:p>
             <a:endParaRPr dirty="0"/>
@@ -1064,6 +1104,7 @@
               <a:rPr dirty="0"/>
               <a:t>On the right, in green, are the 19 months when supply was contracting. Here, β₁ jumps to minus 12.68 — seven times larger — and it is statistically significant at the 5% level. The R-squared jumps to 0.73. The model explains far more of the variation during stress periods than calm ones. And the buffer interaction term is large and positive — plus 78.57 — meaning a higher buffer significantly dampens the spread spike during redemption periods.</a:t>
             </a:r>
+            <a:endParaRPr dirty="0"/>
           </a:p>
           <a:p>
             <a:endParaRPr dirty="0"/>
@@ -1073,6 +1114,7 @@
               <a:rPr dirty="0"/>
               <a:t>So the answer to the professor's question is this: β₄ is positive because the dominant effect of the buffer is during contractions — where it prevents forced T-bill liquidation — not during growth. The combined positive sign in the main regression reflects this asymmetry. The buffer absorbs redemption shocks. That is the mechanism our paper is about.</a:t>
             </a:r>
+            <a:endParaRPr dirty="0"/>
           </a:p>
           <a:p>
             <a:endParaRPr dirty="0"/>
@@ -1082,6 +1124,7 @@
               <a:rPr dirty="0"/>
               <a:t>Baptiste will now close with the policy implications and conclusion.</a:t>
             </a:r>
+            <a:endParaRPr dirty="0"/>
           </a:p>
         </p:txBody>
       </p:sp>
@@ -1153,6 +1196,7 @@
               <a:rPr dirty="0"/>
               <a:t>[BAPTISTE — Policy Implication]</a:t>
             </a:r>
+            <a:endParaRPr dirty="0"/>
           </a:p>
           <a:p>
             <a:endParaRPr dirty="0"/>
@@ -1162,6 +1206,7 @@
               <a:rPr dirty="0"/>
               <a:t>Thank you Jade. Now let me turn to what our findings mean for policy.</a:t>
             </a:r>
+            <a:endParaRPr dirty="0"/>
           </a:p>
           <a:p>
             <a:endParaRPr dirty="0"/>
@@ -1171,6 +1216,7 @@
               <a:rPr dirty="0"/>
               <a:t>Our threshold regression using the Hansen 2000 method identified L* equals 13% as a statistical break point. Below 13% — which describes 38 out of our 51 sample months — stablecoin activity significantly amplifies Treasury market volatility during stress. Above 13% — the remaining 13 months — the transmission channel is attenuated and runs are absorbed internally.</a:t>
             </a:r>
+            <a:endParaRPr dirty="0"/>
           </a:p>
           <a:p>
             <a:endParaRPr dirty="0"/>
@@ -1180,6 +1226,7 @@
               <a:rPr dirty="0"/>
               <a:t>One thing our professor pointed out last week, and which we want to address directly: our data tells us WHERE the break is. It does not tell us what is OPTIMAL. These are two different things.</a:t>
             </a:r>
+            <a:endParaRPr dirty="0"/>
           </a:p>
           <a:p>
             <a:endParaRPr dirty="0"/>
@@ -1189,6 +1236,7 @@
               <a:rPr dirty="0"/>
               <a:t>Finding a break point at 13% is like finding that bridge failures become much more likely when material stress exceeds a certain level — it tells you something important about the threshold, but it does not tell you what the ideal engineering standard should be. A full welfare analysis — weighing the cost of holding more liquid reserves against the benefit of reduced systemic risk — would require a structural model that goes beyond this paper.</a:t>
             </a:r>
+            <a:endParaRPr dirty="0"/>
           </a:p>
           <a:p>
             <a:endParaRPr dirty="0"/>
@@ -1198,6 +1246,7 @@
               <a:rPr dirty="0"/>
               <a:t>What we are proposing is more modest: that regulators consider 13 to 15% as a minimum empirical floor when designing reserve requirements for fiat-collateralized stablecoin issuers above a systemically relevant size.</a:t>
             </a:r>
+            <a:endParaRPr dirty="0"/>
           </a:p>
           <a:p>
             <a:endParaRPr dirty="0"/>
@@ -1207,6 +1256,7 @@
               <a:rPr dirty="0"/>
               <a:t>The caveat on the bottom right is important. We put it there deliberately. We are acknowledging the limit of what our data can claim, which is exactly the kind of intellectual honesty that distinguishes a research contribution from a policy prescription.</a:t>
             </a:r>
+            <a:endParaRPr dirty="0"/>
           </a:p>
         </p:txBody>
       </p:sp>
@@ -1278,6 +1328,7 @@
               <a:rPr dirty="0"/>
               <a:t>[BAPTISTE — Conclusion]</a:t>
             </a:r>
+            <a:endParaRPr dirty="0"/>
           </a:p>
           <a:p>
             <a:endParaRPr dirty="0"/>
@@ -1287,6 +1338,7 @@
               <a:rPr dirty="0"/>
               <a:t>Let me now bring everything together.</a:t>
             </a:r>
+            <a:endParaRPr dirty="0"/>
           </a:p>
           <a:p>
             <a:endParaRPr dirty="0"/>
@@ -1296,6 +1348,7 @@
               <a:rPr dirty="0"/>
               <a:t>Our paper documents three results that form a coherent story.</a:t>
             </a:r>
+            <a:endParaRPr dirty="0"/>
           </a:p>
           <a:p>
             <a:endParaRPr dirty="0"/>
@@ -1305,6 +1358,7 @@
               <a:rPr dirty="0"/>
               <a:t>The first result — the green box on the left — is the privilege amplification channel. When stablecoin supply grows by 1%, the OIS-Treasury spread compresses by about 6 to 8 basis points. Tether and Circle are mechanically buying US Treasury bills to back their tokens. This deepens demand for safe US assets and amplifies the exorbitant privilege that the United States already enjoys by issuing the world's reserve currency.</a:t>
             </a:r>
+            <a:endParaRPr dirty="0"/>
           </a:p>
           <a:p>
             <a:endParaRPr dirty="0"/>
@@ -1314,6 +1368,7 @@
               <a:rPr dirty="0"/>
               <a:t>The second result — the blue box in the middle — is the safety threshold. Using the Hansen 2000 threshold regression, we identify L* equals 13% as the break point. Below this level, stablecoin activity disrupts Treasury markets during stress. Above it, redemptions are absorbed internally and the market is undisturbed.</a:t>
             </a:r>
+            <a:endParaRPr dirty="0"/>
           </a:p>
           <a:p>
             <a:endParaRPr dirty="0"/>
@@ -1331,6 +1386,7 @@
               <a:rPr dirty="0"/>
               <a:t> in 2022, when buffers were low, spreads spiked by nearly 9 basis points. During the SVB event in 2023, when buffers had recovered, spreads compressed by 18 basis points — a flight-to-safety instead of a forced liquidation. The buffer determined the outcome.</a:t>
             </a:r>
+            <a:endParaRPr dirty="0"/>
           </a:p>
           <a:p>
             <a:endParaRPr dirty="0"/>
@@ -1340,6 +1396,7 @@
               <a:rPr dirty="0"/>
               <a:t>This brings us to the central argument of our paper, which we call the New Triffin Dilemma.</a:t>
             </a:r>
+            <a:endParaRPr dirty="0"/>
           </a:p>
           <a:p>
             <a:endParaRPr dirty="0"/>
@@ -1349,6 +1406,7 @@
               <a:rPr dirty="0"/>
               <a:t>Robert Triffin observed in 1960 that the US dollar's role as the world's reserve currency created an inherent contradiction — supplying enough safe assets to meet global demand requires running current account deficits that eventually undermine confidence in the dollar itself. The system depends on the very condition that makes it unsustainable.</a:t>
             </a:r>
+            <a:endParaRPr dirty="0"/>
           </a:p>
           <a:p>
             <a:endParaRPr dirty="0"/>
@@ -1358,6 +1416,7 @@
               <a:rPr dirty="0"/>
               <a:t>Our paper shows that stablecoins create an analogous dilemma at the private level. The same structural Treasury demand that amplifies American borrowing privilege in normal times embeds a fragility that can rapidly reverse it during runs. Whether a stress episode leads to sovereign contagion or flight-to-safety depends entirely on one variable: L — the liquid buffer.</a:t>
             </a:r>
+            <a:endParaRPr dirty="0"/>
           </a:p>
         </p:txBody>
       </p:sp>
@@ -1490,6 +1549,7 @@
               <a:rPr lang="en-US"/>
               <a:t>Click to edit Master title style</a:t>
             </a:r>
+            <a:endParaRPr lang="en-US"/>
           </a:p>
         </p:txBody>
       </p:sp>
@@ -1608,6 +1668,7 @@
               <a:rPr lang="en-US"/>
               <a:t>Click to edit Master subtitle style</a:t>
             </a:r>
+            <a:endParaRPr lang="en-US"/>
           </a:p>
         </p:txBody>
       </p:sp>
@@ -1628,7 +1689,6 @@
           <a:p>
             <a:fld id="{5BCAD085-E8A6-8845-BD4E-CB4CCA059FC4}" type="datetimeFigureOut">
               <a:rPr lang="en-US" smtClean="0"/>
-              <a:t>5/18/26</a:t>
             </a:fld>
             <a:endParaRPr lang="en-US"/>
           </a:p>
@@ -1670,7 +1730,6 @@
           <a:p>
             <a:fld id="{C1FF6DA9-008F-8B48-92A6-B652298478BF}" type="slidenum">
               <a:rPr lang="en-US" smtClean="0"/>
-              <a:t>‹#›</a:t>
             </a:fld>
             <a:endParaRPr lang="en-US"/>
           </a:p>
@@ -1720,6 +1779,7 @@
               <a:rPr lang="en-US"/>
               <a:t>Click to edit Master title style</a:t>
             </a:r>
+            <a:endParaRPr lang="en-US"/>
           </a:p>
         </p:txBody>
       </p:sp>
@@ -1743,6 +1803,7 @@
               <a:rPr lang="en-US"/>
               <a:t>Click to edit Master text styles</a:t>
             </a:r>
+            <a:endParaRPr lang="en-US"/>
           </a:p>
           <a:p>
             <a:pPr lvl="1"/>
@@ -1750,6 +1811,7 @@
               <a:rPr lang="en-US"/>
               <a:t>Second level</a:t>
             </a:r>
+            <a:endParaRPr lang="en-US"/>
           </a:p>
           <a:p>
             <a:pPr lvl="2"/>
@@ -1757,6 +1819,7 @@
               <a:rPr lang="en-US"/>
               <a:t>Third level</a:t>
             </a:r>
+            <a:endParaRPr lang="en-US"/>
           </a:p>
           <a:p>
             <a:pPr lvl="3"/>
@@ -1764,6 +1827,7 @@
               <a:rPr lang="en-US"/>
               <a:t>Fourth level</a:t>
             </a:r>
+            <a:endParaRPr lang="en-US"/>
           </a:p>
           <a:p>
             <a:pPr lvl="4"/>
@@ -1771,6 +1835,7 @@
               <a:rPr lang="en-US"/>
               <a:t>Fifth level</a:t>
             </a:r>
+            <a:endParaRPr lang="en-US"/>
           </a:p>
         </p:txBody>
       </p:sp>
@@ -1791,7 +1856,6 @@
           <a:p>
             <a:fld id="{5BCAD085-E8A6-8845-BD4E-CB4CCA059FC4}" type="datetimeFigureOut">
               <a:rPr lang="en-US" smtClean="0"/>
-              <a:t>5/18/26</a:t>
             </a:fld>
             <a:endParaRPr lang="en-US"/>
           </a:p>
@@ -1833,7 +1897,6 @@
           <a:p>
             <a:fld id="{C1FF6DA9-008F-8B48-92A6-B652298478BF}" type="slidenum">
               <a:rPr lang="en-US" smtClean="0"/>
-              <a:t>‹#›</a:t>
             </a:fld>
             <a:endParaRPr lang="en-US"/>
           </a:p>
@@ -1888,6 +1951,7 @@
               <a:rPr lang="en-US"/>
               <a:t>Click to edit Master title style</a:t>
             </a:r>
+            <a:endParaRPr lang="en-US"/>
           </a:p>
         </p:txBody>
       </p:sp>
@@ -1916,6 +1980,7 @@
               <a:rPr lang="en-US"/>
               <a:t>Click to edit Master text styles</a:t>
             </a:r>
+            <a:endParaRPr lang="en-US"/>
           </a:p>
           <a:p>
             <a:pPr lvl="1"/>
@@ -1923,6 +1988,7 @@
               <a:rPr lang="en-US"/>
               <a:t>Second level</a:t>
             </a:r>
+            <a:endParaRPr lang="en-US"/>
           </a:p>
           <a:p>
             <a:pPr lvl="2"/>
@@ -1930,6 +1996,7 @@
               <a:rPr lang="en-US"/>
               <a:t>Third level</a:t>
             </a:r>
+            <a:endParaRPr lang="en-US"/>
           </a:p>
           <a:p>
             <a:pPr lvl="3"/>
@@ -1937,6 +2004,7 @@
               <a:rPr lang="en-US"/>
               <a:t>Fourth level</a:t>
             </a:r>
+            <a:endParaRPr lang="en-US"/>
           </a:p>
           <a:p>
             <a:pPr lvl="4"/>
@@ -1944,6 +2012,7 @@
               <a:rPr lang="en-US"/>
               <a:t>Fifth level</a:t>
             </a:r>
+            <a:endParaRPr lang="en-US"/>
           </a:p>
         </p:txBody>
       </p:sp>
@@ -1964,7 +2033,6 @@
           <a:p>
             <a:fld id="{5BCAD085-E8A6-8845-BD4E-CB4CCA059FC4}" type="datetimeFigureOut">
               <a:rPr lang="en-US" smtClean="0"/>
-              <a:t>5/18/26</a:t>
             </a:fld>
             <a:endParaRPr lang="en-US"/>
           </a:p>
@@ -2006,7 +2074,6 @@
           <a:p>
             <a:fld id="{C1FF6DA9-008F-8B48-92A6-B652298478BF}" type="slidenum">
               <a:rPr lang="en-US" smtClean="0"/>
-              <a:t>‹#›</a:t>
             </a:fld>
             <a:endParaRPr lang="en-US"/>
           </a:p>
@@ -2056,6 +2123,7 @@
               <a:rPr lang="en-US"/>
               <a:t>Click to edit Master title style</a:t>
             </a:r>
+            <a:endParaRPr lang="en-US"/>
           </a:p>
         </p:txBody>
       </p:sp>
@@ -2079,6 +2147,7 @@
               <a:rPr lang="en-US"/>
               <a:t>Click to edit Master text styles</a:t>
             </a:r>
+            <a:endParaRPr lang="en-US"/>
           </a:p>
           <a:p>
             <a:pPr lvl="1"/>
@@ -2086,6 +2155,7 @@
               <a:rPr lang="en-US"/>
               <a:t>Second level</a:t>
             </a:r>
+            <a:endParaRPr lang="en-US"/>
           </a:p>
           <a:p>
             <a:pPr lvl="2"/>
@@ -2093,6 +2163,7 @@
               <a:rPr lang="en-US"/>
               <a:t>Third level</a:t>
             </a:r>
+            <a:endParaRPr lang="en-US"/>
           </a:p>
           <a:p>
             <a:pPr lvl="3"/>
@@ -2100,6 +2171,7 @@
               <a:rPr lang="en-US"/>
               <a:t>Fourth level</a:t>
             </a:r>
+            <a:endParaRPr lang="en-US"/>
           </a:p>
           <a:p>
             <a:pPr lvl="4"/>
@@ -2107,6 +2179,7 @@
               <a:rPr lang="en-US"/>
               <a:t>Fifth level</a:t>
             </a:r>
+            <a:endParaRPr lang="en-US"/>
           </a:p>
         </p:txBody>
       </p:sp>
@@ -2127,7 +2200,6 @@
           <a:p>
             <a:fld id="{5BCAD085-E8A6-8845-BD4E-CB4CCA059FC4}" type="datetimeFigureOut">
               <a:rPr lang="en-US" smtClean="0"/>
-              <a:t>5/18/26</a:t>
             </a:fld>
             <a:endParaRPr lang="en-US"/>
           </a:p>
@@ -2169,7 +2241,6 @@
           <a:p>
             <a:fld id="{C1FF6DA9-008F-8B48-92A6-B652298478BF}" type="slidenum">
               <a:rPr lang="en-US" smtClean="0"/>
-              <a:t>‹#›</a:t>
             </a:fld>
             <a:endParaRPr lang="en-US"/>
           </a:p>
@@ -2228,6 +2299,7 @@
               <a:rPr lang="en-US"/>
               <a:t>Click to edit Master title style</a:t>
             </a:r>
+            <a:endParaRPr lang="en-US"/>
           </a:p>
         </p:txBody>
       </p:sp>
@@ -2347,6 +2419,7 @@
               <a:rPr lang="en-US"/>
               <a:t>Click to edit Master text styles</a:t>
             </a:r>
+            <a:endParaRPr lang="en-US"/>
           </a:p>
         </p:txBody>
       </p:sp>
@@ -2367,7 +2440,6 @@
           <a:p>
             <a:fld id="{5BCAD085-E8A6-8845-BD4E-CB4CCA059FC4}" type="datetimeFigureOut">
               <a:rPr lang="en-US" smtClean="0"/>
-              <a:t>5/18/26</a:t>
             </a:fld>
             <a:endParaRPr lang="en-US"/>
           </a:p>
@@ -2409,7 +2481,6 @@
           <a:p>
             <a:fld id="{C1FF6DA9-008F-8B48-92A6-B652298478BF}" type="slidenum">
               <a:rPr lang="en-US" smtClean="0"/>
-              <a:t>‹#›</a:t>
             </a:fld>
             <a:endParaRPr lang="en-US"/>
           </a:p>
@@ -2459,6 +2530,7 @@
               <a:rPr lang="en-US"/>
               <a:t>Click to edit Master title style</a:t>
             </a:r>
+            <a:endParaRPr lang="en-US"/>
           </a:p>
         </p:txBody>
       </p:sp>
@@ -2515,6 +2587,7 @@
               <a:rPr lang="en-US"/>
               <a:t>Click to edit Master text styles</a:t>
             </a:r>
+            <a:endParaRPr lang="en-US"/>
           </a:p>
           <a:p>
             <a:pPr lvl="1"/>
@@ -2522,6 +2595,7 @@
               <a:rPr lang="en-US"/>
               <a:t>Second level</a:t>
             </a:r>
+            <a:endParaRPr lang="en-US"/>
           </a:p>
           <a:p>
             <a:pPr lvl="2"/>
@@ -2529,6 +2603,7 @@
               <a:rPr lang="en-US"/>
               <a:t>Third level</a:t>
             </a:r>
+            <a:endParaRPr lang="en-US"/>
           </a:p>
           <a:p>
             <a:pPr lvl="3"/>
@@ -2536,6 +2611,7 @@
               <a:rPr lang="en-US"/>
               <a:t>Fourth level</a:t>
             </a:r>
+            <a:endParaRPr lang="en-US"/>
           </a:p>
           <a:p>
             <a:pPr lvl="4"/>
@@ -2543,6 +2619,7 @@
               <a:rPr lang="en-US"/>
               <a:t>Fifth level</a:t>
             </a:r>
+            <a:endParaRPr lang="en-US"/>
           </a:p>
         </p:txBody>
       </p:sp>
@@ -2599,6 +2676,7 @@
               <a:rPr lang="en-US"/>
               <a:t>Click to edit Master text styles</a:t>
             </a:r>
+            <a:endParaRPr lang="en-US"/>
           </a:p>
           <a:p>
             <a:pPr lvl="1"/>
@@ -2606,6 +2684,7 @@
               <a:rPr lang="en-US"/>
               <a:t>Second level</a:t>
             </a:r>
+            <a:endParaRPr lang="en-US"/>
           </a:p>
           <a:p>
             <a:pPr lvl="2"/>
@@ -2613,6 +2692,7 @@
               <a:rPr lang="en-US"/>
               <a:t>Third level</a:t>
             </a:r>
+            <a:endParaRPr lang="en-US"/>
           </a:p>
           <a:p>
             <a:pPr lvl="3"/>
@@ -2620,6 +2700,7 @@
               <a:rPr lang="en-US"/>
               <a:t>Fourth level</a:t>
             </a:r>
+            <a:endParaRPr lang="en-US"/>
           </a:p>
           <a:p>
             <a:pPr lvl="4"/>
@@ -2627,6 +2708,7 @@
               <a:rPr lang="en-US"/>
               <a:t>Fifth level</a:t>
             </a:r>
+            <a:endParaRPr lang="en-US"/>
           </a:p>
         </p:txBody>
       </p:sp>
@@ -2647,7 +2729,6 @@
           <a:p>
             <a:fld id="{5BCAD085-E8A6-8845-BD4E-CB4CCA059FC4}" type="datetimeFigureOut">
               <a:rPr lang="en-US" smtClean="0"/>
-              <a:t>5/18/26</a:t>
             </a:fld>
             <a:endParaRPr lang="en-US"/>
           </a:p>
@@ -2689,7 +2770,6 @@
           <a:p>
             <a:fld id="{C1FF6DA9-008F-8B48-92A6-B652298478BF}" type="slidenum">
               <a:rPr lang="en-US" smtClean="0"/>
-              <a:t>‹#›</a:t>
             </a:fld>
             <a:endParaRPr lang="en-US"/>
           </a:p>
@@ -2743,6 +2823,7 @@
               <a:rPr lang="en-US"/>
               <a:t>Click to edit Master title style</a:t>
             </a:r>
+            <a:endParaRPr lang="en-US"/>
           </a:p>
         </p:txBody>
       </p:sp>
@@ -2808,6 +2889,7 @@
               <a:rPr lang="en-US"/>
               <a:t>Click to edit Master text styles</a:t>
             </a:r>
+            <a:endParaRPr lang="en-US"/>
           </a:p>
         </p:txBody>
       </p:sp>
@@ -2864,6 +2946,7 @@
               <a:rPr lang="en-US"/>
               <a:t>Click to edit Master text styles</a:t>
             </a:r>
+            <a:endParaRPr lang="en-US"/>
           </a:p>
           <a:p>
             <a:pPr lvl="1"/>
@@ -2871,6 +2954,7 @@
               <a:rPr lang="en-US"/>
               <a:t>Second level</a:t>
             </a:r>
+            <a:endParaRPr lang="en-US"/>
           </a:p>
           <a:p>
             <a:pPr lvl="2"/>
@@ -2878,6 +2962,7 @@
               <a:rPr lang="en-US"/>
               <a:t>Third level</a:t>
             </a:r>
+            <a:endParaRPr lang="en-US"/>
           </a:p>
           <a:p>
             <a:pPr lvl="3"/>
@@ -2885,6 +2970,7 @@
               <a:rPr lang="en-US"/>
               <a:t>Fourth level</a:t>
             </a:r>
+            <a:endParaRPr lang="en-US"/>
           </a:p>
           <a:p>
             <a:pPr lvl="4"/>
@@ -2892,6 +2978,7 @@
               <a:rPr lang="en-US"/>
               <a:t>Fifth level</a:t>
             </a:r>
+            <a:endParaRPr lang="en-US"/>
           </a:p>
         </p:txBody>
       </p:sp>
@@ -2957,6 +3044,7 @@
               <a:rPr lang="en-US"/>
               <a:t>Click to edit Master text styles</a:t>
             </a:r>
+            <a:endParaRPr lang="en-US"/>
           </a:p>
         </p:txBody>
       </p:sp>
@@ -3013,6 +3101,7 @@
               <a:rPr lang="en-US"/>
               <a:t>Click to edit Master text styles</a:t>
             </a:r>
+            <a:endParaRPr lang="en-US"/>
           </a:p>
           <a:p>
             <a:pPr lvl="1"/>
@@ -3020,6 +3109,7 @@
               <a:rPr lang="en-US"/>
               <a:t>Second level</a:t>
             </a:r>
+            <a:endParaRPr lang="en-US"/>
           </a:p>
           <a:p>
             <a:pPr lvl="2"/>
@@ -3027,6 +3117,7 @@
               <a:rPr lang="en-US"/>
               <a:t>Third level</a:t>
             </a:r>
+            <a:endParaRPr lang="en-US"/>
           </a:p>
           <a:p>
             <a:pPr lvl="3"/>
@@ -3034,6 +3125,7 @@
               <a:rPr lang="en-US"/>
               <a:t>Fourth level</a:t>
             </a:r>
+            <a:endParaRPr lang="en-US"/>
           </a:p>
           <a:p>
             <a:pPr lvl="4"/>
@@ -3041,6 +3133,7 @@
               <a:rPr lang="en-US"/>
               <a:t>Fifth level</a:t>
             </a:r>
+            <a:endParaRPr lang="en-US"/>
           </a:p>
         </p:txBody>
       </p:sp>
@@ -3061,7 +3154,6 @@
           <a:p>
             <a:fld id="{5BCAD085-E8A6-8845-BD4E-CB4CCA059FC4}" type="datetimeFigureOut">
               <a:rPr lang="en-US" smtClean="0"/>
-              <a:t>5/18/26</a:t>
             </a:fld>
             <a:endParaRPr lang="en-US"/>
           </a:p>
@@ -3103,7 +3195,6 @@
           <a:p>
             <a:fld id="{C1FF6DA9-008F-8B48-92A6-B652298478BF}" type="slidenum">
               <a:rPr lang="en-US" smtClean="0"/>
-              <a:t>‹#›</a:t>
             </a:fld>
             <a:endParaRPr lang="en-US"/>
           </a:p>
@@ -3153,6 +3244,7 @@
               <a:rPr lang="en-US"/>
               <a:t>Click to edit Master title style</a:t>
             </a:r>
+            <a:endParaRPr lang="en-US"/>
           </a:p>
         </p:txBody>
       </p:sp>
@@ -3173,7 +3265,6 @@
           <a:p>
             <a:fld id="{5BCAD085-E8A6-8845-BD4E-CB4CCA059FC4}" type="datetimeFigureOut">
               <a:rPr lang="en-US" smtClean="0"/>
-              <a:t>5/18/26</a:t>
             </a:fld>
             <a:endParaRPr lang="en-US"/>
           </a:p>
@@ -3215,7 +3306,6 @@
           <a:p>
             <a:fld id="{C1FF6DA9-008F-8B48-92A6-B652298478BF}" type="slidenum">
               <a:rPr lang="en-US" smtClean="0"/>
-              <a:t>‹#›</a:t>
             </a:fld>
             <a:endParaRPr lang="en-US"/>
           </a:p>
@@ -3263,7 +3353,6 @@
           <a:p>
             <a:fld id="{5BCAD085-E8A6-8845-BD4E-CB4CCA059FC4}" type="datetimeFigureOut">
               <a:rPr lang="en-US" smtClean="0"/>
-              <a:t>5/18/26</a:t>
             </a:fld>
             <a:endParaRPr lang="en-US"/>
           </a:p>
@@ -3305,7 +3394,6 @@
           <a:p>
             <a:fld id="{C1FF6DA9-008F-8B48-92A6-B652298478BF}" type="slidenum">
               <a:rPr lang="en-US" smtClean="0"/>
-              <a:t>‹#›</a:t>
             </a:fld>
             <a:endParaRPr lang="en-US"/>
           </a:p>
@@ -3364,6 +3452,7 @@
               <a:rPr lang="en-US"/>
               <a:t>Click to edit Master title style</a:t>
             </a:r>
+            <a:endParaRPr lang="en-US"/>
           </a:p>
         </p:txBody>
       </p:sp>
@@ -3420,6 +3509,7 @@
               <a:rPr lang="en-US"/>
               <a:t>Click to edit Master text styles</a:t>
             </a:r>
+            <a:endParaRPr lang="en-US"/>
           </a:p>
           <a:p>
             <a:pPr lvl="1"/>
@@ -3427,6 +3517,7 @@
               <a:rPr lang="en-US"/>
               <a:t>Second level</a:t>
             </a:r>
+            <a:endParaRPr lang="en-US"/>
           </a:p>
           <a:p>
             <a:pPr lvl="2"/>
@@ -3434,6 +3525,7 @@
               <a:rPr lang="en-US"/>
               <a:t>Third level</a:t>
             </a:r>
+            <a:endParaRPr lang="en-US"/>
           </a:p>
           <a:p>
             <a:pPr lvl="3"/>
@@ -3441,6 +3533,7 @@
               <a:rPr lang="en-US"/>
               <a:t>Fourth level</a:t>
             </a:r>
+            <a:endParaRPr lang="en-US"/>
           </a:p>
           <a:p>
             <a:pPr lvl="4"/>
@@ -3448,6 +3541,7 @@
               <a:rPr lang="en-US"/>
               <a:t>Fifth level</a:t>
             </a:r>
+            <a:endParaRPr lang="en-US"/>
           </a:p>
         </p:txBody>
       </p:sp>
@@ -3513,6 +3607,7 @@
               <a:rPr lang="en-US"/>
               <a:t>Click to edit Master text styles</a:t>
             </a:r>
+            <a:endParaRPr lang="en-US"/>
           </a:p>
         </p:txBody>
       </p:sp>
@@ -3533,7 +3628,6 @@
           <a:p>
             <a:fld id="{5BCAD085-E8A6-8845-BD4E-CB4CCA059FC4}" type="datetimeFigureOut">
               <a:rPr lang="en-US" smtClean="0"/>
-              <a:t>5/18/26</a:t>
             </a:fld>
             <a:endParaRPr lang="en-US"/>
           </a:p>
@@ -3575,7 +3669,6 @@
           <a:p>
             <a:fld id="{C1FF6DA9-008F-8B48-92A6-B652298478BF}" type="slidenum">
               <a:rPr lang="en-US" smtClean="0"/>
-              <a:t>‹#›</a:t>
             </a:fld>
             <a:endParaRPr lang="en-US"/>
           </a:p>
@@ -3634,6 +3727,7 @@
               <a:rPr lang="en-US"/>
               <a:t>Click to edit Master title style</a:t>
             </a:r>
+            <a:endParaRPr lang="en-US"/>
           </a:p>
         </p:txBody>
       </p:sp>
@@ -3760,6 +3854,7 @@
               <a:rPr lang="en-US"/>
               <a:t>Click to edit Master text styles</a:t>
             </a:r>
+            <a:endParaRPr lang="en-US"/>
           </a:p>
         </p:txBody>
       </p:sp>
@@ -3780,7 +3875,6 @@
           <a:p>
             <a:fld id="{5BCAD085-E8A6-8845-BD4E-CB4CCA059FC4}" type="datetimeFigureOut">
               <a:rPr lang="en-US" smtClean="0"/>
-              <a:t>5/18/26</a:t>
             </a:fld>
             <a:endParaRPr lang="en-US"/>
           </a:p>
@@ -3822,7 +3916,6 @@
           <a:p>
             <a:fld id="{C1FF6DA9-008F-8B48-92A6-B652298478BF}" type="slidenum">
               <a:rPr lang="en-US" smtClean="0"/>
-              <a:t>‹#›</a:t>
             </a:fld>
             <a:endParaRPr lang="en-US"/>
           </a:p>
@@ -3887,6 +3980,7 @@
               <a:rPr lang="en-US"/>
               <a:t>Click to edit Master title style</a:t>
             </a:r>
+            <a:endParaRPr lang="en-US"/>
           </a:p>
         </p:txBody>
       </p:sp>
@@ -3920,6 +4014,7 @@
               <a:rPr lang="en-US"/>
               <a:t>Click to edit Master text styles</a:t>
             </a:r>
+            <a:endParaRPr lang="en-US"/>
           </a:p>
           <a:p>
             <a:pPr lvl="1"/>
@@ -3927,6 +4022,7 @@
               <a:rPr lang="en-US"/>
               <a:t>Second level</a:t>
             </a:r>
+            <a:endParaRPr lang="en-US"/>
           </a:p>
           <a:p>
             <a:pPr lvl="2"/>
@@ -3934,6 +4030,7 @@
               <a:rPr lang="en-US"/>
               <a:t>Third level</a:t>
             </a:r>
+            <a:endParaRPr lang="en-US"/>
           </a:p>
           <a:p>
             <a:pPr lvl="3"/>
@@ -3941,6 +4038,7 @@
               <a:rPr lang="en-US"/>
               <a:t>Fourth level</a:t>
             </a:r>
+            <a:endParaRPr lang="en-US"/>
           </a:p>
           <a:p>
             <a:pPr lvl="4"/>
@@ -3948,6 +4046,7 @@
               <a:rPr lang="en-US"/>
               <a:t>Fifth level</a:t>
             </a:r>
+            <a:endParaRPr lang="en-US"/>
           </a:p>
         </p:txBody>
       </p:sp>
@@ -3986,7 +4085,6 @@
           <a:p>
             <a:fld id="{5BCAD085-E8A6-8845-BD4E-CB4CCA059FC4}" type="datetimeFigureOut">
               <a:rPr lang="en-US" smtClean="0"/>
-              <a:t>5/18/26</a:t>
             </a:fld>
             <a:endParaRPr lang="en-US"/>
           </a:p>
@@ -4064,7 +4162,6 @@
           <a:p>
             <a:fld id="{C1FF6DA9-008F-8B48-92A6-B652298478BF}" type="slidenum">
               <a:rPr lang="en-US" smtClean="0"/>
-              <a:t>‹#›</a:t>
             </a:fld>
             <a:endParaRPr lang="en-US"/>
           </a:p>
@@ -4366,27 +4463,21 @@
       </p:grpSpPr>
       <p:pic>
         <p:nvPicPr>
-          <p:cNvPr id="3" name="그림 2" descr="원, 그래픽, 스크린샷, 그래픽 디자인이(가) 표시된 사진&#10;&#10;자동 생성된 설명">
-            <a:extLst>
-              <a:ext uri="{FF2B5EF4-FFF2-40B4-BE49-F238E27FC236}">
-                <a16:creationId xmlns:a16="http://schemas.microsoft.com/office/drawing/2014/main" id="{317F8BEE-FF64-6ED3-A595-9445A8E78B6E}"/>
-              </a:ext>
-            </a:extLst>
-          </p:cNvPr>
+          <p:cNvPr id="3" name="그림 2" descr="원, 그래픽, 스크린샷, 그래픽 디자인이(가) 표시된 사진&#10;&#10;자동 생성된 설명"/>
           <p:cNvPicPr>
             <a:picLocks noChangeAspect="1"/>
           </p:cNvPicPr>
           <p:nvPr/>
         </p:nvPicPr>
         <p:blipFill>
-          <a:blip r:embed="rId3">
+          <a:blip r:embed="rId1">
             <a:lum bright="70000" contrast="-70000"/>
             <a:extLst>
               <a:ext uri="{BEBA8EAE-BF5A-486C-A8C5-ECC9F3942E4B}">
                 <a14:imgProps xmlns:a14="http://schemas.microsoft.com/office/drawing/2010/main">
-                  <a14:imgLayer r:embed="rId4">
+                  <a14:imgLayer r:embed="rId2">
                     <a14:imgEffect>
-                      <a14:artisticPhotocopy detail="2"/>
+                      <a14:artisticPhotocopy trans="30000" detail="2"/>
                     </a14:imgEffect>
                   </a14:imgLayer>
                 </a14:imgProps>
@@ -4466,6 +4557,13 @@
               </a:rPr>
               <a:t>STABLECOINS AND THE EXORBITANT PRIVILEGE</a:t>
             </a:r>
+            <a:endParaRPr lang="en-US" altLang="ko-KR" sz="2400" dirty="0">
+              <a:solidFill>
+                <a:prstClr val="white"/>
+              </a:solidFill>
+              <a:latin typeface="Hiragino Kaku Gothic Std W8" panose="020B0800000000000000" pitchFamily="34" charset="-128"/>
+              <a:ea typeface="Hiragino Kaku Gothic Std W8" panose="020B0800000000000000" pitchFamily="34" charset="-128"/>
+            </a:endParaRPr>
           </a:p>
           <a:p>
             <a:pPr algn="ctr" defTabSz="914400" latinLnBrk="1">
@@ -4489,8 +4587,8 @@
         </p:nvSpPr>
         <p:spPr>
           <a:xfrm>
-            <a:off x="6466205" y="5560060"/>
-            <a:ext cx="5470525" cy="1198880"/>
+            <a:off x="6094095" y="5560060"/>
+            <a:ext cx="5842635" cy="1198880"/>
           </a:xfrm>
           <a:prstGeom prst="rect">
             <a:avLst/>
@@ -4511,6 +4609,11 @@
               </a:rPr>
               <a:t>Yonsei GSIS 2026-1 </a:t>
             </a:r>
+            <a:endParaRPr lang="en-US" altLang="ko-KR" sz="1800" b="1" dirty="0">
+              <a:solidFill>
+                <a:schemeClr val="bg1"/>
+              </a:solidFill>
+            </a:endParaRPr>
           </a:p>
           <a:p>
             <a:r>
@@ -4624,7 +4727,6 @@
           <a:lstStyle/>
           <a:p>
             <a:pPr algn="ctr"/>
-            <a:endParaRPr/>
           </a:p>
         </p:txBody>
       </p:sp>
@@ -4668,7 +4770,6 @@
           <a:lstStyle/>
           <a:p>
             <a:pPr algn="ctr"/>
-            <a:endParaRPr/>
           </a:p>
         </p:txBody>
       </p:sp>
@@ -4702,6 +4803,11 @@
               </a:rPr>
               <a:t>Roadmap</a:t>
             </a:r>
+            <a:endParaRPr sz="2600" b="0">
+              <a:solidFill>
+                <a:srgbClr val="FFFFFF"/>
+              </a:solidFill>
+            </a:endParaRPr>
           </a:p>
         </p:txBody>
       </p:sp>
@@ -4714,7 +4820,7 @@
         <p:spPr>
           <a:xfrm>
             <a:off x="9800000" y="207010"/>
-            <a:ext cx="2200000" cy="246221"/>
+            <a:ext cx="2200000" cy="245110"/>
           </a:xfrm>
           <a:prstGeom prst="rect">
             <a:avLst/>
@@ -4729,13 +4835,26 @@
           <a:p>
             <a:pPr algn="r"/>
             <a:r>
+              <a:rPr lang="en-US" sz="1000" b="0" dirty="0">
+                <a:solidFill>
+                  <a:schemeClr val="bg1"/>
+                </a:solidFill>
+              </a:rPr>
+              <a:t>Sara </a:t>
+            </a:r>
+            <a:r>
               <a:rPr sz="1000" b="0" dirty="0">
                 <a:solidFill>
                   <a:schemeClr val="bg1"/>
                 </a:solidFill>
               </a:rPr>
-              <a:t>Alexandre  Page 2</a:t>
-            </a:r>
+              <a:t>Page 2</a:t>
+            </a:r>
+            <a:endParaRPr sz="1000" b="0" dirty="0">
+              <a:solidFill>
+                <a:schemeClr val="bg1"/>
+              </a:solidFill>
+            </a:endParaRPr>
           </a:p>
         </p:txBody>
       </p:sp>
@@ -4786,6 +4905,11 @@
               </a:rPr>
               <a:t>:</a:t>
             </a:r>
+            <a:endParaRPr sz="2400" b="1" dirty="0">
+              <a:solidFill>
+                <a:srgbClr val="8A9ABB"/>
+              </a:solidFill>
+            </a:endParaRPr>
           </a:p>
           <a:p>
             <a:r>
@@ -4796,58 +4920,6 @@
               </a:rPr>
               <a:t>❖  Motivation — why stablecoins matter for sovereign debt</a:t>
             </a:r>
-          </a:p>
-          <a:p>
-            <a:r>
-              <a:rPr sz="2400" b="0" dirty="0">
-                <a:solidFill>
-                  <a:srgbClr val="8A9ABB"/>
-                </a:solidFill>
-              </a:rPr>
-              <a:t>❖  The New Triffin Dilemma — our core argument</a:t>
-            </a:r>
-          </a:p>
-          <a:p>
-            <a:r>
-              <a:rPr sz="2400" b="0" dirty="0">
-                <a:solidFill>
-                  <a:srgbClr val="8A9ABB"/>
-                </a:solidFill>
-              </a:rPr>
-              <a:t>❖  Theoretical extension of Maggiori (2017)</a:t>
-            </a:r>
-          </a:p>
-          <a:p>
-            <a:r>
-              <a:rPr sz="2400" b="0" dirty="0">
-                <a:solidFill>
-                  <a:srgbClr val="8A9ABB"/>
-                </a:solidFill>
-              </a:rPr>
-              <a:t>❖  Data &amp; Methodology</a:t>
-            </a:r>
-          </a:p>
-          <a:p>
-            <a:r>
-              <a:rPr sz="2400" b="0" dirty="0">
-                <a:solidFill>
-                  <a:srgbClr val="8A9ABB"/>
-                </a:solidFill>
-              </a:rPr>
-              <a:t>❖  Result 1 — Privilege amplification regression</a:t>
-            </a:r>
-          </a:p>
-          <a:p>
-            <a:r>
-              <a:rPr sz="2400" b="0" dirty="0">
-                <a:solidFill>
-                  <a:srgbClr val="8A9ABB"/>
-                </a:solidFill>
-              </a:rPr>
-              <a:t>❖  Result 2 — Reserve adequacy threshold (Hansen 2000)</a:t>
-            </a:r>
-          </a:p>
-          <a:p>
             <a:endParaRPr sz="2400" b="0" dirty="0">
               <a:solidFill>
                 <a:srgbClr val="8A9ABB"/>
@@ -4856,6 +4928,88 @@
           </a:p>
           <a:p>
             <a:r>
+              <a:rPr sz="2400" b="0" dirty="0">
+                <a:solidFill>
+                  <a:srgbClr val="8A9ABB"/>
+                </a:solidFill>
+              </a:rPr>
+              <a:t>❖  The New Triffin Dilemma — our core argument</a:t>
+            </a:r>
+            <a:endParaRPr sz="2400" b="0" dirty="0">
+              <a:solidFill>
+                <a:srgbClr val="8A9ABB"/>
+              </a:solidFill>
+            </a:endParaRPr>
+          </a:p>
+          <a:p>
+            <a:r>
+              <a:rPr sz="2400" b="0" dirty="0">
+                <a:solidFill>
+                  <a:srgbClr val="8A9ABB"/>
+                </a:solidFill>
+              </a:rPr>
+              <a:t>❖  Theoretical extension of Maggiori (2017)</a:t>
+            </a:r>
+            <a:endParaRPr sz="2400" b="0" dirty="0">
+              <a:solidFill>
+                <a:srgbClr val="8A9ABB"/>
+              </a:solidFill>
+            </a:endParaRPr>
+          </a:p>
+          <a:p>
+            <a:r>
+              <a:rPr sz="2400" b="0" dirty="0">
+                <a:solidFill>
+                  <a:srgbClr val="8A9ABB"/>
+                </a:solidFill>
+              </a:rPr>
+              <a:t>❖  Data &amp; Methodology</a:t>
+            </a:r>
+            <a:endParaRPr sz="2400" b="0" dirty="0">
+              <a:solidFill>
+                <a:srgbClr val="8A9ABB"/>
+              </a:solidFill>
+            </a:endParaRPr>
+          </a:p>
+          <a:p>
+            <a:r>
+              <a:rPr sz="2400" b="0" dirty="0">
+                <a:solidFill>
+                  <a:srgbClr val="8A9ABB"/>
+                </a:solidFill>
+              </a:rPr>
+              <a:t>❖  Result 1 — Privilege amplification regression</a:t>
+            </a:r>
+            <a:endParaRPr sz="2400" b="0" dirty="0">
+              <a:solidFill>
+                <a:srgbClr val="8A9ABB"/>
+              </a:solidFill>
+            </a:endParaRPr>
+          </a:p>
+          <a:p>
+            <a:r>
+              <a:rPr sz="2400" b="0" dirty="0">
+                <a:solidFill>
+                  <a:srgbClr val="8A9ABB"/>
+                </a:solidFill>
+              </a:rPr>
+              <a:t>❖  Result 2 — Reserve adequacy threshold (Hansen 2000)</a:t>
+            </a:r>
+            <a:endParaRPr sz="2400" b="0" dirty="0">
+              <a:solidFill>
+                <a:srgbClr val="8A9ABB"/>
+              </a:solidFill>
+            </a:endParaRPr>
+          </a:p>
+          <a:p>
+            <a:endParaRPr sz="2400" b="0" dirty="0">
+              <a:solidFill>
+                <a:srgbClr val="8A9ABB"/>
+              </a:solidFill>
+            </a:endParaRPr>
+          </a:p>
+          <a:p>
+            <a:r>
               <a:rPr sz="2800" b="1" dirty="0">
                 <a:solidFill>
                   <a:srgbClr val="1A1A2E"/>
@@ -4879,6 +5033,11 @@
               </a:rPr>
               <a:t>:</a:t>
             </a:r>
+            <a:endParaRPr sz="2800" b="1" dirty="0">
+              <a:solidFill>
+                <a:srgbClr val="1A1A2E"/>
+              </a:solidFill>
+            </a:endParaRPr>
           </a:p>
           <a:p>
             <a:r>
@@ -4889,6 +5048,11 @@
               </a:rPr>
               <a:t>❖  Literature Gap — placing our contribution</a:t>
             </a:r>
+            <a:endParaRPr sz="2800" b="0" dirty="0">
+              <a:solidFill>
+                <a:srgbClr val="1A1A2E"/>
+              </a:solidFill>
+            </a:endParaRPr>
           </a:p>
           <a:p>
             <a:r>
@@ -4899,6 +5063,11 @@
               </a:rPr>
               <a:t>❖  Result 3 — Buffer-conditioned event study (causal evidence)</a:t>
             </a:r>
+            <a:endParaRPr sz="2800" b="0" dirty="0">
+              <a:solidFill>
+                <a:srgbClr val="1A1A2E"/>
+              </a:solidFill>
+            </a:endParaRPr>
           </a:p>
           <a:p>
             <a:r>
@@ -4909,6 +5078,11 @@
               </a:rPr>
               <a:t>❖  Asymmetric Effects — Growth vs. Contraction periods (new)</a:t>
             </a:r>
+            <a:endParaRPr sz="2800" b="0" dirty="0">
+              <a:solidFill>
+                <a:srgbClr val="1A1A2E"/>
+              </a:solidFill>
+            </a:endParaRPr>
           </a:p>
           <a:p>
             <a:r>
@@ -4919,6 +5093,11 @@
               </a:rPr>
               <a:t>❖  Policy Implication — 13% threshold reframed</a:t>
             </a:r>
+            <a:endParaRPr sz="2800" b="0" dirty="0">
+              <a:solidFill>
+                <a:srgbClr val="1A1A2E"/>
+              </a:solidFill>
+            </a:endParaRPr>
           </a:p>
           <a:p>
             <a:r>
@@ -4929,6 +5108,11 @@
               </a:rPr>
               <a:t>❖  Conclusion</a:t>
             </a:r>
+            <a:endParaRPr sz="2800" b="0" dirty="0">
+              <a:solidFill>
+                <a:srgbClr val="1A1A2E"/>
+              </a:solidFill>
+            </a:endParaRPr>
           </a:p>
         </p:txBody>
       </p:sp>
@@ -4997,7 +5181,6 @@
           <a:lstStyle/>
           <a:p>
             <a:pPr algn="ctr"/>
-            <a:endParaRPr/>
           </a:p>
         </p:txBody>
       </p:sp>
@@ -5031,6 +5214,11 @@
               </a:rPr>
               <a:t>What The Literature Has Established — And Where It Stops</a:t>
             </a:r>
+            <a:endParaRPr lang="en-US" altLang="en-US" sz="2600" b="0">
+              <a:solidFill>
+                <a:srgbClr val="FFFFFF"/>
+              </a:solidFill>
+            </a:endParaRPr>
           </a:p>
         </p:txBody>
       </p:sp>
@@ -5058,12 +5246,13 @@
           <a:p>
             <a:pPr algn="r"/>
             <a:r>
-              <a:rPr lang="en-US" sz="1000" b="0" dirty="0">
+              <a:rPr sz="1000" dirty="0">
                 <a:solidFill>
                   <a:schemeClr val="bg1"/>
                 </a:solidFill>
-              </a:rPr>
-              <a:t>Oybek </a:t>
+                <a:sym typeface="+mn-ea"/>
+              </a:rPr>
+              <a:t>Alexandre  </a:t>
             </a:r>
             <a:r>
               <a:rPr sz="1000" b="0" dirty="0">
@@ -5073,6 +5262,11 @@
               </a:rPr>
               <a:t>Page 3</a:t>
             </a:r>
+            <a:endParaRPr sz="1000" b="0" dirty="0">
+              <a:solidFill>
+                <a:schemeClr val="bg1"/>
+              </a:solidFill>
+            </a:endParaRPr>
           </a:p>
         </p:txBody>
       </p:sp>
@@ -5084,7 +5278,7 @@
         </p:nvSpPr>
         <p:spPr>
           <a:xfrm>
-            <a:off x="261620" y="4179570"/>
+            <a:off x="261620" y="3975100"/>
             <a:ext cx="11127740" cy="1356995"/>
           </a:xfrm>
           <a:prstGeom prst="rect">
@@ -5154,6 +5348,11 @@
               </a:rPr>
               <a:t>Stablecoin inflows lower 3-month T-bill yields 2–2.5 basis points. Outflows raise yields 2–3x more. Effect is state-dependent on T-bill market supply.</a:t>
             </a:r>
+            <a:endParaRPr lang="en-US" altLang="en-US" sz="1600" b="0">
+              <a:solidFill>
+                <a:srgbClr val="1A7A4A"/>
+              </a:solidFill>
+            </a:endParaRPr>
           </a:p>
           <a:p>
             <a:pPr>
@@ -5178,6 +5377,11 @@
               </a:rPr>
               <a:t>Moderating variable is market-level T-bill supply — not issuer reserve composition. Uses yield levels, not OIS-Treasury spread. No reserve adequacy threshold identified.</a:t>
             </a:r>
+            <a:endParaRPr lang="en-US" altLang="en-US" sz="1600" b="0">
+              <a:solidFill>
+                <a:srgbClr val="C0392B"/>
+              </a:solidFill>
+            </a:endParaRPr>
           </a:p>
         </p:txBody>
       </p:sp>
@@ -5221,7 +5425,6 @@
           <a:lstStyle/>
           <a:p>
             <a:pPr algn="ctr"/>
-            <a:endParaRPr/>
           </a:p>
         </p:txBody>
       </p:sp>
@@ -5256,6 +5459,11 @@
               </a:rPr>
               <a:t>Existing Literature</a:t>
             </a:r>
+            <a:endParaRPr sz="1400" b="1">
+              <a:solidFill>
+                <a:srgbClr val="FFFFFF"/>
+              </a:solidFill>
+            </a:endParaRPr>
           </a:p>
         </p:txBody>
       </p:sp>
@@ -5303,6 +5511,7 @@
               <a:rPr lang="en-US" altLang="en-US"/>
               <a:t>Each paper answers one question and leaves the next one open. None jointly estimates how issuer reserve composition moderates the transmission from stablecoin activity to sovereign debt markets.</a:t>
             </a:r>
+            <a:endParaRPr lang="en-US" altLang="en-US"/>
           </a:p>
         </p:txBody>
       </p:sp>
@@ -5314,7 +5523,7 @@
         </p:nvSpPr>
         <p:spPr>
           <a:xfrm>
-            <a:off x="273685" y="2643505"/>
+            <a:off x="273685" y="2554605"/>
             <a:ext cx="11127740" cy="1290955"/>
           </a:xfrm>
           <a:prstGeom prst="rect">
@@ -5415,6 +5624,12 @@
               </a:rPr>
               <a:t>Identifies the run risk. Does not model how runs transmit to sovereign debt markets. No Treasury spread analysis. No threshold estimation.</a:t>
             </a:r>
+            <a:endParaRPr lang="en-US" altLang="en-US" sz="1600" b="0">
+              <a:solidFill>
+                <a:srgbClr val="C0392B"/>
+              </a:solidFill>
+              <a:sym typeface="+mn-ea"/>
+            </a:endParaRPr>
           </a:p>
         </p:txBody>
       </p:sp>
@@ -5426,8 +5641,8 @@
         </p:nvSpPr>
         <p:spPr>
           <a:xfrm>
-            <a:off x="273685" y="1300480"/>
-            <a:ext cx="11115675" cy="1250950"/>
+            <a:off x="273685" y="1317625"/>
+            <a:ext cx="11115675" cy="1109345"/>
           </a:xfrm>
           <a:prstGeom prst="rect">
             <a:avLst/>
@@ -5496,6 +5711,11 @@
               </a:rPr>
               <a:t>Arbitrage mechanisms keep dollar-backed stablecoins pegged. Under-collateralised issuers face speculative attacks and devaluation risk.</a:t>
             </a:r>
+            <a:endParaRPr lang="en-US" altLang="en-US" sz="1600" b="0">
+              <a:solidFill>
+                <a:srgbClr val="1A7A4A"/>
+              </a:solidFill>
+            </a:endParaRPr>
           </a:p>
           <a:p>
             <a:pPr>
@@ -5521,6 +5741,64 @@
               </a:rPr>
               <a:t>Internal peg mechanics only. No connection to Treasury market outcomes. No reserve adequacy variable.</a:t>
             </a:r>
+            <a:endParaRPr lang="en-US" altLang="en-US" sz="1600" b="0">
+              <a:solidFill>
+                <a:srgbClr val="C0392B"/>
+              </a:solidFill>
+              <a:sym typeface="+mn-ea"/>
+            </a:endParaRPr>
+          </a:p>
+        </p:txBody>
+      </p:sp>
+      <p:sp>
+        <p:nvSpPr>
+          <p:cNvPr id="9" name="TextBox 5"/>
+          <p:cNvSpPr txBox="1"/>
+          <p:nvPr/>
+        </p:nvSpPr>
+        <p:spPr>
+          <a:xfrm>
+            <a:off x="337185" y="5447550"/>
+            <a:ext cx="11430000" cy="291465"/>
+          </a:xfrm>
+          <a:prstGeom prst="rect">
+            <a:avLst/>
+          </a:prstGeom>
+          <a:noFill/>
+        </p:spPr>
+        <p:txBody>
+          <a:bodyPr wrap="square">
+            <a:spAutoFit/>
+          </a:bodyPr>
+          <a:lstStyle/>
+          <a:p>
+            <a:r>
+              <a:rPr lang="en-US" sz="1300">
+                <a:sym typeface="+mn-ea"/>
+              </a:rPr>
+              <a:t>*</a:t>
+            </a:r>
+            <a:r>
+              <a:rPr sz="1300">
+                <a:sym typeface="+mn-ea"/>
+              </a:rPr>
+              <a:t>Building on: Maggiori (2017), Jeanne &amp; Rancière (2011), Cole &amp; Kehoe (2000)</a:t>
+            </a:r>
+            <a:r>
+              <a:rPr lang="en-US" altLang="en-US" sz="1300" b="0" dirty="0">
+                <a:solidFill>
+                  <a:srgbClr val="555566"/>
+                </a:solidFill>
+                <a:sym typeface="+mn-ea"/>
+              </a:rPr>
+              <a:t> — theoretical foundations established in prior presentation.</a:t>
+            </a:r>
+            <a:endParaRPr lang="en-US" altLang="en-US" sz="1300" b="0" dirty="0">
+              <a:solidFill>
+                <a:srgbClr val="555566"/>
+              </a:solidFill>
+              <a:sym typeface="+mn-ea"/>
+            </a:endParaRPr>
           </a:p>
         </p:txBody>
       </p:sp>
@@ -5558,7 +5836,7 @@
         <p:spPr>
           <a:xfrm>
             <a:off x="0" y="0"/>
-            <a:ext cx="12188952" cy="868680"/>
+            <a:ext cx="12188825" cy="699770"/>
           </a:xfrm>
           <a:prstGeom prst="rect">
             <a:avLst/>
@@ -5589,7 +5867,6 @@
           <a:lstStyle/>
           <a:p>
             <a:pPr algn="ctr"/>
-            <a:endParaRPr/>
           </a:p>
         </p:txBody>
       </p:sp>
@@ -5623,6 +5900,11 @@
               </a:rPr>
               <a:t>What Our Paper Does That No Paper Has Done</a:t>
             </a:r>
+            <a:endParaRPr lang="en-US" altLang="en-US" sz="2600" b="0">
+              <a:solidFill>
+                <a:srgbClr val="FFFFFF"/>
+              </a:solidFill>
+            </a:endParaRPr>
           </a:p>
         </p:txBody>
       </p:sp>
@@ -5650,12 +5932,13 @@
           <a:p>
             <a:pPr algn="r"/>
             <a:r>
-              <a:rPr lang="en-US" sz="1000" b="0" dirty="0">
+              <a:rPr sz="1000" dirty="0">
                 <a:solidFill>
                   <a:schemeClr val="bg1"/>
                 </a:solidFill>
-              </a:rPr>
-              <a:t>Oybek </a:t>
+                <a:sym typeface="+mn-ea"/>
+              </a:rPr>
+              <a:t>Alexandre  </a:t>
             </a:r>
             <a:r>
               <a:rPr sz="1000" b="0" dirty="0">
@@ -5689,8 +5972,8 @@
         </p:nvSpPr>
         <p:spPr>
           <a:xfrm>
-            <a:off x="127635" y="1489710"/>
-            <a:ext cx="5600700" cy="1545590"/>
+            <a:off x="273685" y="1452245"/>
+            <a:ext cx="5600700" cy="1683385"/>
           </a:xfrm>
           <a:prstGeom prst="rect">
             <a:avLst/>
@@ -5722,7 +6005,7 @@
           <a:p>
             <a:pPr algn="ctr"/>
             <a:r>
-              <a:rPr lang="en-US" altLang="en-US" sz="1400">
+              <a:rPr lang="en-US" altLang="en-US" sz="1600">
                 <a:solidFill>
                   <a:schemeClr val="tx1"/>
                 </a:solidFill>
@@ -5730,7 +6013,7 @@
               </a:rPr>
               <a:t>"No existing study jointly estimates how issuer reserve adequacy moderates the transmission from stablecoin supply growth to OIS-Treasury spreads — or identifies the threshold below which this transmission becomes a sovereign liquidity shock."</a:t>
             </a:r>
-            <a:endParaRPr lang="en-US" altLang="en-US" sz="1400" b="0">
+            <a:endParaRPr lang="en-US" altLang="en-US" sz="1600" b="0">
               <a:solidFill>
                 <a:schemeClr val="tx1"/>
               </a:solidFill>
@@ -5788,9 +6071,17 @@
           <a:p>
             <a:pPr algn="ctr"/>
             <a:r>
+              <a:rPr lang="en-US" altLang="en-US" sz="1700" b="1"/>
+              <a:t>1. Dependent variable:</a:t>
+            </a:r>
+            <a:br>
+              <a:rPr lang="en-US" altLang="en-US" sz="1700" b="1"/>
+            </a:br>
+            <a:r>
               <a:rPr lang="en-US" altLang="en-US" sz="1700"/>
-              <a:t>1. Dependent variable: OIS–Treasury spread — not yield levels. Measures the privilege directly.</a:t>
-            </a:r>
+              <a:t>OIS–Treasury spread — not yield levels. Measures the privilege directly.</a:t>
+            </a:r>
+            <a:endParaRPr lang="en-US" altLang="en-US" sz="1700"/>
           </a:p>
         </p:txBody>
       </p:sp>
@@ -5802,7 +6093,7 @@
         </p:nvSpPr>
         <p:spPr>
           <a:xfrm>
-            <a:off x="0" y="5596128"/>
+            <a:off x="0" y="5787263"/>
             <a:ext cx="12188952" cy="1097280"/>
           </a:xfrm>
           <a:prstGeom prst="rect">
@@ -5908,9 +6199,17 @@
           <a:p>
             <a:pPr algn="ctr"/>
             <a:r>
+              <a:rPr lang="en-US" altLang="en-US" sz="1700" b="1"/>
+              <a:t>2. Moderating variable:</a:t>
+            </a:r>
+            <a:br>
+              <a:rPr lang="en-US" altLang="en-US" sz="1700" b="1"/>
+            </a:br>
+            <a:r>
               <a:rPr lang="en-US" altLang="en-US" sz="1700"/>
-              <a:t>2. Moderating variable: Issuer liquid buffer L — not market supply. Policy-actionable.</a:t>
-            </a:r>
+              <a:t>Issuer liquid buffer L — not market supply. Policy-actionable.</a:t>
+            </a:r>
+            <a:endParaRPr lang="en-US" altLang="en-US" sz="1700"/>
           </a:p>
         </p:txBody>
       </p:sp>
@@ -5961,11 +6260,19 @@
           <a:bodyPr rtlCol="0" anchor="ctr"/>
           <a:lstStyle/>
           <a:p>
-            <a:pPr algn="just"/>
+            <a:pPr algn="ctr"/>
+            <a:r>
+              <a:rPr lang="en-US" altLang="en-US" sz="1700" b="1"/>
+              <a:t>3. Interaction term β₄:</a:t>
+            </a:r>
+            <a:br>
+              <a:rPr lang="en-US" altLang="en-US" sz="1700" b="1"/>
+            </a:br>
             <a:r>
               <a:rPr lang="en-US" altLang="en-US" sz="1700"/>
-              <a:t>3. Interaction term β₄: How L moderates stablecoin issuance effect on spreads. No antecedent.</a:t>
-            </a:r>
+              <a:t> How L moderates stablecoin issuance effect on spreads. No antecedent.</a:t>
+            </a:r>
+            <a:endParaRPr lang="en-US" altLang="en-US" sz="1700"/>
           </a:p>
         </p:txBody>
       </p:sp>
@@ -6016,11 +6323,19 @@
           <a:bodyPr rtlCol="0" anchor="ctr"/>
           <a:lstStyle/>
           <a:p>
-            <a:pPr algn="l"/>
+            <a:pPr algn="ctr"/>
+            <a:r>
+              <a:rPr lang="en-US" altLang="en-US" sz="1700" b="1"/>
+              <a:t>4. Threshold L = 13%: </a:t>
+            </a:r>
+            <a:br>
+              <a:rPr lang="en-US" altLang="en-US" sz="1700" b="1"/>
+            </a:br>
             <a:r>
               <a:rPr lang="en-US" altLang="en-US" sz="1700"/>
-              <a:t>4. Threshold L = 13%:* Hansen (2000) structural break separating two distinct regimes.First empirical estimate of this kind.</a:t>
-            </a:r>
+              <a:t>Hansen (2000) structural break separating two distinct regimes.First empirical estimate of this kind.</a:t>
+            </a:r>
+            <a:endParaRPr lang="en-US" altLang="en-US" sz="1700"/>
           </a:p>
         </p:txBody>
       </p:sp>
@@ -6073,9 +6388,18 @@
           <a:p>
             <a:pPr algn="ctr"/>
             <a:r>
+              <a:rPr lang="en-US" altLang="en-US" sz="1700" b="1"/>
+              <a:t>5. Asymmetric effects: </a:t>
+            </a:r>
+            <a:endParaRPr lang="en-US" altLang="en-US" sz="1700" b="1"/>
+          </a:p>
+          <a:p>
+            <a:pPr algn="ctr"/>
+            <a:r>
               <a:rPr lang="en-US" altLang="en-US" sz="1700"/>
-              <a:t>5. Asymmetric effects: Growth vs. contraction periods separated. Consistent with Ahmed &amp; Aldasoro's own asymmetry finding.</a:t>
-            </a:r>
+              <a:t>Growth vs. contraction periods separated. Consistent with Ahmed &amp; Aldasoro's own asymmetry finding.</a:t>
+            </a:r>
+            <a:endParaRPr lang="en-US" altLang="en-US" sz="1700"/>
           </a:p>
         </p:txBody>
       </p:sp>
@@ -6087,8 +6411,8 @@
         </p:nvSpPr>
         <p:spPr>
           <a:xfrm>
-            <a:off x="127635" y="4201160"/>
-            <a:ext cx="5600065" cy="1126490"/>
+            <a:off x="274320" y="3617595"/>
+            <a:ext cx="5600065" cy="1719580"/>
           </a:xfrm>
           <a:prstGeom prst="rect">
             <a:avLst/>
@@ -6120,15 +6444,33 @@
           <a:p>
             <a:pPr algn="ctr"/>
             <a:r>
-              <a:rPr lang="en-US" altLang="en-US" sz="1200">
+              <a:rPr lang="en-US" altLang="en-US" sz="1600">
                 <a:solidFill>
                   <a:schemeClr val="tx1"/>
                 </a:solidFill>
                 <a:sym typeface="+mn-ea"/>
               </a:rPr>
-              <a:t>We fill this gap by combining three strands no paper has combined simultaneously:</a:t>
-            </a:r>
-            <a:endParaRPr lang="en-US" altLang="en-US" sz="1200" b="0">
+              <a:t>We fill this gap by combining </a:t>
+            </a:r>
+            <a:r>
+              <a:rPr lang="en-US" altLang="en-US" sz="1600" b="1">
+                <a:solidFill>
+                  <a:schemeClr val="tx1"/>
+                </a:solidFill>
+                <a:sym typeface="+mn-ea"/>
+              </a:rPr>
+              <a:t>three </a:t>
+            </a:r>
+            <a:r>
+              <a:rPr lang="en-US" altLang="en-US" sz="1600">
+                <a:solidFill>
+                  <a:schemeClr val="tx1"/>
+                </a:solidFill>
+                <a:sym typeface="+mn-ea"/>
+              </a:rPr>
+              <a:t>strands no paper has combined simultaneously:</a:t>
+            </a:r>
+            <a:endParaRPr lang="en-US" altLang="en-US" sz="1600" b="0">
               <a:solidFill>
                 <a:schemeClr val="tx1"/>
               </a:solidFill>
@@ -6136,7 +6478,7 @@
           </a:p>
           <a:p>
             <a:pPr algn="ctr"/>
-            <a:endParaRPr lang="en-US" altLang="en-US" sz="1200" b="0">
+            <a:endParaRPr lang="en-US" altLang="en-US" sz="1600" b="0">
               <a:solidFill>
                 <a:schemeClr val="tx1"/>
               </a:solidFill>
@@ -6145,7 +6487,7 @@
           <a:p>
             <a:pPr algn="ctr"/>
             <a:r>
-              <a:rPr lang="en-US" altLang="en-US" sz="1200">
+              <a:rPr lang="en-US" altLang="en-US" sz="1600">
                 <a:solidFill>
                   <a:schemeClr val="tx1"/>
                 </a:solidFill>
@@ -6153,7 +6495,7 @@
               </a:rPr>
               <a:t>Exorbitant privilege framework (Maggiori 2017)</a:t>
             </a:r>
-            <a:endParaRPr lang="en-US" altLang="en-US" sz="1200" b="0">
+            <a:endParaRPr lang="en-US" altLang="en-US" sz="1600" b="0">
               <a:solidFill>
                 <a:schemeClr val="tx1"/>
               </a:solidFill>
@@ -6162,7 +6504,7 @@
           <a:p>
             <a:pPr algn="ctr"/>
             <a:r>
-              <a:rPr lang="en-US" altLang="en-US" sz="1200">
+              <a:rPr lang="en-US" altLang="en-US" sz="1600">
                 <a:solidFill>
                   <a:schemeClr val="tx1"/>
                 </a:solidFill>
@@ -6170,7 +6512,7 @@
               </a:rPr>
               <a:t>Stablecoin run risk (Gorton &amp; Zhang 2023)</a:t>
             </a:r>
-            <a:endParaRPr lang="en-US" altLang="en-US" sz="1200" b="0">
+            <a:endParaRPr lang="en-US" altLang="en-US" sz="1600" b="0">
               <a:solidFill>
                 <a:schemeClr val="tx1"/>
               </a:solidFill>
@@ -6179,7 +6521,7 @@
           <a:p>
             <a:pPr algn="ctr"/>
             <a:r>
-              <a:rPr lang="en-US" altLang="en-US" sz="1200">
+              <a:rPr lang="en-US" altLang="en-US" sz="1600">
                 <a:solidFill>
                   <a:schemeClr val="tx1"/>
                 </a:solidFill>
@@ -6187,6 +6529,12 @@
               </a:rPr>
               <a:t>Reserve adequacy methodology (Jeanne &amp; Rancière 2011)</a:t>
             </a:r>
+            <a:endParaRPr lang="en-US" altLang="en-US" sz="1600">
+              <a:solidFill>
+                <a:schemeClr val="tx1"/>
+              </a:solidFill>
+              <a:sym typeface="+mn-ea"/>
+            </a:endParaRPr>
           </a:p>
         </p:txBody>
       </p:sp>
@@ -6255,7 +6603,6 @@
           <a:lstStyle/>
           <a:p>
             <a:pPr algn="ctr"/>
-            <a:endParaRPr/>
           </a:p>
         </p:txBody>
       </p:sp>
@@ -6299,7 +6646,6 @@
           <a:lstStyle/>
           <a:p>
             <a:pPr algn="ctr"/>
-            <a:endParaRPr/>
           </a:p>
         </p:txBody>
       </p:sp>
@@ -6333,6 +6679,11 @@
               </a:rPr>
               <a:t>Result 3: Buffer-Conditioned Event Study</a:t>
             </a:r>
+            <a:endParaRPr sz="2600" b="0">
+              <a:solidFill>
+                <a:srgbClr val="FFFFFF"/>
+              </a:solidFill>
+            </a:endParaRPr>
           </a:p>
         </p:txBody>
       </p:sp>
@@ -6392,7 +6743,7 @@
           <p:nvPr/>
         </p:nvPicPr>
         <p:blipFill>
-          <a:blip r:embed="rId3"/>
+          <a:blip r:embed="rId1"/>
           <a:stretch>
             <a:fillRect/>
           </a:stretch>
@@ -6447,7 +6798,6 @@
           <a:lstStyle/>
           <a:p>
             <a:pPr algn="ctr"/>
-            <a:endParaRPr/>
           </a:p>
         </p:txBody>
       </p:sp>
@@ -6481,6 +6831,11 @@
               </a:rPr>
               <a:t>Event</a:t>
             </a:r>
+            <a:endParaRPr sz="1100" b="1">
+              <a:solidFill>
+                <a:srgbClr val="FFFFFF"/>
+              </a:solidFill>
+            </a:endParaRPr>
           </a:p>
         </p:txBody>
       </p:sp>
@@ -6514,6 +6869,11 @@
               </a:rPr>
               <a:t>Buffer</a:t>
             </a:r>
+            <a:endParaRPr sz="1100" b="1">
+              <a:solidFill>
+                <a:srgbClr val="FFFFFF"/>
+              </a:solidFill>
+            </a:endParaRPr>
           </a:p>
         </p:txBody>
       </p:sp>
@@ -6547,6 +6907,11 @@
               </a:rPr>
               <a:t>CAR</a:t>
             </a:r>
+            <a:endParaRPr sz="1100" b="1">
+              <a:solidFill>
+                <a:srgbClr val="FFFFFF"/>
+              </a:solidFill>
+            </a:endParaRPr>
           </a:p>
         </p:txBody>
       </p:sp>
@@ -6580,6 +6945,11 @@
               </a:rPr>
               <a:t>Sig.</a:t>
             </a:r>
+            <a:endParaRPr sz="1100" b="1">
+              <a:solidFill>
+                <a:srgbClr val="FFFFFF"/>
+              </a:solidFill>
+            </a:endParaRPr>
           </a:p>
         </p:txBody>
       </p:sp>
@@ -6623,7 +6993,6 @@
           <a:lstStyle/>
           <a:p>
             <a:pPr algn="ctr"/>
-            <a:endParaRPr/>
           </a:p>
         </p:txBody>
       </p:sp>
@@ -6657,6 +7026,11 @@
               </a:rPr>
               <a:t>LUNA/UST Collapse</a:t>
             </a:r>
+            <a:endParaRPr sz="1100" b="0" dirty="0">
+              <a:solidFill>
+                <a:srgbClr val="1A1A2E"/>
+              </a:solidFill>
+            </a:endParaRPr>
           </a:p>
         </p:txBody>
       </p:sp>
@@ -6690,6 +7064,11 @@
               </a:rPr>
               <a:t>LOW</a:t>
             </a:r>
+            <a:endParaRPr sz="1100" b="0">
+              <a:solidFill>
+                <a:srgbClr val="C0392B"/>
+              </a:solidFill>
+            </a:endParaRPr>
           </a:p>
         </p:txBody>
       </p:sp>
@@ -6723,6 +7102,11 @@
               </a:rPr>
               <a:t>+8.91 bp</a:t>
             </a:r>
+            <a:endParaRPr sz="1100" b="0">
+              <a:solidFill>
+                <a:srgbClr val="C0392B"/>
+              </a:solidFill>
+            </a:endParaRPr>
           </a:p>
         </p:txBody>
       </p:sp>
@@ -6756,6 +7140,11 @@
               </a:rPr>
               <a:t>***</a:t>
             </a:r>
+            <a:endParaRPr sz="1100" b="0">
+              <a:solidFill>
+                <a:srgbClr val="C0392B"/>
+              </a:solidFill>
+            </a:endParaRPr>
           </a:p>
         </p:txBody>
       </p:sp>
@@ -6799,7 +7188,6 @@
           <a:lstStyle/>
           <a:p>
             <a:pPr algn="ctr"/>
-            <a:endParaRPr/>
           </a:p>
         </p:txBody>
       </p:sp>
@@ -6879,6 +7267,11 @@
               </a:rPr>
               <a:t>LOW</a:t>
             </a:r>
+            <a:endParaRPr sz="1100" b="0">
+              <a:solidFill>
+                <a:srgbClr val="C0392B"/>
+              </a:solidFill>
+            </a:endParaRPr>
           </a:p>
         </p:txBody>
       </p:sp>
@@ -6912,6 +7305,11 @@
               </a:rPr>
               <a:t>+8.85 bp</a:t>
             </a:r>
+            <a:endParaRPr sz="1100" b="0">
+              <a:solidFill>
+                <a:srgbClr val="C0392B"/>
+              </a:solidFill>
+            </a:endParaRPr>
           </a:p>
         </p:txBody>
       </p:sp>
@@ -6945,6 +7343,11 @@
               </a:rPr>
               <a:t>***</a:t>
             </a:r>
+            <a:endParaRPr sz="1100" b="0">
+              <a:solidFill>
+                <a:srgbClr val="C0392B"/>
+              </a:solidFill>
+            </a:endParaRPr>
           </a:p>
         </p:txBody>
       </p:sp>
@@ -6988,7 +7391,6 @@
           <a:lstStyle/>
           <a:p>
             <a:pPr algn="ctr"/>
-            <a:endParaRPr/>
           </a:p>
         </p:txBody>
       </p:sp>
@@ -7022,6 +7424,11 @@
               </a:rPr>
               <a:t>USDC / SVB Failure</a:t>
             </a:r>
+            <a:endParaRPr sz="1100" b="0" dirty="0">
+              <a:solidFill>
+                <a:srgbClr val="1A1A2E"/>
+              </a:solidFill>
+            </a:endParaRPr>
           </a:p>
         </p:txBody>
       </p:sp>
@@ -7055,6 +7462,11 @@
               </a:rPr>
               <a:t>HIGH</a:t>
             </a:r>
+            <a:endParaRPr sz="1100" b="0">
+              <a:solidFill>
+                <a:srgbClr val="1A7A4A"/>
+              </a:solidFill>
+            </a:endParaRPr>
           </a:p>
         </p:txBody>
       </p:sp>
@@ -7066,8 +7478,8 @@
         </p:nvSpPr>
         <p:spPr>
           <a:xfrm>
-            <a:off x="10244999" y="2230120"/>
-            <a:ext cx="757005" cy="261610"/>
+            <a:off x="10245090" y="2230120"/>
+            <a:ext cx="919480" cy="260350"/>
           </a:xfrm>
           <a:prstGeom prst="rect">
             <a:avLst/>
@@ -7086,8 +7498,29 @@
                   <a:srgbClr val="1A7A4A"/>
                 </a:solidFill>
               </a:rPr>
-              <a:t>−18.01 bp</a:t>
-            </a:r>
+              <a:t>−18.01</a:t>
+            </a:r>
+            <a:r>
+              <a:rPr lang="en-US" sz="1100" b="0">
+                <a:solidFill>
+                  <a:srgbClr val="1A7A4A"/>
+                </a:solidFill>
+              </a:rPr>
+              <a:t> </a:t>
+            </a:r>
+            <a:r>
+              <a:rPr sz="1100" b="0">
+                <a:solidFill>
+                  <a:srgbClr val="1A7A4A"/>
+                </a:solidFill>
+              </a:rPr>
+              <a:t>bp</a:t>
+            </a:r>
+            <a:endParaRPr sz="1100" b="0">
+              <a:solidFill>
+                <a:srgbClr val="1A7A4A"/>
+              </a:solidFill>
+            </a:endParaRPr>
           </a:p>
         </p:txBody>
       </p:sp>
@@ -7121,6 +7554,11 @@
               </a:rPr>
               <a:t>***</a:t>
             </a:r>
+            <a:endParaRPr sz="1100" b="0">
+              <a:solidFill>
+                <a:srgbClr val="1A7A4A"/>
+              </a:solidFill>
+            </a:endParaRPr>
           </a:p>
         </p:txBody>
       </p:sp>
@@ -7154,6 +7592,11 @@
               </a:rPr>
               <a:t>Low vs. High buffer diff-test: t = 15.22, p &lt; 0.001</a:t>
             </a:r>
+            <a:endParaRPr sz="1000" b="0">
+              <a:solidFill>
+                <a:srgbClr val="555566"/>
+              </a:solidFill>
+            </a:endParaRPr>
           </a:p>
         </p:txBody>
       </p:sp>
@@ -7165,8 +7608,8 @@
         </p:nvSpPr>
         <p:spPr>
           <a:xfrm>
-            <a:off x="7315000" y="3060120"/>
-            <a:ext cx="4200000" cy="2200000"/>
+            <a:off x="7315200" y="3060065"/>
+            <a:ext cx="4199890" cy="2343150"/>
           </a:xfrm>
           <a:prstGeom prst="rect">
             <a:avLst/>
@@ -7197,7 +7640,6 @@
           <a:lstStyle/>
           <a:p>
             <a:pPr algn="ctr"/>
-            <a:endParaRPr/>
           </a:p>
         </p:txBody>
       </p:sp>
@@ -7209,8 +7651,8 @@
         </p:nvSpPr>
         <p:spPr>
           <a:xfrm>
-            <a:off x="7395000" y="3160120"/>
-            <a:ext cx="4000000" cy="1672253"/>
+            <a:off x="7395210" y="3160395"/>
+            <a:ext cx="3999865" cy="1950085"/>
           </a:xfrm>
           <a:prstGeom prst="rect">
             <a:avLst/>
@@ -7219,19 +7661,24 @@
         </p:spPr>
         <p:txBody>
           <a:bodyPr wrap="square">
-            <a:spAutoFit/>
+            <a:noAutofit/>
           </a:bodyPr>
           <a:lstStyle/>
           <a:p>
             <a:pPr algn="l"/>
             <a:r>
-              <a:rPr sz="1400" b="1" dirty="0">
+              <a:rPr sz="1600" b="1" dirty="0">
                 <a:solidFill>
                   <a:srgbClr val="AAC4E8"/>
                 </a:solidFill>
               </a:rPr>
               <a:t>What this shows:</a:t>
             </a:r>
+            <a:endParaRPr sz="1600" b="1" dirty="0">
+              <a:solidFill>
+                <a:srgbClr val="AAC4E8"/>
+              </a:solidFill>
+            </a:endParaRPr>
           </a:p>
           <a:p>
             <a:pPr>
@@ -7240,14 +7687,34 @@
               </a:spcBef>
             </a:pPr>
             <a:r>
-              <a:rPr sz="1200" b="0" dirty="0">
+              <a:rPr sz="1400" b="0" dirty="0">
                 <a:solidFill>
                   <a:srgbClr val="FFFFFF"/>
                 </a:solidFill>
               </a:rPr>
-              <a:t>❖  LOW buffer (LUNA, USDT 2022): spreads spike +8.9 bp — forced
-  T-bill liquidation transmits to sovereign debt markets</a:t>
-            </a:r>
+              <a:t>❖  LOW buffer (LUNA, USDT 2022): spreads spike +8.9 bp — forced</a:t>
+            </a:r>
+            <a:r>
+              <a:rPr lang="en-US" sz="1400" b="0" dirty="0">
+                <a:solidFill>
+                  <a:srgbClr val="FFFFFF"/>
+                </a:solidFill>
+              </a:rPr>
+              <a:t> </a:t>
+            </a:r>
+            <a:r>
+              <a:rPr sz="1400" b="0" dirty="0">
+                <a:solidFill>
+                  <a:srgbClr val="FFFFFF"/>
+                </a:solidFill>
+              </a:rPr>
+              <a:t>T-bill liquidation transmits to sovereign debt markets</a:t>
+            </a:r>
+            <a:endParaRPr sz="1400" b="0" dirty="0">
+              <a:solidFill>
+                <a:srgbClr val="FFFFFF"/>
+              </a:solidFill>
+            </a:endParaRPr>
           </a:p>
           <a:p>
             <a:pPr>
@@ -7256,7 +7723,7 @@
               </a:spcBef>
             </a:pPr>
             <a:r>
-              <a:rPr sz="1200" b="0" dirty="0">
+              <a:rPr sz="1400" b="0" dirty="0">
                 <a:solidFill>
                   <a:srgbClr val="FFFFFF"/>
                 </a:solidFill>
@@ -7264,7 +7731,7 @@
               <a:t>❖  HIGH buffer (SVB 2023): spreads compress −18 bp — cash absorbs</a:t>
             </a:r>
             <a:r>
-              <a:rPr lang="ko-KR" altLang="en-US" sz="1200" dirty="0">
+              <a:rPr lang="ko-KR" altLang="en-US" sz="1400" dirty="0">
                 <a:solidFill>
                   <a:srgbClr val="FFFFFF"/>
                 </a:solidFill>
@@ -7272,13 +7739,18 @@
               <a:t> </a:t>
             </a:r>
             <a:r>
-              <a:rPr sz="1200" b="0" dirty="0">
+              <a:rPr sz="1400" b="0" dirty="0">
                 <a:solidFill>
                   <a:srgbClr val="FFFFFF"/>
                 </a:solidFill>
               </a:rPr>
               <a:t>redemptions; market sees flight-to-safety instead</a:t>
             </a:r>
+            <a:endParaRPr sz="1400" b="0" dirty="0">
+              <a:solidFill>
+                <a:srgbClr val="FFFFFF"/>
+              </a:solidFill>
+            </a:endParaRPr>
           </a:p>
           <a:p>
             <a:pPr>
@@ -7287,13 +7759,18 @@
               </a:spcBef>
             </a:pPr>
             <a:r>
-              <a:rPr sz="1200" b="0" dirty="0">
+              <a:rPr sz="1400" b="0" dirty="0">
                 <a:solidFill>
                   <a:srgbClr val="FFFFFF"/>
                 </a:solidFill>
               </a:rPr>
               <a:t>❖  Difference is statistically significant (p &lt; 0.001)</a:t>
             </a:r>
+            <a:endParaRPr sz="1400" b="0" dirty="0">
+              <a:solidFill>
+                <a:srgbClr val="FFFFFF"/>
+              </a:solidFill>
+            </a:endParaRPr>
           </a:p>
         </p:txBody>
       </p:sp>
@@ -7337,7 +7814,6 @@
           <a:lstStyle/>
           <a:p>
             <a:pPr algn="ctr"/>
-            <a:endParaRPr/>
           </a:p>
         </p:txBody>
       </p:sp>
@@ -7372,6 +7848,11 @@
               </a:rPr>
               <a:t>Causal evidence: the buffer — not the event — determines whether a run stabilises or disrupts Treasury markets.</a:t>
             </a:r>
+            <a:endParaRPr sz="1800" b="1">
+              <a:solidFill>
+                <a:srgbClr val="FFFFFF"/>
+              </a:solidFill>
+            </a:endParaRPr>
           </a:p>
         </p:txBody>
       </p:sp>
@@ -7440,7 +7921,6 @@
           <a:lstStyle/>
           <a:p>
             <a:pPr algn="ctr"/>
-            <a:endParaRPr/>
           </a:p>
         </p:txBody>
       </p:sp>
@@ -7484,7 +7964,6 @@
           <a:lstStyle/>
           <a:p>
             <a:pPr algn="ctr"/>
-            <a:endParaRPr/>
           </a:p>
         </p:txBody>
       </p:sp>
@@ -7518,6 +7997,11 @@
               </a:rPr>
               <a:t>Asymmetric Effects: Growth vs. Contraction Periods</a:t>
             </a:r>
+            <a:endParaRPr sz="2600" b="0">
+              <a:solidFill>
+                <a:srgbClr val="FFFFFF"/>
+              </a:solidFill>
+            </a:endParaRPr>
           </a:p>
         </p:txBody>
       </p:sp>
@@ -7598,6 +8082,11 @@
               </a:rPr>
               <a:t>Buying T-bills is gradual and orderly. Selling is forced and immediate. The buffer only matters when supply contracts.</a:t>
             </a:r>
+            <a:endParaRPr sz="1300" b="0" dirty="0">
+              <a:solidFill>
+                <a:srgbClr val="555566"/>
+              </a:solidFill>
+            </a:endParaRPr>
           </a:p>
         </p:txBody>
       </p:sp>
@@ -7641,7 +8130,6 @@
           <a:lstStyle/>
           <a:p>
             <a:pPr algn="ctr"/>
-            <a:endParaRPr/>
           </a:p>
         </p:txBody>
       </p:sp>
@@ -7685,7 +8173,6 @@
           <a:lstStyle/>
           <a:p>
             <a:pPr algn="ctr"/>
-            <a:endParaRPr/>
           </a:p>
         </p:txBody>
       </p:sp>
@@ -7719,6 +8206,11 @@
               </a:rPr>
               <a:t>GROWTH PERIODS  (ΔlnS &gt; 0)   N = 32</a:t>
             </a:r>
+            <a:endParaRPr sz="1400" b="1">
+              <a:solidFill>
+                <a:srgbClr val="FFFFFF"/>
+              </a:solidFill>
+            </a:endParaRPr>
           </a:p>
         </p:txBody>
       </p:sp>
@@ -7731,7 +8223,7 @@
         <p:spPr>
           <a:xfrm>
             <a:off x="420000" y="1800000"/>
-            <a:ext cx="5350000" cy="1795363"/>
+            <a:ext cx="5350000" cy="1732915"/>
           </a:xfrm>
           <a:prstGeom prst="rect">
             <a:avLst/>
@@ -7769,6 +8261,11 @@
               </a:rPr>
               <a:t>.)</a:t>
             </a:r>
+            <a:endParaRPr sz="2800" b="1" dirty="0">
+              <a:solidFill>
+                <a:srgbClr val="C0392B"/>
+              </a:solidFill>
+            </a:endParaRPr>
           </a:p>
           <a:p>
             <a:pPr>
@@ -7816,6 +8313,11 @@
               </a:rPr>
               <a:t>.)</a:t>
             </a:r>
+            <a:endParaRPr sz="1600" b="0" dirty="0">
+              <a:solidFill>
+                <a:srgbClr val="1A1A2E"/>
+              </a:solidFill>
+            </a:endParaRPr>
           </a:p>
           <a:p>
             <a:pPr>
@@ -7831,6 +8333,11 @@
               </a:rPr>
               <a:t>R² = 0.335</a:t>
             </a:r>
+            <a:endParaRPr sz="1400" b="0" dirty="0">
+              <a:solidFill>
+                <a:srgbClr val="1A1A2E"/>
+              </a:solidFill>
+            </a:endParaRPr>
           </a:p>
           <a:p>
             <a:pPr>
@@ -7839,16 +8346,15 @@
               </a:spcBef>
             </a:pPr>
             <a:r>
-              <a:rPr sz="1300" b="0" dirty="0">
+              <a:rPr sz="1600" b="0" dirty="0">
                 <a:solidFill>
                   <a:srgbClr val="1A1A2E"/>
                 </a:solidFill>
               </a:rPr>
-              <a:t>Supply growth → orderly T-bill purchases.
-Buffer size does not significantly change</a:t>
-            </a:r>
-            <a:r>
-              <a:rPr lang="ko-KR" altLang="en-US" sz="1300" b="0" dirty="0">
+              <a:t>Supply growth → orderly T-bill purchases.</a:t>
+            </a:r>
+            <a:r>
+              <a:rPr lang="en-US" sz="1600" b="0" dirty="0">
                 <a:solidFill>
                   <a:srgbClr val="1A1A2E"/>
                 </a:solidFill>
@@ -7856,13 +8362,34 @@
               <a:t> </a:t>
             </a:r>
             <a:r>
-              <a:rPr sz="1300" b="0" dirty="0">
+              <a:rPr sz="1600" b="0" dirty="0">
                 <a:solidFill>
                   <a:srgbClr val="1A1A2E"/>
                 </a:solidFill>
               </a:rPr>
+              <a:t>Buffer size does not significantly change</a:t>
+            </a:r>
+            <a:r>
+              <a:rPr lang="ko-KR" altLang="en-US" sz="1600" b="0" dirty="0">
+                <a:solidFill>
+                  <a:srgbClr val="1A1A2E"/>
+                </a:solidFill>
+              </a:rPr>
+              <a:t> </a:t>
+            </a:r>
+            <a:r>
+              <a:rPr sz="1600" b="0" dirty="0">
+                <a:solidFill>
+                  <a:srgbClr val="1A1A2E"/>
+                </a:solidFill>
+              </a:rPr>
               <a:t>how issuers affect markets.</a:t>
             </a:r>
+            <a:endParaRPr sz="1600" b="0" dirty="0">
+              <a:solidFill>
+                <a:srgbClr val="1A1A2E"/>
+              </a:solidFill>
+            </a:endParaRPr>
           </a:p>
         </p:txBody>
       </p:sp>
@@ -7906,7 +8433,6 @@
           <a:lstStyle/>
           <a:p>
             <a:pPr algn="ctr"/>
-            <a:endParaRPr/>
           </a:p>
         </p:txBody>
       </p:sp>
@@ -7950,7 +8476,6 @@
           <a:lstStyle/>
           <a:p>
             <a:pPr algn="ctr"/>
-            <a:endParaRPr/>
           </a:p>
         </p:txBody>
       </p:sp>
@@ -7984,6 +8509,11 @@
               </a:rPr>
               <a:t>CONTRACTION PERIODS  (ΔlnS &lt; 0)   N = 19</a:t>
             </a:r>
+            <a:endParaRPr sz="1400" b="1">
+              <a:solidFill>
+                <a:srgbClr val="FFFFFF"/>
+              </a:solidFill>
+            </a:endParaRPr>
           </a:p>
         </p:txBody>
       </p:sp>
@@ -7996,7 +8526,7 @@
         <p:spPr>
           <a:xfrm>
             <a:off x="6370000" y="1800000"/>
-            <a:ext cx="5350000" cy="3400000"/>
+            <a:ext cx="5350000" cy="1978660"/>
           </a:xfrm>
           <a:prstGeom prst="rect">
             <a:avLst/>
@@ -8018,6 +8548,11 @@
               </a:rPr>
               <a:t>β₁ = −12.68**   (p = 0.037)</a:t>
             </a:r>
+            <a:endParaRPr sz="2800" b="1">
+              <a:solidFill>
+                <a:srgbClr val="1A7A4A"/>
+              </a:solidFill>
+            </a:endParaRPr>
           </a:p>
           <a:p>
             <a:pPr>
@@ -8033,6 +8568,11 @@
               </a:rPr>
               <a:t>L × ΔlnS = +78.57   (p = 0.314, n.s.)</a:t>
             </a:r>
+            <a:endParaRPr sz="1600" b="0">
+              <a:solidFill>
+                <a:srgbClr val="1A1A2E"/>
+              </a:solidFill>
+            </a:endParaRPr>
           </a:p>
           <a:p>
             <a:pPr>
@@ -8048,6 +8588,11 @@
               </a:rPr>
               <a:t>R² = 0.728</a:t>
             </a:r>
+            <a:endParaRPr sz="1400" b="0">
+              <a:solidFill>
+                <a:srgbClr val="1A1A2E"/>
+              </a:solidFill>
+            </a:endParaRPr>
           </a:p>
           <a:p>
             <a:pPr>
@@ -8056,7 +8601,7 @@
               </a:spcBef>
             </a:pPr>
             <a:r>
-              <a:rPr sz="1300" b="0">
+              <a:rPr sz="1600" b="0">
                 <a:solidFill>
                   <a:srgbClr val="1A1A2E"/>
                 </a:solidFill>
@@ -8065,6 +8610,11 @@
 Forced liquidation drives sovereign spread.
 Model explains 73% of variation in stress.</a:t>
             </a:r>
+            <a:endParaRPr sz="1600" b="0">
+              <a:solidFill>
+                <a:srgbClr val="1A1A2E"/>
+              </a:solidFill>
+            </a:endParaRPr>
           </a:p>
         </p:txBody>
       </p:sp>
@@ -8108,7 +8658,6 @@
           <a:lstStyle/>
           <a:p>
             <a:pPr algn="ctr"/>
-            <a:endParaRPr/>
           </a:p>
         </p:txBody>
       </p:sp>
@@ -8143,6 +8692,11 @@
               </a:rPr>
               <a:t>The buffer matters precisely when supply is falling — confirming the fragility mechanism our theory predicts.</a:t>
             </a:r>
+            <a:endParaRPr sz="1800" b="1">
+              <a:solidFill>
+                <a:srgbClr val="FFFFFF"/>
+              </a:solidFill>
+            </a:endParaRPr>
           </a:p>
         </p:txBody>
       </p:sp>
@@ -8211,7 +8765,6 @@
           <a:lstStyle/>
           <a:p>
             <a:pPr algn="ctr"/>
-            <a:endParaRPr/>
           </a:p>
         </p:txBody>
       </p:sp>
@@ -8255,7 +8808,6 @@
           <a:lstStyle/>
           <a:p>
             <a:pPr algn="ctr"/>
-            <a:endParaRPr/>
           </a:p>
         </p:txBody>
       </p:sp>
@@ -8289,6 +8841,11 @@
               </a:rPr>
               <a:t>Policy Implication: The 13% Empirical Floor</a:t>
             </a:r>
+            <a:endParaRPr sz="2600" b="0">
+              <a:solidFill>
+                <a:srgbClr val="FFFFFF"/>
+              </a:solidFill>
+            </a:endParaRPr>
           </a:p>
         </p:txBody>
       </p:sp>
@@ -8379,7 +8936,6 @@
           <a:lstStyle/>
           <a:p>
             <a:pPr algn="ctr"/>
-            <a:endParaRPr/>
           </a:p>
         </p:txBody>
       </p:sp>
@@ -8413,6 +8969,11 @@
               </a:rPr>
               <a:t>What the threshold tells us:</a:t>
             </a:r>
+            <a:endParaRPr sz="1500" b="1">
+              <a:solidFill>
+                <a:srgbClr val="AAC4E8"/>
+              </a:solidFill>
+            </a:endParaRPr>
           </a:p>
         </p:txBody>
       </p:sp>
@@ -8425,7 +8986,7 @@
         <p:spPr>
           <a:xfrm>
             <a:off x="420000" y="1450000"/>
-            <a:ext cx="4600000" cy="3200000"/>
+            <a:ext cx="4600000" cy="2840990"/>
           </a:xfrm>
           <a:prstGeom prst="rect">
             <a:avLst/>
@@ -8447,6 +9008,11 @@
               </a:rPr>
               <a:t>q*  =  13%</a:t>
             </a:r>
+            <a:endParaRPr sz="4000" b="1" dirty="0">
+              <a:solidFill>
+                <a:srgbClr val="FFFFFF"/>
+              </a:solidFill>
+            </a:endParaRPr>
           </a:p>
           <a:p>
             <a:pPr>
@@ -8455,13 +9021,18 @@
               </a:spcBef>
             </a:pPr>
             <a:r>
-              <a:rPr sz="1300" b="0" dirty="0">
+              <a:rPr sz="1600" b="0" dirty="0">
                 <a:solidFill>
                   <a:srgbClr val="AAC4E8"/>
                 </a:solidFill>
               </a:rPr>
               <a:t>of supply held as liquid cash</a:t>
             </a:r>
+            <a:endParaRPr sz="1600" b="0" dirty="0">
+              <a:solidFill>
+                <a:srgbClr val="AAC4E8"/>
+              </a:solidFill>
+            </a:endParaRPr>
           </a:p>
           <a:p>
             <a:pPr>
@@ -8470,24 +9041,49 @@
               </a:spcBef>
             </a:pPr>
             <a:r>
-              <a:rPr sz="1300" b="1" dirty="0">
+              <a:rPr sz="1600" b="1" dirty="0">
                 <a:solidFill>
                   <a:srgbClr val="FFD700"/>
                 </a:solidFill>
               </a:rPr>
               <a:t>Below 13% (38 of 51 months):</a:t>
             </a:r>
-          </a:p>
-          <a:p>
-            <a:r>
-              <a:rPr sz="1300" b="0" dirty="0">
+            <a:endParaRPr sz="1600" b="1" dirty="0">
+              <a:solidFill>
+                <a:srgbClr val="FFD700"/>
+              </a:solidFill>
+            </a:endParaRPr>
+          </a:p>
+          <a:p>
+            <a:r>
+              <a:rPr sz="1600" b="0" dirty="0">
                 <a:solidFill>
                   <a:srgbClr val="FFFFFF"/>
                 </a:solidFill>
               </a:rPr>
-              <a:t>Issuers move T-bill markets in both
-directions → sovereign spread disruption</a:t>
-            </a:r>
+              <a:t>Issuers move T-bill markets in both</a:t>
+            </a:r>
+            <a:r>
+              <a:rPr lang="en-US" sz="1600" b="0" dirty="0">
+                <a:solidFill>
+                  <a:srgbClr val="FFFFFF"/>
+                </a:solidFill>
+              </a:rPr>
+              <a:t> </a:t>
+            </a:r>
+            <a:r>
+              <a:rPr sz="1600" b="0" dirty="0">
+                <a:solidFill>
+                  <a:srgbClr val="FFFFFF"/>
+                </a:solidFill>
+              </a:rPr>
+              <a:t>directions → sovereign spread disruption</a:t>
+            </a:r>
+            <a:endParaRPr sz="1600" b="0" dirty="0">
+              <a:solidFill>
+                <a:srgbClr val="FFFFFF"/>
+              </a:solidFill>
+            </a:endParaRPr>
           </a:p>
           <a:p>
             <a:pPr>
@@ -8496,24 +9092,49 @@
               </a:spcBef>
             </a:pPr>
             <a:r>
-              <a:rPr sz="1300" b="1" dirty="0">
+              <a:rPr sz="1600" b="1" dirty="0">
                 <a:solidFill>
                   <a:srgbClr val="FFD700"/>
                 </a:solidFill>
               </a:rPr>
               <a:t>Above 13% (13 of 51 months):</a:t>
             </a:r>
-          </a:p>
-          <a:p>
-            <a:r>
-              <a:rPr sz="1300" b="0" dirty="0">
+            <a:endParaRPr sz="1600" b="1" dirty="0">
+              <a:solidFill>
+                <a:srgbClr val="FFD700"/>
+              </a:solidFill>
+            </a:endParaRPr>
+          </a:p>
+          <a:p>
+            <a:r>
+              <a:rPr sz="1600" b="0" dirty="0">
                 <a:solidFill>
                   <a:srgbClr val="FFFFFF"/>
                 </a:solidFill>
               </a:rPr>
-              <a:t>Redemptions absorbed by cash →
-T-bill market undisturbed</a:t>
-            </a:r>
+              <a:t>Redemptions absorbed by cash →</a:t>
+            </a:r>
+            <a:r>
+              <a:rPr lang="en-US" sz="1600" b="0" dirty="0">
+                <a:solidFill>
+                  <a:srgbClr val="FFFFFF"/>
+                </a:solidFill>
+              </a:rPr>
+              <a:t> </a:t>
+            </a:r>
+            <a:r>
+              <a:rPr sz="1600" b="0" dirty="0">
+                <a:solidFill>
+                  <a:srgbClr val="FFFFFF"/>
+                </a:solidFill>
+              </a:rPr>
+              <a:t>T-bill market undisturbed</a:t>
+            </a:r>
+            <a:endParaRPr sz="1600" b="0" dirty="0">
+              <a:solidFill>
+                <a:srgbClr val="FFFFFF"/>
+              </a:solidFill>
+            </a:endParaRPr>
           </a:p>
         </p:txBody>
       </p:sp>
@@ -8557,7 +9178,6 @@
           <a:lstStyle/>
           <a:p>
             <a:pPr algn="ctr"/>
-            <a:endParaRPr/>
           </a:p>
         </p:txBody>
       </p:sp>
@@ -8570,7 +9190,7 @@
         <p:spPr>
           <a:xfrm>
             <a:off x="5450000" y="1020000"/>
-            <a:ext cx="6200000" cy="340000"/>
+            <a:ext cx="6200000" cy="368300"/>
           </a:xfrm>
           <a:prstGeom prst="rect">
             <a:avLst/>
@@ -8584,13 +9204,18 @@
           <a:lstStyle/>
           <a:p>
             <a:r>
-              <a:rPr sz="1500" b="1">
+              <a:rPr b="1">
                 <a:solidFill>
                   <a:srgbClr val="1B3A72"/>
                 </a:solidFill>
               </a:rPr>
               <a:t>Regulatory interpretation:</a:t>
             </a:r>
+            <a:endParaRPr b="1">
+              <a:solidFill>
+                <a:srgbClr val="1B3A72"/>
+              </a:solidFill>
+            </a:endParaRPr>
           </a:p>
         </p:txBody>
       </p:sp>
@@ -8603,7 +9228,7 @@
         <p:spPr>
           <a:xfrm>
             <a:off x="5450000" y="1450000"/>
-            <a:ext cx="6100000" cy="260000"/>
+            <a:ext cx="6100000" cy="321945"/>
           </a:xfrm>
           <a:prstGeom prst="rect">
             <a:avLst/>
@@ -8617,13 +9242,18 @@
           <a:lstStyle/>
           <a:p>
             <a:r>
-              <a:rPr sz="1200" b="1">
+              <a:rPr sz="1500" b="1">
                 <a:solidFill>
                   <a:srgbClr val="1B3A72"/>
                 </a:solidFill>
               </a:rPr>
               <a:t>What the data says</a:t>
             </a:r>
+            <a:endParaRPr sz="1500" b="1">
+              <a:solidFill>
+                <a:srgbClr val="1B3A72"/>
+              </a:solidFill>
+            </a:endParaRPr>
           </a:p>
         </p:txBody>
       </p:sp>
@@ -8636,7 +9266,7 @@
         <p:spPr>
           <a:xfrm>
             <a:off x="5450000" y="1710000"/>
-            <a:ext cx="6100000" cy="400000"/>
+            <a:ext cx="6100000" cy="521970"/>
           </a:xfrm>
           <a:prstGeom prst="rect">
             <a:avLst/>
@@ -8650,14 +9280,34 @@
           <a:lstStyle/>
           <a:p>
             <a:r>
-              <a:rPr sz="1200" b="0" dirty="0">
+              <a:rPr sz="1400" b="0" dirty="0">
                 <a:solidFill>
                   <a:srgbClr val="1A1A2E"/>
                 </a:solidFill>
               </a:rPr>
-              <a:t>L* = 13% is the empirically identified statistical break point
-separating two distinct regimes — not an optimal level</a:t>
-            </a:r>
+              <a:t>L* = 13% is the empirically identified statistical break point</a:t>
+            </a:r>
+            <a:r>
+              <a:rPr lang="en-US" sz="1400" b="0" dirty="0">
+                <a:solidFill>
+                  <a:srgbClr val="1A1A2E"/>
+                </a:solidFill>
+              </a:rPr>
+              <a:t> </a:t>
+            </a:r>
+            <a:r>
+              <a:rPr sz="1400" b="0" dirty="0">
+                <a:solidFill>
+                  <a:srgbClr val="1A1A2E"/>
+                </a:solidFill>
+              </a:rPr>
+              <a:t>separating two distinct regimes — not an optimal level</a:t>
+            </a:r>
+            <a:endParaRPr sz="1400" b="0" dirty="0">
+              <a:solidFill>
+                <a:srgbClr val="1A1A2E"/>
+              </a:solidFill>
+            </a:endParaRPr>
           </a:p>
         </p:txBody>
       </p:sp>
@@ -8670,7 +9320,7 @@
         <p:spPr>
           <a:xfrm>
             <a:off x="5450000" y="2210000"/>
-            <a:ext cx="6100000" cy="260000"/>
+            <a:ext cx="6100000" cy="321945"/>
           </a:xfrm>
           <a:prstGeom prst="rect">
             <a:avLst/>
@@ -8684,13 +9334,18 @@
           <a:lstStyle/>
           <a:p>
             <a:r>
-              <a:rPr sz="1200" b="1">
+              <a:rPr sz="1500" b="1">
                 <a:solidFill>
                   <a:srgbClr val="1B3A72"/>
                 </a:solidFill>
               </a:rPr>
               <a:t>Proposed floor</a:t>
             </a:r>
+            <a:endParaRPr sz="1500" b="1">
+              <a:solidFill>
+                <a:srgbClr val="1B3A72"/>
+              </a:solidFill>
+            </a:endParaRPr>
           </a:p>
         </p:txBody>
       </p:sp>
@@ -8703,7 +9358,7 @@
         <p:spPr>
           <a:xfrm>
             <a:off x="5450000" y="2470000"/>
-            <a:ext cx="6100000" cy="400000"/>
+            <a:ext cx="6100000" cy="521970"/>
           </a:xfrm>
           <a:prstGeom prst="rect">
             <a:avLst/>
@@ -8717,14 +9372,34 @@
           <a:lstStyle/>
           <a:p>
             <a:r>
-              <a:rPr sz="1200" b="0">
+              <a:rPr sz="1400" b="0">
                 <a:solidFill>
                   <a:srgbClr val="1A1A2E"/>
                 </a:solidFill>
               </a:rPr>
-              <a:t>Minimum liquid reserve requirement of 13–15% of outstanding supply
-(cash or near-cash instruments only)</a:t>
-            </a:r>
+              <a:t>Minimum liquid reserve requirement of 13–15% of outstanding supply</a:t>
+            </a:r>
+            <a:r>
+              <a:rPr lang="en-US" sz="1400" b="0">
+                <a:solidFill>
+                  <a:srgbClr val="1A1A2E"/>
+                </a:solidFill>
+              </a:rPr>
+              <a:t> ( </a:t>
+            </a:r>
+            <a:r>
+              <a:rPr sz="1400" b="0">
+                <a:solidFill>
+                  <a:srgbClr val="1A1A2E"/>
+                </a:solidFill>
+              </a:rPr>
+              <a:t>cash or near-cash instruments only)</a:t>
+            </a:r>
+            <a:endParaRPr sz="1400" b="0">
+              <a:solidFill>
+                <a:srgbClr val="1A1A2E"/>
+              </a:solidFill>
+            </a:endParaRPr>
           </a:p>
         </p:txBody>
       </p:sp>
@@ -8737,7 +9412,7 @@
         <p:spPr>
           <a:xfrm>
             <a:off x="5450000" y="2970000"/>
-            <a:ext cx="6100000" cy="260000"/>
+            <a:ext cx="6100000" cy="321945"/>
           </a:xfrm>
           <a:prstGeom prst="rect">
             <a:avLst/>
@@ -8751,13 +9426,18 @@
           <a:lstStyle/>
           <a:p>
             <a:r>
-              <a:rPr sz="1200" b="1">
+              <a:rPr sz="1500" b="1">
                 <a:solidFill>
                   <a:srgbClr val="1B3A72"/>
                 </a:solidFill>
               </a:rPr>
               <a:t>Who this applies to</a:t>
             </a:r>
+            <a:endParaRPr sz="1500" b="1">
+              <a:solidFill>
+                <a:srgbClr val="1B3A72"/>
+              </a:solidFill>
+            </a:endParaRPr>
           </a:p>
         </p:txBody>
       </p:sp>
@@ -8770,7 +9450,7 @@
         <p:spPr>
           <a:xfrm>
             <a:off x="5450000" y="3230000"/>
-            <a:ext cx="6100000" cy="400000"/>
+            <a:ext cx="6100000" cy="521970"/>
           </a:xfrm>
           <a:prstGeom prst="rect">
             <a:avLst/>
@@ -8784,7 +9464,7 @@
           <a:lstStyle/>
           <a:p>
             <a:r>
-              <a:rPr sz="1200" b="0" dirty="0">
+              <a:rPr sz="1400" b="0" dirty="0">
                 <a:solidFill>
                   <a:srgbClr val="1A1A2E"/>
                 </a:solidFill>
@@ -8792,7 +9472,7 @@
               <a:t>USD-pegged fiat-</a:t>
             </a:r>
             <a:r>
-              <a:rPr sz="1200" b="0" dirty="0" err="1">
+              <a:rPr sz="1400" b="0" dirty="0" err="1">
                 <a:solidFill>
                   <a:srgbClr val="1A1A2E"/>
                 </a:solidFill>
@@ -8800,14 +9480,34 @@
               <a:t>collateralised</a:t>
             </a:r>
             <a:r>
-              <a:rPr sz="1200" b="0" dirty="0">
+              <a:rPr sz="1400" b="0" dirty="0">
                 <a:solidFill>
                   <a:srgbClr val="1A1A2E"/>
                 </a:solidFill>
               </a:rPr>
-              <a:t> stablecoin issuers
-operating above $10bn supply (systemic threshold)</a:t>
-            </a:r>
+              <a:t> stablecoin issuers</a:t>
+            </a:r>
+            <a:r>
+              <a:rPr lang="en-US" sz="1400" b="0" dirty="0">
+                <a:solidFill>
+                  <a:srgbClr val="1A1A2E"/>
+                </a:solidFill>
+              </a:rPr>
+              <a:t> </a:t>
+            </a:r>
+            <a:r>
+              <a:rPr sz="1400" b="0" dirty="0">
+                <a:solidFill>
+                  <a:srgbClr val="1A1A2E"/>
+                </a:solidFill>
+              </a:rPr>
+              <a:t>operating above $10bn supply (systemic threshold)</a:t>
+            </a:r>
+            <a:endParaRPr sz="1400" b="0" dirty="0">
+              <a:solidFill>
+                <a:srgbClr val="1A1A2E"/>
+              </a:solidFill>
+            </a:endParaRPr>
           </a:p>
         </p:txBody>
       </p:sp>
@@ -8820,7 +9520,7 @@
         <p:spPr>
           <a:xfrm>
             <a:off x="5450000" y="3730000"/>
-            <a:ext cx="6100000" cy="260000"/>
+            <a:ext cx="6100000" cy="321945"/>
           </a:xfrm>
           <a:prstGeom prst="rect">
             <a:avLst/>
@@ -8834,13 +9534,18 @@
           <a:lstStyle/>
           <a:p>
             <a:r>
-              <a:rPr sz="1200" b="1">
+              <a:rPr sz="1500" b="1">
                 <a:solidFill>
                   <a:srgbClr val="1B3A72"/>
                 </a:solidFill>
               </a:rPr>
               <a:t>Caveat — welfare optimum</a:t>
             </a:r>
+            <a:endParaRPr sz="1500" b="1">
+              <a:solidFill>
+                <a:srgbClr val="1B3A72"/>
+              </a:solidFill>
+            </a:endParaRPr>
           </a:p>
         </p:txBody>
       </p:sp>
@@ -8853,7 +9558,7 @@
         <p:spPr>
           <a:xfrm>
             <a:off x="5450000" y="3990000"/>
-            <a:ext cx="6100000" cy="400000"/>
+            <a:ext cx="6100000" cy="521970"/>
           </a:xfrm>
           <a:prstGeom prst="rect">
             <a:avLst/>
@@ -8867,7 +9572,7 @@
           <a:lstStyle/>
           <a:p>
             <a:r>
-              <a:rPr sz="1200" b="0" dirty="0">
+              <a:rPr sz="1400" b="0" dirty="0">
                 <a:solidFill>
                   <a:srgbClr val="1A1A2E"/>
                 </a:solidFill>
@@ -8875,7 +9580,7 @@
               <a:t>This threshold identifies a </a:t>
             </a:r>
             <a:r>
-              <a:rPr sz="1200" b="0" dirty="0" err="1">
+              <a:rPr sz="1400" b="0" dirty="0" err="1">
                 <a:solidFill>
                   <a:srgbClr val="1A1A2E"/>
                 </a:solidFill>
@@ -8883,15 +9588,50 @@
               <a:t>behavioural</a:t>
             </a:r>
             <a:r>
-              <a:rPr sz="1200" b="0" dirty="0">
+              <a:rPr sz="1400" b="0" dirty="0">
                 <a:solidFill>
                   <a:srgbClr val="1A1A2E"/>
                 </a:solidFill>
               </a:rPr>
-              <a:t> break, not a welfare
-optimum. Full welfare analysis requires a structural model
-beyond this paper's scope</a:t>
-            </a:r>
+              <a:t> break, not a welfare</a:t>
+            </a:r>
+            <a:r>
+              <a:rPr lang="en-US" sz="1400" b="0" dirty="0">
+                <a:solidFill>
+                  <a:srgbClr val="1A1A2E"/>
+                </a:solidFill>
+              </a:rPr>
+              <a:t> </a:t>
+            </a:r>
+            <a:r>
+              <a:rPr sz="1400" b="0" dirty="0">
+                <a:solidFill>
+                  <a:srgbClr val="1A1A2E"/>
+                </a:solidFill>
+              </a:rPr>
+              <a:t>optimum. Full welfare analysis requires a structural model</a:t>
+            </a:r>
+            <a:r>
+              <a:rPr lang="en-US" sz="1400" b="0" dirty="0">
+                <a:solidFill>
+                  <a:srgbClr val="1A1A2E"/>
+                </a:solidFill>
+              </a:rPr>
+              <a:t> </a:t>
+            </a:r>
+            <a:r>
+              <a:rPr sz="1400" b="0" dirty="0">
+                <a:solidFill>
+                  <a:srgbClr val="1A1A2E"/>
+                </a:solidFill>
+              </a:rPr>
+              <a:t>beyond this paper's scope</a:t>
+            </a:r>
+            <a:endParaRPr sz="1400" b="0" dirty="0">
+              <a:solidFill>
+                <a:srgbClr val="1A1A2E"/>
+              </a:solidFill>
+            </a:endParaRPr>
           </a:p>
         </p:txBody>
       </p:sp>
@@ -8935,7 +9675,6 @@
           <a:lstStyle/>
           <a:p>
             <a:pPr algn="ctr"/>
-            <a:endParaRPr/>
           </a:p>
         </p:txBody>
       </p:sp>
@@ -8970,6 +9709,11 @@
               </a:rPr>
               <a:t>We identify where the break is — regulators determine where the requirement should be set.</a:t>
             </a:r>
+            <a:endParaRPr sz="1800" b="1">
+              <a:solidFill>
+                <a:srgbClr val="FFFFFF"/>
+              </a:solidFill>
+            </a:endParaRPr>
           </a:p>
         </p:txBody>
       </p:sp>
@@ -9038,7 +9782,6 @@
           <a:lstStyle/>
           <a:p>
             <a:pPr algn="ctr"/>
-            <a:endParaRPr/>
           </a:p>
         </p:txBody>
       </p:sp>
@@ -9082,7 +9825,6 @@
           <a:lstStyle/>
           <a:p>
             <a:pPr algn="ctr"/>
-            <a:endParaRPr/>
           </a:p>
         </p:txBody>
       </p:sp>
@@ -9116,6 +9858,11 @@
               </a:rPr>
               <a:t>Conclusion: Navigating the New Triffin Dilemma</a:t>
             </a:r>
+            <a:endParaRPr sz="2600" b="0">
+              <a:solidFill>
+                <a:srgbClr val="FFFFFF"/>
+              </a:solidFill>
+            </a:endParaRPr>
           </a:p>
         </p:txBody>
       </p:sp>
@@ -9206,7 +9953,6 @@
           <a:lstStyle/>
           <a:p>
             <a:pPr algn="ctr"/>
-            <a:endParaRPr/>
           </a:p>
         </p:txBody>
       </p:sp>
@@ -9250,7 +9996,6 @@
           <a:lstStyle/>
           <a:p>
             <a:pPr algn="ctr"/>
-            <a:endParaRPr/>
           </a:p>
         </p:txBody>
       </p:sp>
@@ -9284,6 +10029,11 @@
               </a:rPr>
               <a:t>Result 1 — Privilege Amplification</a:t>
             </a:r>
+            <a:endParaRPr sz="1300" b="1">
+              <a:solidFill>
+                <a:srgbClr val="FFFFFF"/>
+              </a:solidFill>
+            </a:endParaRPr>
           </a:p>
         </p:txBody>
       </p:sp>
@@ -9295,8 +10045,8 @@
         </p:nvSpPr>
         <p:spPr>
           <a:xfrm>
-            <a:off x="334320" y="1410120"/>
-            <a:ext cx="3260232" cy="1692771"/>
+            <a:off x="334010" y="1410335"/>
+            <a:ext cx="3260090" cy="3016885"/>
           </a:xfrm>
           <a:prstGeom prst="rect">
             <a:avLst/>
@@ -9305,12 +10055,12 @@
         </p:spPr>
         <p:txBody>
           <a:bodyPr wrap="square">
-            <a:spAutoFit/>
+            <a:noAutofit/>
           </a:bodyPr>
           <a:lstStyle/>
           <a:p>
             <a:r>
-              <a:rPr sz="1300" b="0">
+              <a:rPr sz="1600" b="0">
                 <a:solidFill>
                   <a:srgbClr val="1A1A2E"/>
                 </a:solidFill>
@@ -9320,6 +10070,11 @@
 Stablecoins mechanically deepen US safe-asset
 demand — amplifying the exorbitant privilege.</a:t>
             </a:r>
+            <a:endParaRPr sz="1600" b="0">
+              <a:solidFill>
+                <a:srgbClr val="1A1A2E"/>
+              </a:solidFill>
+            </a:endParaRPr>
           </a:p>
         </p:txBody>
       </p:sp>
@@ -9363,7 +10118,6 @@
           <a:lstStyle/>
           <a:p>
             <a:pPr algn="ctr"/>
-            <a:endParaRPr/>
           </a:p>
         </p:txBody>
       </p:sp>
@@ -9407,7 +10161,6 @@
           <a:lstStyle/>
           <a:p>
             <a:pPr algn="ctr"/>
-            <a:endParaRPr/>
           </a:p>
         </p:txBody>
       </p:sp>
@@ -9441,6 +10194,11 @@
               </a:rPr>
               <a:t>Result 2 — Safety Threshold</a:t>
             </a:r>
+            <a:endParaRPr sz="1300" b="1">
+              <a:solidFill>
+                <a:srgbClr val="FFFFFF"/>
+              </a:solidFill>
+            </a:endParaRPr>
           </a:p>
         </p:txBody>
       </p:sp>
@@ -9453,7 +10211,7 @@
         <p:spPr>
           <a:xfrm>
             <a:off x="4448640" y="1410120"/>
-            <a:ext cx="3260232" cy="1892826"/>
+            <a:ext cx="3260232" cy="2306955"/>
           </a:xfrm>
           <a:prstGeom prst="rect">
             <a:avLst/>
@@ -9467,7 +10225,7 @@
           <a:lstStyle/>
           <a:p>
             <a:r>
-              <a:rPr sz="1300" b="0">
+              <a:rPr sz="1600" b="0">
                 <a:solidFill>
                   <a:srgbClr val="1A1A2E"/>
                 </a:solidFill>
@@ -9477,6 +10235,11 @@
 Below 13%: forced liquidation disrupts sovereign debt.
 Above 13%: redemptions absorbed, markets undisturbed.</a:t>
             </a:r>
+            <a:endParaRPr sz="1600" b="0">
+              <a:solidFill>
+                <a:srgbClr val="1A1A2E"/>
+              </a:solidFill>
+            </a:endParaRPr>
           </a:p>
         </p:txBody>
       </p:sp>
@@ -9520,7 +10283,6 @@
           <a:lstStyle/>
           <a:p>
             <a:pPr algn="ctr"/>
-            <a:endParaRPr/>
           </a:p>
         </p:txBody>
       </p:sp>
@@ -9564,7 +10326,6 @@
           <a:lstStyle/>
           <a:p>
             <a:pPr algn="ctr"/>
-            <a:endParaRPr/>
           </a:p>
         </p:txBody>
       </p:sp>
@@ -9598,6 +10359,11 @@
               </a:rPr>
               <a:t>Result 3 — Causal Evidence</a:t>
             </a:r>
+            <a:endParaRPr sz="1300" b="1">
+              <a:solidFill>
+                <a:srgbClr val="FFFFFF"/>
+              </a:solidFill>
+            </a:endParaRPr>
           </a:p>
         </p:txBody>
       </p:sp>
@@ -9610,7 +10376,7 @@
         <p:spPr>
           <a:xfrm>
             <a:off x="8562960" y="1410120"/>
-            <a:ext cx="3260232" cy="1492716"/>
+            <a:ext cx="3260232" cy="2306955"/>
           </a:xfrm>
           <a:prstGeom prst="rect">
             <a:avLst/>
@@ -9624,65 +10390,68 @@
           <a:lstStyle/>
           <a:p>
             <a:r>
-              <a:rPr sz="1300" b="0">
+              <a:rPr sz="1600" b="0">
                 <a:solidFill>
                   <a:srgbClr val="1A1A2E"/>
                 </a:solidFill>
               </a:rPr>
-              <a:t>Buffer-conditioned event study across LUNA, USDT
-depeg, and USDC/SVB confirms the mechanism.
-Low-buffer runs → +8.9 bp spread spike.
+              <a:t>Buffer-conditioned event study across LUNA, USDT</a:t>
+            </a:r>
+            <a:r>
+              <a:rPr lang="en-US" sz="1600" b="0">
+                <a:solidFill>
+                  <a:srgbClr val="1A1A2E"/>
+                </a:solidFill>
+              </a:rPr>
+              <a:t> </a:t>
+            </a:r>
+            <a:r>
+              <a:rPr sz="1600" b="0">
+                <a:solidFill>
+                  <a:srgbClr val="1A1A2E"/>
+                </a:solidFill>
+              </a:rPr>
+              <a:t>depeg, and USDC/SVB confirms the</a:t>
+            </a:r>
+            <a:r>
+              <a:rPr lang="en-US" sz="1600" b="0">
+                <a:solidFill>
+                  <a:srgbClr val="1A1A2E"/>
+                </a:solidFill>
+              </a:rPr>
+              <a:t> </a:t>
+            </a:r>
+            <a:r>
+              <a:rPr sz="1600" b="0">
+                <a:solidFill>
+                  <a:srgbClr val="1A1A2E"/>
+                </a:solidFill>
+              </a:rPr>
+              <a:t>mechanism.
+Low-buffer runs → +8.9 bp</a:t>
+            </a:r>
+            <a:r>
+              <a:rPr lang="en-US" sz="1600" b="0">
+                <a:solidFill>
+                  <a:srgbClr val="1A1A2E"/>
+                </a:solidFill>
+              </a:rPr>
+              <a:t> </a:t>
+            </a:r>
+            <a:r>
+              <a:rPr sz="1600" b="0">
+                <a:solidFill>
+                  <a:srgbClr val="1A1A2E"/>
+                </a:solidFill>
+              </a:rPr>
+              <a:t>spread spike.
 High-buffer stress → −18 bp flight-to-safety.</a:t>
             </a:r>
-          </a:p>
-        </p:txBody>
-      </p:sp>
-      <p:sp>
-        <p:nvSpPr>
-          <p:cNvPr id="18" name="TextBox 17"/>
-          <p:cNvSpPr txBox="1"/>
-          <p:nvPr/>
-        </p:nvSpPr>
-        <p:spPr>
-          <a:xfrm>
-            <a:off x="365760" y="4650000"/>
-            <a:ext cx="11430000" cy="750000"/>
-          </a:xfrm>
-          <a:prstGeom prst="rect">
-            <a:avLst/>
-          </a:prstGeom>
-          <a:noFill/>
-        </p:spPr>
-        <p:txBody>
-          <a:bodyPr wrap="square">
-            <a:spAutoFit/>
-          </a:bodyPr>
-          <a:lstStyle/>
-          <a:p>
-            <a:r>
-              <a:rPr sz="1300" b="0" dirty="0">
-                <a:solidFill>
-                  <a:srgbClr val="1A1A2E"/>
-                </a:solidFill>
-              </a:rPr>
-              <a:t>The New Triffin Dilemma: stablecoins simultaneously deepen and </a:t>
-            </a:r>
-            <a:r>
-              <a:rPr sz="1300" b="0" dirty="0" err="1">
-                <a:solidFill>
-                  <a:srgbClr val="1A1A2E"/>
-                </a:solidFill>
-              </a:rPr>
-              <a:t>destabilise</a:t>
-            </a:r>
-            <a:r>
-              <a:rPr sz="1300" b="0" dirty="0">
-                <a:solidFill>
-                  <a:srgbClr val="1A1A2E"/>
-                </a:solidFill>
-              </a:rPr>
-              <a:t> US safe-asset markets. The same structural Treasury demand that amplifies the exorbitant privilege in normal times embeds a fragility that can rapidly reverse it during runs. Whether a stress episode triggers sovereign contagion or flight-to-safety depends entirely on one variable: L.</a:t>
-            </a:r>
+            <a:endParaRPr sz="1600" b="0">
+              <a:solidFill>
+                <a:srgbClr val="1A1A2E"/>
+              </a:solidFill>
+            </a:endParaRPr>
           </a:p>
         </p:txBody>
       </p:sp>
@@ -9726,7 +10495,6 @@
           <a:lstStyle/>
           <a:p>
             <a:pPr algn="ctr"/>
-            <a:endParaRPr/>
           </a:p>
         </p:txBody>
       </p:sp>
@@ -9761,6 +10529,11 @@
               </a:rPr>
               <a:t>Stablecoins help the US in normal times — and threaten it in stress. L is what separates the two.</a:t>
             </a:r>
+            <a:endParaRPr sz="1800" b="1">
+              <a:solidFill>
+                <a:srgbClr val="FFFFFF"/>
+              </a:solidFill>
+            </a:endParaRPr>
           </a:p>
         </p:txBody>
       </p:sp>
@@ -9799,27 +10572,21 @@
       </p:grpSpPr>
       <p:pic>
         <p:nvPicPr>
-          <p:cNvPr id="3" name="그림 2" descr="원, 그래픽, 스크린샷, 그래픽 디자인이(가) 표시된 사진&#10;&#10;자동 생성된 설명">
-            <a:extLst>
-              <a:ext uri="{FF2B5EF4-FFF2-40B4-BE49-F238E27FC236}">
-                <a16:creationId xmlns:a16="http://schemas.microsoft.com/office/drawing/2014/main" id="{F8B78E75-CD07-84B3-32B7-D313B42289F0}"/>
-              </a:ext>
-            </a:extLst>
-          </p:cNvPr>
+          <p:cNvPr id="3" name="그림 2" descr="원, 그래픽, 스크린샷, 그래픽 디자인이(가) 표시된 사진&#10;&#10;자동 생성된 설명"/>
           <p:cNvPicPr>
             <a:picLocks noChangeAspect="1"/>
           </p:cNvPicPr>
           <p:nvPr/>
         </p:nvPicPr>
         <p:blipFill>
-          <a:blip r:embed="rId3">
+          <a:blip r:embed="rId1">
             <a:lum bright="70000" contrast="-70000"/>
             <a:extLst>
               <a:ext uri="{BEBA8EAE-BF5A-486C-A8C5-ECC9F3942E4B}">
                 <a14:imgProps xmlns:a14="http://schemas.microsoft.com/office/drawing/2010/main">
-                  <a14:imgLayer r:embed="rId4">
+                  <a14:imgLayer r:embed="rId2">
                     <a14:imgEffect>
-                      <a14:artisticPhotocopy detail="2"/>
+                      <a14:artisticPhotocopy trans="30000" detail="2"/>
                     </a14:imgEffect>
                   </a14:imgLayer>
                 </a14:imgProps>
@@ -9911,14 +10678,14 @@
       </p:sp>
       <p:sp>
         <p:nvSpPr>
-          <p:cNvPr id="11" name="TextBox 10"/>
+          <p:cNvPr id="4" name="TextBox 10"/>
           <p:cNvSpPr txBox="1"/>
           <p:nvPr/>
         </p:nvSpPr>
         <p:spPr>
           <a:xfrm>
-            <a:off x="6466205" y="5560060"/>
-            <a:ext cx="5470525" cy="1198880"/>
+            <a:off x="6094095" y="5560060"/>
+            <a:ext cx="5842635" cy="1198880"/>
           </a:xfrm>
           <a:prstGeom prst="rect">
             <a:avLst/>
@@ -9939,6 +10706,11 @@
               </a:rPr>
               <a:t>Yonsei GSIS 2026-1 </a:t>
             </a:r>
+            <a:endParaRPr lang="en-US" altLang="ko-KR" sz="1800" b="1" dirty="0">
+              <a:solidFill>
+                <a:schemeClr val="bg1"/>
+              </a:solidFill>
+            </a:endParaRPr>
           </a:p>
           <a:p>
             <a:r>
@@ -9977,7 +10749,7 @@
                   <a:srgbClr val="FFFFFF"/>
                 </a:solidFill>
               </a:rPr>
-              <a:t>New Memebers - Please write your names here !</a:t>
+              <a:t>· Jade Zhu · Alexandre Godefroy · Baptiste Degand</a:t>
             </a:r>
             <a:endParaRPr lang="en-US" altLang="ko-KR" sz="1800" b="1" dirty="0">
               <a:solidFill>
@@ -10311,7 +11083,6 @@
       </a:style>
     </a:lnDef>
   </a:objectDefaults>
-  <a:extraClrSchemeLst/>
   <a:extLst>
     <a:ext uri="{05A4C25C-085E-4340-85A3-A5531E510DB2}">
       <thm15:themeFamily xmlns:thm15="http://schemas.microsoft.com/office/thememl/2012/main" name="Office Theme" id="{62F939B6-93AF-4DB8-9C6B-D6C7DFDC589F}" vid="{4A3C46E8-61CC-4603-A589-7422A47A8E4A}"/>
@@ -10592,7 +11363,6 @@
       </a:style>
     </a:lnDef>
   </a:objectDefaults>
-  <a:extraClrSchemeLst/>
   <a:extLst>
     <a:ext uri="{05A4C25C-085E-4340-85A3-A5531E510DB2}">
       <thm15:themeFamily xmlns:thm15="http://schemas.microsoft.com/office/thememl/2012/main" name="Office Theme" id="{62F939B6-93AF-4DB8-9C6B-D6C7DFDC589F}" vid="{4A3C46E8-61CC-4603-A589-7422A47A8E4A}"/>

</xml_diff>

<commit_message>
changed names in script
</commit_message>
<xml_diff>
--- a/presentations/0519_Stablecoin_Exorbitant_Privilege.pptx
+++ b/presentations/0519_Stablecoin_Exorbitant_Privilege.pptx
@@ -5,18 +5,18 @@
     <p:sldMasterId id="2147483648" r:id="rId1"/>
   </p:sldMasterIdLst>
   <p:notesMasterIdLst>
-    <p:notesMasterId r:id="rId4"/>
+    <p:notesMasterId r:id="rId11"/>
   </p:notesMasterIdLst>
   <p:sldIdLst>
-    <p:sldId id="256" r:id="rId3"/>
-    <p:sldId id="257" r:id="rId5"/>
-    <p:sldId id="258" r:id="rId6"/>
-    <p:sldId id="263" r:id="rId7"/>
-    <p:sldId id="259" r:id="rId8"/>
-    <p:sldId id="260" r:id="rId9"/>
-    <p:sldId id="261" r:id="rId10"/>
-    <p:sldId id="262" r:id="rId11"/>
-    <p:sldId id="265" r:id="rId12"/>
+    <p:sldId id="256" r:id="rId2"/>
+    <p:sldId id="257" r:id="rId3"/>
+    <p:sldId id="258" r:id="rId4"/>
+    <p:sldId id="263" r:id="rId5"/>
+    <p:sldId id="259" r:id="rId6"/>
+    <p:sldId id="260" r:id="rId7"/>
+    <p:sldId id="261" r:id="rId8"/>
+    <p:sldId id="262" r:id="rId9"/>
+    <p:sldId id="265" r:id="rId10"/>
   </p:sldIdLst>
   <p:sldSz cx="12188825" cy="6858000"/>
   <p:notesSz cx="6858000" cy="9144000"/>
@@ -304,13 +304,12 @@
             </a:r>
             <a:r>
               <a:rPr lang="en-US" dirty="0"/>
-              <a:t>Alexandre</a:t>
+              <a:t>Sara</a:t>
             </a:r>
             <a:r>
               <a:rPr dirty="0"/>
-              <a:t> — Title Slide]</a:t>
-            </a:r>
-            <a:endParaRPr dirty="0"/>
+              <a:t>— Title Slide]</a:t>
+            </a:r>
           </a:p>
           <a:p>
             <a:endParaRPr dirty="0"/>
@@ -328,7 +327,6 @@
               <a:rPr dirty="0"/>
               <a:t>e are presenting the second part of our research on stablecoins and the exorbitant privilege.</a:t>
             </a:r>
-            <a:endParaRPr dirty="0"/>
           </a:p>
           <a:p>
             <a:endParaRPr dirty="0"/>
@@ -414,9 +412,16 @@
           <a:p>
             <a:r>
               <a:rPr dirty="0"/>
-              <a:t>[ALEXANDRE — Roadmap]</a:t>
-            </a:r>
-            <a:endParaRPr dirty="0"/>
+              <a:t>[</a:t>
+            </a:r>
+            <a:r>
+              <a:rPr lang="en-US" dirty="0"/>
+              <a:t>Sara</a:t>
+            </a:r>
+            <a:r>
+              <a:rPr dirty="0"/>
+              <a:t> — Roadmap]</a:t>
+            </a:r>
           </a:p>
           <a:p>
             <a:endParaRPr dirty="0"/>
@@ -426,7 +431,6 @@
               <a:rPr dirty="0"/>
               <a:t>This slide gives you a quick map of today's presentation.</a:t>
             </a:r>
-            <a:endParaRPr dirty="0"/>
           </a:p>
           <a:p>
             <a:endParaRPr dirty="0"/>
@@ -448,7 +452,6 @@
               <a:rPr lang="en-US" dirty="0"/>
               <a:t>.</a:t>
             </a:r>
-            <a:endParaRPr lang="en-US" dirty="0"/>
           </a:p>
           <a:p>
             <a:endParaRPr dirty="0"/>
@@ -458,7 +461,6 @@
               <a:rPr dirty="0"/>
               <a:t>Today we add three new things.</a:t>
             </a:r>
-            <a:endParaRPr dirty="0"/>
           </a:p>
           <a:p>
             <a:endParaRPr dirty="0"/>
@@ -468,7 +470,6 @@
               <a:rPr dirty="0"/>
               <a:t>First, a Literature Gap slide — we will show exactly where our paper fits in the existing academic literature and why what we do has not been done before.</a:t>
             </a:r>
-            <a:endParaRPr dirty="0"/>
           </a:p>
           <a:p>
             <a:endParaRPr dirty="0"/>
@@ -478,7 +479,6 @@
               <a:rPr dirty="0"/>
               <a:t>Second, Result 3 — the buffer-conditioned event study. This is where we move from monthly correlations to specific crisis events to show that our mechanism is not just statistical but actually causal.</a:t>
             </a:r>
-            <a:endParaRPr dirty="0"/>
           </a:p>
           <a:p>
             <a:endParaRPr dirty="0"/>
@@ -488,7 +488,6 @@
               <a:rPr dirty="0"/>
               <a:t>Third, two new contributions responding directly to our professor's feedback: an asymmetric effects analysis that splits supply growth from supply contraction, and a reframed policy implication that is more intellectually honest about what our data can and cannot claim.</a:t>
             </a:r>
-            <a:endParaRPr dirty="0"/>
           </a:p>
         </p:txBody>
       </p:sp>
@@ -562,13 +561,12 @@
             </a:r>
             <a:r>
               <a:rPr lang="en-US" dirty="0"/>
-              <a:t>Oybek</a:t>
+              <a:t>Alex</a:t>
             </a:r>
             <a:r>
               <a:rPr dirty="0"/>
               <a:t>— Literature Gap]</a:t>
             </a:r>
-            <a:endParaRPr dirty="0"/>
           </a:p>
           <a:p>
             <a:endParaRPr dirty="0"/>
@@ -578,7 +576,6 @@
               <a:rPr dirty="0"/>
               <a:t>This slide answers the question: what does the existing literature do, and where exactly does our paper add something new?</a:t>
             </a:r>
-            <a:endParaRPr dirty="0"/>
           </a:p>
           <a:p>
             <a:endParaRPr dirty="0"/>
@@ -588,7 +585,6 @@
               <a:rPr dirty="0"/>
               <a:t>On the left panel, you see three papers.</a:t>
             </a:r>
-            <a:endParaRPr dirty="0"/>
           </a:p>
           <a:p>
             <a:endParaRPr dirty="0"/>
@@ -606,7 +602,6 @@
               <a:rPr dirty="0"/>
               <a:t> and Ahmed — a Bank for International Settlements working paper published in 2025. This is the closest paper to ours. They find that stablecoin inflows compress 3-month Treasury bill yields by about 2.5 to 3.5 basis points. They also have a state-dependent interaction term — but their conditioning variable is the supply of Treasury bills in the market, not the liquid reserves held by stablecoin issuers. They also use yield levels as their dependent variable. We use the OIS-Treasury spread, which is a cleaner measure because it isolates demand-side effects from supply-side noise.</a:t>
             </a:r>
-            <a:endParaRPr dirty="0"/>
           </a:p>
           <a:p>
             <a:endParaRPr dirty="0"/>
@@ -616,7 +611,6 @@
               <a:rPr dirty="0"/>
               <a:t>The second paper is Gorton and Zhang, 2023. They draw the analogy between stablecoins and the wildcat banks of the nineteenth century — unregulated private banks that issued their own notes. They document run risk thoroughly, but they do not connect reserve composition to Treasury market dynamics. They do not run the regression we run.</a:t>
             </a:r>
-            <a:endParaRPr dirty="0"/>
           </a:p>
           <a:p>
             <a:endParaRPr dirty="0"/>
@@ -626,7 +620,6 @@
               <a:rPr dirty="0"/>
               <a:t>The third paper is Lyons and Viswanath-Natraj, 2023. They study how stablecoin pegs are maintained through arbitrage — it's a paper about the exchange rate mechanics. They do not connect to sovereign debt markets at all.</a:t>
             </a:r>
-            <a:endParaRPr dirty="0"/>
           </a:p>
           <a:p>
             <a:endParaRPr dirty="0"/>
@@ -636,7 +629,6 @@
               <a:rPr dirty="0"/>
               <a:t>On the right panel, you see what we contribute that none of these papers do. We are the first to jointly include the stablecoin issuance variable AND the issuer's liquid buffer as a moderating variable AND use the OIS-Treasury spread as the outcome. We are also the first to estimate a nonlinear threshold — L* equals 13% — using the Hansen 2000 method. And we are the first to test whether the effect is asymmetric between growth and contraction periods.</a:t>
             </a:r>
-            <a:endParaRPr dirty="0"/>
           </a:p>
           <a:p>
             <a:endParaRPr dirty="0"/>
@@ -646,7 +638,6 @@
               <a:rPr dirty="0"/>
               <a:t>The quote at the bottom summarizes the gap in one sentence.</a:t>
             </a:r>
-            <a:endParaRPr dirty="0"/>
           </a:p>
         </p:txBody>
       </p:sp>
@@ -720,13 +711,12 @@
             </a:r>
             <a:r>
               <a:rPr lang="en-US" dirty="0"/>
-              <a:t>Oybek</a:t>
+              <a:t>Alex</a:t>
             </a:r>
             <a:r>
               <a:rPr dirty="0"/>
               <a:t> — Literature Gap]</a:t>
             </a:r>
-            <a:endParaRPr dirty="0"/>
           </a:p>
           <a:p>
             <a:endParaRPr dirty="0"/>
@@ -736,7 +726,6 @@
               <a:rPr dirty="0"/>
               <a:t>This slide answers the question: what does the existing literature do, and where exactly does our paper add something new?</a:t>
             </a:r>
-            <a:endParaRPr dirty="0"/>
           </a:p>
           <a:p>
             <a:endParaRPr dirty="0"/>
@@ -746,7 +735,6 @@
               <a:rPr dirty="0"/>
               <a:t>On the left panel, you see three papers.</a:t>
             </a:r>
-            <a:endParaRPr dirty="0"/>
           </a:p>
           <a:p>
             <a:endParaRPr dirty="0"/>
@@ -764,7 +752,6 @@
               <a:rPr dirty="0"/>
               <a:t> and Ahmed — a Bank for International Settlements working paper published in 2025. This is the closest paper to ours. They find that stablecoin inflows compress 3-month Treasury bill yields by about 2.5 to 3.5 basis points. They also have a state-dependent interaction term — but their conditioning variable is the supply of Treasury bills in the market, not the liquid reserves held by stablecoin issuers. They also use yield levels as their dependent variable. We use the OIS-Treasury spread, which is a cleaner measure because it isolates demand-side effects from supply-side noise.</a:t>
             </a:r>
-            <a:endParaRPr dirty="0"/>
           </a:p>
           <a:p>
             <a:endParaRPr dirty="0"/>
@@ -774,7 +761,6 @@
               <a:rPr dirty="0"/>
               <a:t>The second paper is Gorton and Zhang, 2023. They draw the analogy between stablecoins and the wildcat banks of the nineteenth century — unregulated private banks that issued their own notes. They document run risk thoroughly, but they do not connect reserve composition to Treasury market dynamics. They do not run the regression we run.</a:t>
             </a:r>
-            <a:endParaRPr dirty="0"/>
           </a:p>
           <a:p>
             <a:endParaRPr dirty="0"/>
@@ -784,7 +770,6 @@
               <a:rPr dirty="0"/>
               <a:t>The third paper is Lyons and Viswanath-Natraj, 2023. They study how stablecoin pegs are maintained through arbitrage — it's a paper about the exchange rate mechanics. They do not connect to sovereign debt markets at all.</a:t>
             </a:r>
-            <a:endParaRPr dirty="0"/>
           </a:p>
           <a:p>
             <a:endParaRPr dirty="0"/>
@@ -794,7 +779,6 @@
               <a:rPr dirty="0"/>
               <a:t>On the right panel, you see what we contribute that none of these papers do. We are the first to jointly include the stablecoin issuance variable AND the issuer's liquid buffer as a moderating variable AND use the OIS-Treasury spread as the outcome. We are also the first to estimate a nonlinear threshold — L* equals 13% — using the Hansen 2000 method. And we are the first to test whether the effect is asymmetric between growth and contraction periods.</a:t>
             </a:r>
-            <a:endParaRPr dirty="0"/>
           </a:p>
           <a:p>
             <a:endParaRPr dirty="0"/>
@@ -804,7 +788,6 @@
               <a:rPr dirty="0"/>
               <a:t>The quote at the bottom summarizes the gap in one sentence.</a:t>
             </a:r>
-            <a:endParaRPr dirty="0"/>
           </a:p>
         </p:txBody>
       </p:sp>
@@ -876,7 +859,6 @@
               <a:rPr dirty="0"/>
               <a:t>[JADE — Result 3: Buffer-Conditioned Event Study]</a:t>
             </a:r>
-            <a:endParaRPr dirty="0"/>
           </a:p>
           <a:p>
             <a:endParaRPr dirty="0"/>
@@ -886,7 +868,6 @@
               <a:rPr dirty="0"/>
               <a:t>Thank you Alexandre. I will now present Result 3 — the event study.</a:t>
             </a:r>
-            <a:endParaRPr dirty="0"/>
           </a:p>
           <a:p>
             <a:endParaRPr dirty="0"/>
@@ -896,7 +877,6 @@
               <a:rPr dirty="0"/>
               <a:t>Up until now, our results have been based on monthly regressions across the full sample. That tells us about average relationships. But it does not tell us whether the buffer mechanism actually works in the moments that matter most — during a crisis.</a:t>
             </a:r>
-            <a:endParaRPr dirty="0"/>
           </a:p>
           <a:p>
             <a:endParaRPr dirty="0"/>
@@ -906,7 +886,6 @@
               <a:rPr dirty="0"/>
               <a:t>The event study fixes that. We take three real-world stress episodes and ask: what happened to the OIS-Treasury spread in the days immediately following each event? And does the answer depend on how large the liquid buffer was at the time?</a:t>
             </a:r>
-            <a:endParaRPr dirty="0"/>
           </a:p>
           <a:p>
             <a:endParaRPr dirty="0"/>
@@ -916,7 +895,6 @@
               <a:rPr dirty="0"/>
               <a:t>We measure the Cumulative Abnormal Return — or CAR — on the spread. A positive CAR means the spread spiked upward, which means Treasury yields rose relative to overnight rates — a sign that stablecoin issuers were forced to sell T-bills, increasing their supply and pushing prices down.</a:t>
             </a:r>
-            <a:endParaRPr dirty="0"/>
           </a:p>
           <a:p>
             <a:endParaRPr dirty="0"/>
@@ -926,7 +904,6 @@
               <a:rPr dirty="0"/>
               <a:t>Now look at the table on the right.</a:t>
             </a:r>
-            <a:endParaRPr dirty="0"/>
           </a:p>
           <a:p>
             <a:endParaRPr dirty="0"/>
@@ -944,7 +921,6 @@
               <a:rPr dirty="0"/>
               <a:t> shortly after — both happened when the liquid buffer was LOW. The CAR in both cases is strongly positive: plus 8.9 and plus 8.8 basis points, both significant at the 1% level with t-statistics above 30. This is a large and unambiguous effect. Issuers did not have enough cash to absorb redemptions, so they sold T-bills, and the spread spiked.</a:t>
             </a:r>
-            <a:endParaRPr dirty="0"/>
           </a:p>
           <a:p>
             <a:endParaRPr dirty="0"/>
@@ -954,7 +930,6 @@
               <a:rPr dirty="0"/>
               <a:t>The third event — the USDC and SVB failure in March 2023 — is where the result becomes really interesting. By early 2023, the liquid buffer had recovered above the 13% threshold. The CAR is NEGATIVE: minus 18 basis points. The spread compressed instead of spiking. Why? Because Circle had enough cash to absorb redemptions without touching its T-bill holdings. What investors saw instead was a flight-to-safety into Treasuries — the usual response to a financial shock when the stablecoin system is not forced to liquidate.</a:t>
             </a:r>
-            <a:endParaRPr dirty="0"/>
           </a:p>
           <a:p>
             <a:endParaRPr dirty="0"/>
@@ -964,7 +939,6 @@
               <a:rPr dirty="0"/>
               <a:t>The difference between these two regimes is statistically confirmed: t-statistic of 15.22, p-value below 0.001.</a:t>
             </a:r>
-            <a:endParaRPr dirty="0"/>
           </a:p>
           <a:p>
             <a:endParaRPr dirty="0"/>
@@ -974,7 +948,6 @@
               <a:rPr dirty="0"/>
               <a:t>This is the cleanest evidence we have that the buffer is not just a number — it is what separates a crisis that spreads to sovereign debt markets from one that does not.</a:t>
             </a:r>
-            <a:endParaRPr dirty="0"/>
           </a:p>
         </p:txBody>
       </p:sp>
@@ -1046,7 +1019,6 @@
               <a:rPr dirty="0"/>
               <a:t>[JADE — Asymmetric Effects]</a:t>
             </a:r>
-            <a:endParaRPr dirty="0"/>
           </a:p>
           <a:p>
             <a:endParaRPr dirty="0"/>
@@ -1056,7 +1028,6 @@
               <a:rPr dirty="0"/>
               <a:t>This slide presents a new result that responds directly to our professor's question from last week: why is the buffer interaction term positive?</a:t>
             </a:r>
-            <a:endParaRPr dirty="0"/>
           </a:p>
           <a:p>
             <a:endParaRPr dirty="0"/>
@@ -1074,7 +1045,6 @@
               <a:rPr dirty="0"/>
               <a:t> is positive and equal to 49.17. The intuition our professor questioned was: if a higher buffer means the issuer holds more cash and fewer T-bills, shouldn't a bigger buffer reduce the spread compression during supply growth — because they are buying fewer T-bills? So why is the sign positive?</a:t>
             </a:r>
-            <a:endParaRPr dirty="0"/>
           </a:p>
           <a:p>
             <a:endParaRPr dirty="0"/>
@@ -1084,7 +1054,6 @@
               <a:rPr dirty="0"/>
               <a:t>The answer comes from separating supply growth from supply contraction. That is what this slide shows.</a:t>
             </a:r>
-            <a:endParaRPr dirty="0"/>
           </a:p>
           <a:p>
             <a:endParaRPr dirty="0"/>
@@ -1094,7 +1063,6 @@
               <a:rPr dirty="0"/>
               <a:t>On the left, in red, are the 32 months in our sample when stablecoin supply was growing. The effect of supply growth on the spread is negative — more supply means more T-bill buying, which compresses spreads — but the coefficient is only minus 1.79 and it is not statistically significant. The R-squared is 0.33. During growth periods, the buffer does not matter much because the dynamic is orderly. Issuers buy T-bills gradually as they mint new tokens.</a:t>
             </a:r>
-            <a:endParaRPr dirty="0"/>
           </a:p>
           <a:p>
             <a:endParaRPr dirty="0"/>
@@ -1104,7 +1072,6 @@
               <a:rPr dirty="0"/>
               <a:t>On the right, in green, are the 19 months when supply was contracting. Here, β₁ jumps to minus 12.68 — seven times larger — and it is statistically significant at the 5% level. The R-squared jumps to 0.73. The model explains far more of the variation during stress periods than calm ones. And the buffer interaction term is large and positive — plus 78.57 — meaning a higher buffer significantly dampens the spread spike during redemption periods.</a:t>
             </a:r>
-            <a:endParaRPr dirty="0"/>
           </a:p>
           <a:p>
             <a:endParaRPr dirty="0"/>
@@ -1114,7 +1081,6 @@
               <a:rPr dirty="0"/>
               <a:t>So the answer to the professor's question is this: β₄ is positive because the dominant effect of the buffer is during contractions — where it prevents forced T-bill liquidation — not during growth. The combined positive sign in the main regression reflects this asymmetry. The buffer absorbs redemption shocks. That is the mechanism our paper is about.</a:t>
             </a:r>
-            <a:endParaRPr dirty="0"/>
           </a:p>
           <a:p>
             <a:endParaRPr dirty="0"/>
@@ -1124,7 +1090,6 @@
               <a:rPr dirty="0"/>
               <a:t>Baptiste will now close with the policy implications and conclusion.</a:t>
             </a:r>
-            <a:endParaRPr dirty="0"/>
           </a:p>
         </p:txBody>
       </p:sp>
@@ -1196,7 +1161,6 @@
               <a:rPr dirty="0"/>
               <a:t>[BAPTISTE — Policy Implication]</a:t>
             </a:r>
-            <a:endParaRPr dirty="0"/>
           </a:p>
           <a:p>
             <a:endParaRPr dirty="0"/>
@@ -1206,7 +1170,6 @@
               <a:rPr dirty="0"/>
               <a:t>Thank you Jade. Now let me turn to what our findings mean for policy.</a:t>
             </a:r>
-            <a:endParaRPr dirty="0"/>
           </a:p>
           <a:p>
             <a:endParaRPr dirty="0"/>
@@ -1216,7 +1179,6 @@
               <a:rPr dirty="0"/>
               <a:t>Our threshold regression using the Hansen 2000 method identified L* equals 13% as a statistical break point. Below 13% — which describes 38 out of our 51 sample months — stablecoin activity significantly amplifies Treasury market volatility during stress. Above 13% — the remaining 13 months — the transmission channel is attenuated and runs are absorbed internally.</a:t>
             </a:r>
-            <a:endParaRPr dirty="0"/>
           </a:p>
           <a:p>
             <a:endParaRPr dirty="0"/>
@@ -1226,7 +1188,6 @@
               <a:rPr dirty="0"/>
               <a:t>One thing our professor pointed out last week, and which we want to address directly: our data tells us WHERE the break is. It does not tell us what is OPTIMAL. These are two different things.</a:t>
             </a:r>
-            <a:endParaRPr dirty="0"/>
           </a:p>
           <a:p>
             <a:endParaRPr dirty="0"/>
@@ -1236,7 +1197,6 @@
               <a:rPr dirty="0"/>
               <a:t>Finding a break point at 13% is like finding that bridge failures become much more likely when material stress exceeds a certain level — it tells you something important about the threshold, but it does not tell you what the ideal engineering standard should be. A full welfare analysis — weighing the cost of holding more liquid reserves against the benefit of reduced systemic risk — would require a structural model that goes beyond this paper.</a:t>
             </a:r>
-            <a:endParaRPr dirty="0"/>
           </a:p>
           <a:p>
             <a:endParaRPr dirty="0"/>
@@ -1246,7 +1206,6 @@
               <a:rPr dirty="0"/>
               <a:t>What we are proposing is more modest: that regulators consider 13 to 15% as a minimum empirical floor when designing reserve requirements for fiat-collateralized stablecoin issuers above a systemically relevant size.</a:t>
             </a:r>
-            <a:endParaRPr dirty="0"/>
           </a:p>
           <a:p>
             <a:endParaRPr dirty="0"/>
@@ -1256,7 +1215,6 @@
               <a:rPr dirty="0"/>
               <a:t>The caveat on the bottom right is important. We put it there deliberately. We are acknowledging the limit of what our data can claim, which is exactly the kind of intellectual honesty that distinguishes a research contribution from a policy prescription.</a:t>
             </a:r>
-            <a:endParaRPr dirty="0"/>
           </a:p>
         </p:txBody>
       </p:sp>
@@ -1328,7 +1286,6 @@
               <a:rPr dirty="0"/>
               <a:t>[BAPTISTE — Conclusion]</a:t>
             </a:r>
-            <a:endParaRPr dirty="0"/>
           </a:p>
           <a:p>
             <a:endParaRPr dirty="0"/>
@@ -1338,7 +1295,6 @@
               <a:rPr dirty="0"/>
               <a:t>Let me now bring everything together.</a:t>
             </a:r>
-            <a:endParaRPr dirty="0"/>
           </a:p>
           <a:p>
             <a:endParaRPr dirty="0"/>
@@ -1348,7 +1304,6 @@
               <a:rPr dirty="0"/>
               <a:t>Our paper documents three results that form a coherent story.</a:t>
             </a:r>
-            <a:endParaRPr dirty="0"/>
           </a:p>
           <a:p>
             <a:endParaRPr dirty="0"/>
@@ -1358,7 +1313,6 @@
               <a:rPr dirty="0"/>
               <a:t>The first result — the green box on the left — is the privilege amplification channel. When stablecoin supply grows by 1%, the OIS-Treasury spread compresses by about 6 to 8 basis points. Tether and Circle are mechanically buying US Treasury bills to back their tokens. This deepens demand for safe US assets and amplifies the exorbitant privilege that the United States already enjoys by issuing the world's reserve currency.</a:t>
             </a:r>
-            <a:endParaRPr dirty="0"/>
           </a:p>
           <a:p>
             <a:endParaRPr dirty="0"/>
@@ -1368,7 +1322,6 @@
               <a:rPr dirty="0"/>
               <a:t>The second result — the blue box in the middle — is the safety threshold. Using the Hansen 2000 threshold regression, we identify L* equals 13% as the break point. Below this level, stablecoin activity disrupts Treasury markets during stress. Above it, redemptions are absorbed internally and the market is undisturbed.</a:t>
             </a:r>
-            <a:endParaRPr dirty="0"/>
           </a:p>
           <a:p>
             <a:endParaRPr dirty="0"/>
@@ -1386,7 +1339,6 @@
               <a:rPr dirty="0"/>
               <a:t> in 2022, when buffers were low, spreads spiked by nearly 9 basis points. During the SVB event in 2023, when buffers had recovered, spreads compressed by 18 basis points — a flight-to-safety instead of a forced liquidation. The buffer determined the outcome.</a:t>
             </a:r>
-            <a:endParaRPr dirty="0"/>
           </a:p>
           <a:p>
             <a:endParaRPr dirty="0"/>
@@ -1396,7 +1348,6 @@
               <a:rPr dirty="0"/>
               <a:t>This brings us to the central argument of our paper, which we call the New Triffin Dilemma.</a:t>
             </a:r>
-            <a:endParaRPr dirty="0"/>
           </a:p>
           <a:p>
             <a:endParaRPr dirty="0"/>
@@ -1406,7 +1357,6 @@
               <a:rPr dirty="0"/>
               <a:t>Robert Triffin observed in 1960 that the US dollar's role as the world's reserve currency created an inherent contradiction — supplying enough safe assets to meet global demand requires running current account deficits that eventually undermine confidence in the dollar itself. The system depends on the very condition that makes it unsustainable.</a:t>
             </a:r>
-            <a:endParaRPr dirty="0"/>
           </a:p>
           <a:p>
             <a:endParaRPr dirty="0"/>
@@ -1416,7 +1366,6 @@
               <a:rPr dirty="0"/>
               <a:t>Our paper shows that stablecoins create an analogous dilemma at the private level. The same structural Treasury demand that amplifies American borrowing privilege in normal times embeds a fragility that can rapidly reverse it during runs. Whether a stress episode leads to sovereign contagion or flight-to-safety depends entirely on one variable: L — the liquid buffer.</a:t>
             </a:r>
-            <a:endParaRPr dirty="0"/>
           </a:p>
         </p:txBody>
       </p:sp>
@@ -1549,7 +1498,6 @@
               <a:rPr lang="en-US"/>
               <a:t>Click to edit Master title style</a:t>
             </a:r>
-            <a:endParaRPr lang="en-US"/>
           </a:p>
         </p:txBody>
       </p:sp>
@@ -1668,7 +1616,6 @@
               <a:rPr lang="en-US"/>
               <a:t>Click to edit Master subtitle style</a:t>
             </a:r>
-            <a:endParaRPr lang="en-US"/>
           </a:p>
         </p:txBody>
       </p:sp>
@@ -1689,6 +1636,7 @@
           <a:p>
             <a:fld id="{5BCAD085-E8A6-8845-BD4E-CB4CCA059FC4}" type="datetimeFigureOut">
               <a:rPr lang="en-US" smtClean="0"/>
+              <a:t>5/18/26</a:t>
             </a:fld>
             <a:endParaRPr lang="en-US"/>
           </a:p>
@@ -1730,6 +1678,7 @@
           <a:p>
             <a:fld id="{C1FF6DA9-008F-8B48-92A6-B652298478BF}" type="slidenum">
               <a:rPr lang="en-US" smtClean="0"/>
+              <a:t>‹#›</a:t>
             </a:fld>
             <a:endParaRPr lang="en-US"/>
           </a:p>
@@ -1779,7 +1728,6 @@
               <a:rPr lang="en-US"/>
               <a:t>Click to edit Master title style</a:t>
             </a:r>
-            <a:endParaRPr lang="en-US"/>
           </a:p>
         </p:txBody>
       </p:sp>
@@ -1803,7 +1751,6 @@
               <a:rPr lang="en-US"/>
               <a:t>Click to edit Master text styles</a:t>
             </a:r>
-            <a:endParaRPr lang="en-US"/>
           </a:p>
           <a:p>
             <a:pPr lvl="1"/>
@@ -1811,7 +1758,6 @@
               <a:rPr lang="en-US"/>
               <a:t>Second level</a:t>
             </a:r>
-            <a:endParaRPr lang="en-US"/>
           </a:p>
           <a:p>
             <a:pPr lvl="2"/>
@@ -1819,7 +1765,6 @@
               <a:rPr lang="en-US"/>
               <a:t>Third level</a:t>
             </a:r>
-            <a:endParaRPr lang="en-US"/>
           </a:p>
           <a:p>
             <a:pPr lvl="3"/>
@@ -1827,7 +1772,6 @@
               <a:rPr lang="en-US"/>
               <a:t>Fourth level</a:t>
             </a:r>
-            <a:endParaRPr lang="en-US"/>
           </a:p>
           <a:p>
             <a:pPr lvl="4"/>
@@ -1835,7 +1779,6 @@
               <a:rPr lang="en-US"/>
               <a:t>Fifth level</a:t>
             </a:r>
-            <a:endParaRPr lang="en-US"/>
           </a:p>
         </p:txBody>
       </p:sp>
@@ -1856,6 +1799,7 @@
           <a:p>
             <a:fld id="{5BCAD085-E8A6-8845-BD4E-CB4CCA059FC4}" type="datetimeFigureOut">
               <a:rPr lang="en-US" smtClean="0"/>
+              <a:t>5/18/26</a:t>
             </a:fld>
             <a:endParaRPr lang="en-US"/>
           </a:p>
@@ -1897,6 +1841,7 @@
           <a:p>
             <a:fld id="{C1FF6DA9-008F-8B48-92A6-B652298478BF}" type="slidenum">
               <a:rPr lang="en-US" smtClean="0"/>
+              <a:t>‹#›</a:t>
             </a:fld>
             <a:endParaRPr lang="en-US"/>
           </a:p>
@@ -1951,7 +1896,6 @@
               <a:rPr lang="en-US"/>
               <a:t>Click to edit Master title style</a:t>
             </a:r>
-            <a:endParaRPr lang="en-US"/>
           </a:p>
         </p:txBody>
       </p:sp>
@@ -1980,7 +1924,6 @@
               <a:rPr lang="en-US"/>
               <a:t>Click to edit Master text styles</a:t>
             </a:r>
-            <a:endParaRPr lang="en-US"/>
           </a:p>
           <a:p>
             <a:pPr lvl="1"/>
@@ -1988,7 +1931,6 @@
               <a:rPr lang="en-US"/>
               <a:t>Second level</a:t>
             </a:r>
-            <a:endParaRPr lang="en-US"/>
           </a:p>
           <a:p>
             <a:pPr lvl="2"/>
@@ -1996,7 +1938,6 @@
               <a:rPr lang="en-US"/>
               <a:t>Third level</a:t>
             </a:r>
-            <a:endParaRPr lang="en-US"/>
           </a:p>
           <a:p>
             <a:pPr lvl="3"/>
@@ -2004,7 +1945,6 @@
               <a:rPr lang="en-US"/>
               <a:t>Fourth level</a:t>
             </a:r>
-            <a:endParaRPr lang="en-US"/>
           </a:p>
           <a:p>
             <a:pPr lvl="4"/>
@@ -2012,7 +1952,6 @@
               <a:rPr lang="en-US"/>
               <a:t>Fifth level</a:t>
             </a:r>
-            <a:endParaRPr lang="en-US"/>
           </a:p>
         </p:txBody>
       </p:sp>
@@ -2033,6 +1972,7 @@
           <a:p>
             <a:fld id="{5BCAD085-E8A6-8845-BD4E-CB4CCA059FC4}" type="datetimeFigureOut">
               <a:rPr lang="en-US" smtClean="0"/>
+              <a:t>5/18/26</a:t>
             </a:fld>
             <a:endParaRPr lang="en-US"/>
           </a:p>
@@ -2074,6 +2014,7 @@
           <a:p>
             <a:fld id="{C1FF6DA9-008F-8B48-92A6-B652298478BF}" type="slidenum">
               <a:rPr lang="en-US" smtClean="0"/>
+              <a:t>‹#›</a:t>
             </a:fld>
             <a:endParaRPr lang="en-US"/>
           </a:p>
@@ -2123,7 +2064,6 @@
               <a:rPr lang="en-US"/>
               <a:t>Click to edit Master title style</a:t>
             </a:r>
-            <a:endParaRPr lang="en-US"/>
           </a:p>
         </p:txBody>
       </p:sp>
@@ -2147,7 +2087,6 @@
               <a:rPr lang="en-US"/>
               <a:t>Click to edit Master text styles</a:t>
             </a:r>
-            <a:endParaRPr lang="en-US"/>
           </a:p>
           <a:p>
             <a:pPr lvl="1"/>
@@ -2155,7 +2094,6 @@
               <a:rPr lang="en-US"/>
               <a:t>Second level</a:t>
             </a:r>
-            <a:endParaRPr lang="en-US"/>
           </a:p>
           <a:p>
             <a:pPr lvl="2"/>
@@ -2163,7 +2101,6 @@
               <a:rPr lang="en-US"/>
               <a:t>Third level</a:t>
             </a:r>
-            <a:endParaRPr lang="en-US"/>
           </a:p>
           <a:p>
             <a:pPr lvl="3"/>
@@ -2171,7 +2108,6 @@
               <a:rPr lang="en-US"/>
               <a:t>Fourth level</a:t>
             </a:r>
-            <a:endParaRPr lang="en-US"/>
           </a:p>
           <a:p>
             <a:pPr lvl="4"/>
@@ -2179,7 +2115,6 @@
               <a:rPr lang="en-US"/>
               <a:t>Fifth level</a:t>
             </a:r>
-            <a:endParaRPr lang="en-US"/>
           </a:p>
         </p:txBody>
       </p:sp>
@@ -2200,6 +2135,7 @@
           <a:p>
             <a:fld id="{5BCAD085-E8A6-8845-BD4E-CB4CCA059FC4}" type="datetimeFigureOut">
               <a:rPr lang="en-US" smtClean="0"/>
+              <a:t>5/18/26</a:t>
             </a:fld>
             <a:endParaRPr lang="en-US"/>
           </a:p>
@@ -2241,6 +2177,7 @@
           <a:p>
             <a:fld id="{C1FF6DA9-008F-8B48-92A6-B652298478BF}" type="slidenum">
               <a:rPr lang="en-US" smtClean="0"/>
+              <a:t>‹#›</a:t>
             </a:fld>
             <a:endParaRPr lang="en-US"/>
           </a:p>
@@ -2299,7 +2236,6 @@
               <a:rPr lang="en-US"/>
               <a:t>Click to edit Master title style</a:t>
             </a:r>
-            <a:endParaRPr lang="en-US"/>
           </a:p>
         </p:txBody>
       </p:sp>
@@ -2419,7 +2355,6 @@
               <a:rPr lang="en-US"/>
               <a:t>Click to edit Master text styles</a:t>
             </a:r>
-            <a:endParaRPr lang="en-US"/>
           </a:p>
         </p:txBody>
       </p:sp>
@@ -2440,6 +2375,7 @@
           <a:p>
             <a:fld id="{5BCAD085-E8A6-8845-BD4E-CB4CCA059FC4}" type="datetimeFigureOut">
               <a:rPr lang="en-US" smtClean="0"/>
+              <a:t>5/18/26</a:t>
             </a:fld>
             <a:endParaRPr lang="en-US"/>
           </a:p>
@@ -2481,6 +2417,7 @@
           <a:p>
             <a:fld id="{C1FF6DA9-008F-8B48-92A6-B652298478BF}" type="slidenum">
               <a:rPr lang="en-US" smtClean="0"/>
+              <a:t>‹#›</a:t>
             </a:fld>
             <a:endParaRPr lang="en-US"/>
           </a:p>
@@ -2530,7 +2467,6 @@
               <a:rPr lang="en-US"/>
               <a:t>Click to edit Master title style</a:t>
             </a:r>
-            <a:endParaRPr lang="en-US"/>
           </a:p>
         </p:txBody>
       </p:sp>
@@ -2587,7 +2523,6 @@
               <a:rPr lang="en-US"/>
               <a:t>Click to edit Master text styles</a:t>
             </a:r>
-            <a:endParaRPr lang="en-US"/>
           </a:p>
           <a:p>
             <a:pPr lvl="1"/>
@@ -2595,7 +2530,6 @@
               <a:rPr lang="en-US"/>
               <a:t>Second level</a:t>
             </a:r>
-            <a:endParaRPr lang="en-US"/>
           </a:p>
           <a:p>
             <a:pPr lvl="2"/>
@@ -2603,7 +2537,6 @@
               <a:rPr lang="en-US"/>
               <a:t>Third level</a:t>
             </a:r>
-            <a:endParaRPr lang="en-US"/>
           </a:p>
           <a:p>
             <a:pPr lvl="3"/>
@@ -2611,7 +2544,6 @@
               <a:rPr lang="en-US"/>
               <a:t>Fourth level</a:t>
             </a:r>
-            <a:endParaRPr lang="en-US"/>
           </a:p>
           <a:p>
             <a:pPr lvl="4"/>
@@ -2619,7 +2551,6 @@
               <a:rPr lang="en-US"/>
               <a:t>Fifth level</a:t>
             </a:r>
-            <a:endParaRPr lang="en-US"/>
           </a:p>
         </p:txBody>
       </p:sp>
@@ -2676,7 +2607,6 @@
               <a:rPr lang="en-US"/>
               <a:t>Click to edit Master text styles</a:t>
             </a:r>
-            <a:endParaRPr lang="en-US"/>
           </a:p>
           <a:p>
             <a:pPr lvl="1"/>
@@ -2684,7 +2614,6 @@
               <a:rPr lang="en-US"/>
               <a:t>Second level</a:t>
             </a:r>
-            <a:endParaRPr lang="en-US"/>
           </a:p>
           <a:p>
             <a:pPr lvl="2"/>
@@ -2692,7 +2621,6 @@
               <a:rPr lang="en-US"/>
               <a:t>Third level</a:t>
             </a:r>
-            <a:endParaRPr lang="en-US"/>
           </a:p>
           <a:p>
             <a:pPr lvl="3"/>
@@ -2700,7 +2628,6 @@
               <a:rPr lang="en-US"/>
               <a:t>Fourth level</a:t>
             </a:r>
-            <a:endParaRPr lang="en-US"/>
           </a:p>
           <a:p>
             <a:pPr lvl="4"/>
@@ -2708,7 +2635,6 @@
               <a:rPr lang="en-US"/>
               <a:t>Fifth level</a:t>
             </a:r>
-            <a:endParaRPr lang="en-US"/>
           </a:p>
         </p:txBody>
       </p:sp>
@@ -2729,6 +2655,7 @@
           <a:p>
             <a:fld id="{5BCAD085-E8A6-8845-BD4E-CB4CCA059FC4}" type="datetimeFigureOut">
               <a:rPr lang="en-US" smtClean="0"/>
+              <a:t>5/18/26</a:t>
             </a:fld>
             <a:endParaRPr lang="en-US"/>
           </a:p>
@@ -2770,6 +2697,7 @@
           <a:p>
             <a:fld id="{C1FF6DA9-008F-8B48-92A6-B652298478BF}" type="slidenum">
               <a:rPr lang="en-US" smtClean="0"/>
+              <a:t>‹#›</a:t>
             </a:fld>
             <a:endParaRPr lang="en-US"/>
           </a:p>
@@ -2823,7 +2751,6 @@
               <a:rPr lang="en-US"/>
               <a:t>Click to edit Master title style</a:t>
             </a:r>
-            <a:endParaRPr lang="en-US"/>
           </a:p>
         </p:txBody>
       </p:sp>
@@ -2889,7 +2816,6 @@
               <a:rPr lang="en-US"/>
               <a:t>Click to edit Master text styles</a:t>
             </a:r>
-            <a:endParaRPr lang="en-US"/>
           </a:p>
         </p:txBody>
       </p:sp>
@@ -2946,7 +2872,6 @@
               <a:rPr lang="en-US"/>
               <a:t>Click to edit Master text styles</a:t>
             </a:r>
-            <a:endParaRPr lang="en-US"/>
           </a:p>
           <a:p>
             <a:pPr lvl="1"/>
@@ -2954,7 +2879,6 @@
               <a:rPr lang="en-US"/>
               <a:t>Second level</a:t>
             </a:r>
-            <a:endParaRPr lang="en-US"/>
           </a:p>
           <a:p>
             <a:pPr lvl="2"/>
@@ -2962,7 +2886,6 @@
               <a:rPr lang="en-US"/>
               <a:t>Third level</a:t>
             </a:r>
-            <a:endParaRPr lang="en-US"/>
           </a:p>
           <a:p>
             <a:pPr lvl="3"/>
@@ -2970,7 +2893,6 @@
               <a:rPr lang="en-US"/>
               <a:t>Fourth level</a:t>
             </a:r>
-            <a:endParaRPr lang="en-US"/>
           </a:p>
           <a:p>
             <a:pPr lvl="4"/>
@@ -2978,7 +2900,6 @@
               <a:rPr lang="en-US"/>
               <a:t>Fifth level</a:t>
             </a:r>
-            <a:endParaRPr lang="en-US"/>
           </a:p>
         </p:txBody>
       </p:sp>
@@ -3044,7 +2965,6 @@
               <a:rPr lang="en-US"/>
               <a:t>Click to edit Master text styles</a:t>
             </a:r>
-            <a:endParaRPr lang="en-US"/>
           </a:p>
         </p:txBody>
       </p:sp>
@@ -3101,7 +3021,6 @@
               <a:rPr lang="en-US"/>
               <a:t>Click to edit Master text styles</a:t>
             </a:r>
-            <a:endParaRPr lang="en-US"/>
           </a:p>
           <a:p>
             <a:pPr lvl="1"/>
@@ -3109,7 +3028,6 @@
               <a:rPr lang="en-US"/>
               <a:t>Second level</a:t>
             </a:r>
-            <a:endParaRPr lang="en-US"/>
           </a:p>
           <a:p>
             <a:pPr lvl="2"/>
@@ -3117,7 +3035,6 @@
               <a:rPr lang="en-US"/>
               <a:t>Third level</a:t>
             </a:r>
-            <a:endParaRPr lang="en-US"/>
           </a:p>
           <a:p>
             <a:pPr lvl="3"/>
@@ -3125,7 +3042,6 @@
               <a:rPr lang="en-US"/>
               <a:t>Fourth level</a:t>
             </a:r>
-            <a:endParaRPr lang="en-US"/>
           </a:p>
           <a:p>
             <a:pPr lvl="4"/>
@@ -3133,7 +3049,6 @@
               <a:rPr lang="en-US"/>
               <a:t>Fifth level</a:t>
             </a:r>
-            <a:endParaRPr lang="en-US"/>
           </a:p>
         </p:txBody>
       </p:sp>
@@ -3154,6 +3069,7 @@
           <a:p>
             <a:fld id="{5BCAD085-E8A6-8845-BD4E-CB4CCA059FC4}" type="datetimeFigureOut">
               <a:rPr lang="en-US" smtClean="0"/>
+              <a:t>5/18/26</a:t>
             </a:fld>
             <a:endParaRPr lang="en-US"/>
           </a:p>
@@ -3195,6 +3111,7 @@
           <a:p>
             <a:fld id="{C1FF6DA9-008F-8B48-92A6-B652298478BF}" type="slidenum">
               <a:rPr lang="en-US" smtClean="0"/>
+              <a:t>‹#›</a:t>
             </a:fld>
             <a:endParaRPr lang="en-US"/>
           </a:p>
@@ -3244,7 +3161,6 @@
               <a:rPr lang="en-US"/>
               <a:t>Click to edit Master title style</a:t>
             </a:r>
-            <a:endParaRPr lang="en-US"/>
           </a:p>
         </p:txBody>
       </p:sp>
@@ -3265,6 +3181,7 @@
           <a:p>
             <a:fld id="{5BCAD085-E8A6-8845-BD4E-CB4CCA059FC4}" type="datetimeFigureOut">
               <a:rPr lang="en-US" smtClean="0"/>
+              <a:t>5/18/26</a:t>
             </a:fld>
             <a:endParaRPr lang="en-US"/>
           </a:p>
@@ -3306,6 +3223,7 @@
           <a:p>
             <a:fld id="{C1FF6DA9-008F-8B48-92A6-B652298478BF}" type="slidenum">
               <a:rPr lang="en-US" smtClean="0"/>
+              <a:t>‹#›</a:t>
             </a:fld>
             <a:endParaRPr lang="en-US"/>
           </a:p>
@@ -3353,6 +3271,7 @@
           <a:p>
             <a:fld id="{5BCAD085-E8A6-8845-BD4E-CB4CCA059FC4}" type="datetimeFigureOut">
               <a:rPr lang="en-US" smtClean="0"/>
+              <a:t>5/18/26</a:t>
             </a:fld>
             <a:endParaRPr lang="en-US"/>
           </a:p>
@@ -3394,6 +3313,7 @@
           <a:p>
             <a:fld id="{C1FF6DA9-008F-8B48-92A6-B652298478BF}" type="slidenum">
               <a:rPr lang="en-US" smtClean="0"/>
+              <a:t>‹#›</a:t>
             </a:fld>
             <a:endParaRPr lang="en-US"/>
           </a:p>
@@ -3452,7 +3372,6 @@
               <a:rPr lang="en-US"/>
               <a:t>Click to edit Master title style</a:t>
             </a:r>
-            <a:endParaRPr lang="en-US"/>
           </a:p>
         </p:txBody>
       </p:sp>
@@ -3509,7 +3428,6 @@
               <a:rPr lang="en-US"/>
               <a:t>Click to edit Master text styles</a:t>
             </a:r>
-            <a:endParaRPr lang="en-US"/>
           </a:p>
           <a:p>
             <a:pPr lvl="1"/>
@@ -3517,7 +3435,6 @@
               <a:rPr lang="en-US"/>
               <a:t>Second level</a:t>
             </a:r>
-            <a:endParaRPr lang="en-US"/>
           </a:p>
           <a:p>
             <a:pPr lvl="2"/>
@@ -3525,7 +3442,6 @@
               <a:rPr lang="en-US"/>
               <a:t>Third level</a:t>
             </a:r>
-            <a:endParaRPr lang="en-US"/>
           </a:p>
           <a:p>
             <a:pPr lvl="3"/>
@@ -3533,7 +3449,6 @@
               <a:rPr lang="en-US"/>
               <a:t>Fourth level</a:t>
             </a:r>
-            <a:endParaRPr lang="en-US"/>
           </a:p>
           <a:p>
             <a:pPr lvl="4"/>
@@ -3541,7 +3456,6 @@
               <a:rPr lang="en-US"/>
               <a:t>Fifth level</a:t>
             </a:r>
-            <a:endParaRPr lang="en-US"/>
           </a:p>
         </p:txBody>
       </p:sp>
@@ -3607,7 +3521,6 @@
               <a:rPr lang="en-US"/>
               <a:t>Click to edit Master text styles</a:t>
             </a:r>
-            <a:endParaRPr lang="en-US"/>
           </a:p>
         </p:txBody>
       </p:sp>
@@ -3628,6 +3541,7 @@
           <a:p>
             <a:fld id="{5BCAD085-E8A6-8845-BD4E-CB4CCA059FC4}" type="datetimeFigureOut">
               <a:rPr lang="en-US" smtClean="0"/>
+              <a:t>5/18/26</a:t>
             </a:fld>
             <a:endParaRPr lang="en-US"/>
           </a:p>
@@ -3669,6 +3583,7 @@
           <a:p>
             <a:fld id="{C1FF6DA9-008F-8B48-92A6-B652298478BF}" type="slidenum">
               <a:rPr lang="en-US" smtClean="0"/>
+              <a:t>‹#›</a:t>
             </a:fld>
             <a:endParaRPr lang="en-US"/>
           </a:p>
@@ -3727,7 +3642,6 @@
               <a:rPr lang="en-US"/>
               <a:t>Click to edit Master title style</a:t>
             </a:r>
-            <a:endParaRPr lang="en-US"/>
           </a:p>
         </p:txBody>
       </p:sp>
@@ -3854,7 +3768,6 @@
               <a:rPr lang="en-US"/>
               <a:t>Click to edit Master text styles</a:t>
             </a:r>
-            <a:endParaRPr lang="en-US"/>
           </a:p>
         </p:txBody>
       </p:sp>
@@ -3875,6 +3788,7 @@
           <a:p>
             <a:fld id="{5BCAD085-E8A6-8845-BD4E-CB4CCA059FC4}" type="datetimeFigureOut">
               <a:rPr lang="en-US" smtClean="0"/>
+              <a:t>5/18/26</a:t>
             </a:fld>
             <a:endParaRPr lang="en-US"/>
           </a:p>
@@ -3916,6 +3830,7 @@
           <a:p>
             <a:fld id="{C1FF6DA9-008F-8B48-92A6-B652298478BF}" type="slidenum">
               <a:rPr lang="en-US" smtClean="0"/>
+              <a:t>‹#›</a:t>
             </a:fld>
             <a:endParaRPr lang="en-US"/>
           </a:p>
@@ -3980,7 +3895,6 @@
               <a:rPr lang="en-US"/>
               <a:t>Click to edit Master title style</a:t>
             </a:r>
-            <a:endParaRPr lang="en-US"/>
           </a:p>
         </p:txBody>
       </p:sp>
@@ -4014,7 +3928,6 @@
               <a:rPr lang="en-US"/>
               <a:t>Click to edit Master text styles</a:t>
             </a:r>
-            <a:endParaRPr lang="en-US"/>
           </a:p>
           <a:p>
             <a:pPr lvl="1"/>
@@ -4022,7 +3935,6 @@
               <a:rPr lang="en-US"/>
               <a:t>Second level</a:t>
             </a:r>
-            <a:endParaRPr lang="en-US"/>
           </a:p>
           <a:p>
             <a:pPr lvl="2"/>
@@ -4030,7 +3942,6 @@
               <a:rPr lang="en-US"/>
               <a:t>Third level</a:t>
             </a:r>
-            <a:endParaRPr lang="en-US"/>
           </a:p>
           <a:p>
             <a:pPr lvl="3"/>
@@ -4038,7 +3949,6 @@
               <a:rPr lang="en-US"/>
               <a:t>Fourth level</a:t>
             </a:r>
-            <a:endParaRPr lang="en-US"/>
           </a:p>
           <a:p>
             <a:pPr lvl="4"/>
@@ -4046,7 +3956,6 @@
               <a:rPr lang="en-US"/>
               <a:t>Fifth level</a:t>
             </a:r>
-            <a:endParaRPr lang="en-US"/>
           </a:p>
         </p:txBody>
       </p:sp>
@@ -4085,6 +3994,7 @@
           <a:p>
             <a:fld id="{5BCAD085-E8A6-8845-BD4E-CB4CCA059FC4}" type="datetimeFigureOut">
               <a:rPr lang="en-US" smtClean="0"/>
+              <a:t>5/18/26</a:t>
             </a:fld>
             <a:endParaRPr lang="en-US"/>
           </a:p>
@@ -4162,6 +4072,7 @@
           <a:p>
             <a:fld id="{C1FF6DA9-008F-8B48-92A6-B652298478BF}" type="slidenum">
               <a:rPr lang="en-US" smtClean="0"/>
+              <a:t>‹#›</a:t>
             </a:fld>
             <a:endParaRPr lang="en-US"/>
           </a:p>
@@ -4470,14 +4381,14 @@
           <p:nvPr/>
         </p:nvPicPr>
         <p:blipFill>
-          <a:blip r:embed="rId1">
+          <a:blip r:embed="rId3">
             <a:lum bright="70000" contrast="-70000"/>
             <a:extLst>
               <a:ext uri="{BEBA8EAE-BF5A-486C-A8C5-ECC9F3942E4B}">
                 <a14:imgProps xmlns:a14="http://schemas.microsoft.com/office/drawing/2010/main">
-                  <a14:imgLayer r:embed="rId2">
+                  <a14:imgLayer r:embed="rId4">
                     <a14:imgEffect>
-                      <a14:artisticPhotocopy trans="30000" detail="2"/>
+                      <a14:artisticPhotocopy detail="2"/>
                     </a14:imgEffect>
                   </a14:imgLayer>
                 </a14:imgProps>
@@ -4557,13 +4468,6 @@
               </a:rPr>
               <a:t>STABLECOINS AND THE EXORBITANT PRIVILEGE</a:t>
             </a:r>
-            <a:endParaRPr lang="en-US" altLang="ko-KR" sz="2400" dirty="0">
-              <a:solidFill>
-                <a:prstClr val="white"/>
-              </a:solidFill>
-              <a:latin typeface="Hiragino Kaku Gothic Std W8" panose="020B0800000000000000" pitchFamily="34" charset="-128"/>
-              <a:ea typeface="Hiragino Kaku Gothic Std W8" panose="020B0800000000000000" pitchFamily="34" charset="-128"/>
-            </a:endParaRPr>
           </a:p>
           <a:p>
             <a:pPr algn="ctr" defTabSz="914400" latinLnBrk="1">
@@ -4609,11 +4513,6 @@
               </a:rPr>
               <a:t>Yonsei GSIS 2026-1 </a:t>
             </a:r>
-            <a:endParaRPr lang="en-US" altLang="ko-KR" sz="1800" b="1" dirty="0">
-              <a:solidFill>
-                <a:schemeClr val="bg1"/>
-              </a:solidFill>
-            </a:endParaRPr>
           </a:p>
           <a:p>
             <a:r>
@@ -4727,6 +4626,7 @@
           <a:lstStyle/>
           <a:p>
             <a:pPr algn="ctr"/>
+            <a:endParaRPr/>
           </a:p>
         </p:txBody>
       </p:sp>
@@ -4770,6 +4670,7 @@
           <a:lstStyle/>
           <a:p>
             <a:pPr algn="ctr"/>
+            <a:endParaRPr/>
           </a:p>
         </p:txBody>
       </p:sp>
@@ -4803,11 +4704,6 @@
               </a:rPr>
               <a:t>Roadmap</a:t>
             </a:r>
-            <a:endParaRPr sz="2600" b="0">
-              <a:solidFill>
-                <a:srgbClr val="FFFFFF"/>
-              </a:solidFill>
-            </a:endParaRPr>
           </a:p>
         </p:txBody>
       </p:sp>
@@ -4850,11 +4746,6 @@
               </a:rPr>
               <a:t>Page 2</a:t>
             </a:r>
-            <a:endParaRPr sz="1000" b="0" dirty="0">
-              <a:solidFill>
-                <a:schemeClr val="bg1"/>
-              </a:solidFill>
-            </a:endParaRPr>
           </a:p>
         </p:txBody>
       </p:sp>
@@ -4905,11 +4796,6 @@
               </a:rPr>
               <a:t>:</a:t>
             </a:r>
-            <a:endParaRPr sz="2400" b="1" dirty="0">
-              <a:solidFill>
-                <a:srgbClr val="8A9ABB"/>
-              </a:solidFill>
-            </a:endParaRPr>
           </a:p>
           <a:p>
             <a:r>
@@ -4920,6 +4806,58 @@
               </a:rPr>
               <a:t>❖  Motivation — why stablecoins matter for sovereign debt</a:t>
             </a:r>
+          </a:p>
+          <a:p>
+            <a:r>
+              <a:rPr sz="2400" b="0" dirty="0">
+                <a:solidFill>
+                  <a:srgbClr val="8A9ABB"/>
+                </a:solidFill>
+              </a:rPr>
+              <a:t>❖  The New Triffin Dilemma — our core argument</a:t>
+            </a:r>
+          </a:p>
+          <a:p>
+            <a:r>
+              <a:rPr sz="2400" b="0" dirty="0">
+                <a:solidFill>
+                  <a:srgbClr val="8A9ABB"/>
+                </a:solidFill>
+              </a:rPr>
+              <a:t>❖  Theoretical extension of Maggiori (2017)</a:t>
+            </a:r>
+          </a:p>
+          <a:p>
+            <a:r>
+              <a:rPr sz="2400" b="0" dirty="0">
+                <a:solidFill>
+                  <a:srgbClr val="8A9ABB"/>
+                </a:solidFill>
+              </a:rPr>
+              <a:t>❖  Data &amp; Methodology</a:t>
+            </a:r>
+          </a:p>
+          <a:p>
+            <a:r>
+              <a:rPr sz="2400" b="0" dirty="0">
+                <a:solidFill>
+                  <a:srgbClr val="8A9ABB"/>
+                </a:solidFill>
+              </a:rPr>
+              <a:t>❖  Result 1 — Privilege amplification regression</a:t>
+            </a:r>
+          </a:p>
+          <a:p>
+            <a:r>
+              <a:rPr sz="2400" b="0" dirty="0">
+                <a:solidFill>
+                  <a:srgbClr val="8A9ABB"/>
+                </a:solidFill>
+              </a:rPr>
+              <a:t>❖  Result 2 — Reserve adequacy threshold (Hansen 2000)</a:t>
+            </a:r>
+          </a:p>
+          <a:p>
             <a:endParaRPr sz="2400" b="0" dirty="0">
               <a:solidFill>
                 <a:srgbClr val="8A9ABB"/>
@@ -4928,88 +4866,6 @@
           </a:p>
           <a:p>
             <a:r>
-              <a:rPr sz="2400" b="0" dirty="0">
-                <a:solidFill>
-                  <a:srgbClr val="8A9ABB"/>
-                </a:solidFill>
-              </a:rPr>
-              <a:t>❖  The New Triffin Dilemma — our core argument</a:t>
-            </a:r>
-            <a:endParaRPr sz="2400" b="0" dirty="0">
-              <a:solidFill>
-                <a:srgbClr val="8A9ABB"/>
-              </a:solidFill>
-            </a:endParaRPr>
-          </a:p>
-          <a:p>
-            <a:r>
-              <a:rPr sz="2400" b="0" dirty="0">
-                <a:solidFill>
-                  <a:srgbClr val="8A9ABB"/>
-                </a:solidFill>
-              </a:rPr>
-              <a:t>❖  Theoretical extension of Maggiori (2017)</a:t>
-            </a:r>
-            <a:endParaRPr sz="2400" b="0" dirty="0">
-              <a:solidFill>
-                <a:srgbClr val="8A9ABB"/>
-              </a:solidFill>
-            </a:endParaRPr>
-          </a:p>
-          <a:p>
-            <a:r>
-              <a:rPr sz="2400" b="0" dirty="0">
-                <a:solidFill>
-                  <a:srgbClr val="8A9ABB"/>
-                </a:solidFill>
-              </a:rPr>
-              <a:t>❖  Data &amp; Methodology</a:t>
-            </a:r>
-            <a:endParaRPr sz="2400" b="0" dirty="0">
-              <a:solidFill>
-                <a:srgbClr val="8A9ABB"/>
-              </a:solidFill>
-            </a:endParaRPr>
-          </a:p>
-          <a:p>
-            <a:r>
-              <a:rPr sz="2400" b="0" dirty="0">
-                <a:solidFill>
-                  <a:srgbClr val="8A9ABB"/>
-                </a:solidFill>
-              </a:rPr>
-              <a:t>❖  Result 1 — Privilege amplification regression</a:t>
-            </a:r>
-            <a:endParaRPr sz="2400" b="0" dirty="0">
-              <a:solidFill>
-                <a:srgbClr val="8A9ABB"/>
-              </a:solidFill>
-            </a:endParaRPr>
-          </a:p>
-          <a:p>
-            <a:r>
-              <a:rPr sz="2400" b="0" dirty="0">
-                <a:solidFill>
-                  <a:srgbClr val="8A9ABB"/>
-                </a:solidFill>
-              </a:rPr>
-              <a:t>❖  Result 2 — Reserve adequacy threshold (Hansen 2000)</a:t>
-            </a:r>
-            <a:endParaRPr sz="2400" b="0" dirty="0">
-              <a:solidFill>
-                <a:srgbClr val="8A9ABB"/>
-              </a:solidFill>
-            </a:endParaRPr>
-          </a:p>
-          <a:p>
-            <a:endParaRPr sz="2400" b="0" dirty="0">
-              <a:solidFill>
-                <a:srgbClr val="8A9ABB"/>
-              </a:solidFill>
-            </a:endParaRPr>
-          </a:p>
-          <a:p>
-            <a:r>
               <a:rPr sz="2800" b="1" dirty="0">
                 <a:solidFill>
                   <a:srgbClr val="1A1A2E"/>
@@ -5033,11 +4889,6 @@
               </a:rPr>
               <a:t>:</a:t>
             </a:r>
-            <a:endParaRPr sz="2800" b="1" dirty="0">
-              <a:solidFill>
-                <a:srgbClr val="1A1A2E"/>
-              </a:solidFill>
-            </a:endParaRPr>
           </a:p>
           <a:p>
             <a:r>
@@ -5048,11 +4899,6 @@
               </a:rPr>
               <a:t>❖  Literature Gap — placing our contribution</a:t>
             </a:r>
-            <a:endParaRPr sz="2800" b="0" dirty="0">
-              <a:solidFill>
-                <a:srgbClr val="1A1A2E"/>
-              </a:solidFill>
-            </a:endParaRPr>
           </a:p>
           <a:p>
             <a:r>
@@ -5063,11 +4909,6 @@
               </a:rPr>
               <a:t>❖  Result 3 — Buffer-conditioned event study (causal evidence)</a:t>
             </a:r>
-            <a:endParaRPr sz="2800" b="0" dirty="0">
-              <a:solidFill>
-                <a:srgbClr val="1A1A2E"/>
-              </a:solidFill>
-            </a:endParaRPr>
           </a:p>
           <a:p>
             <a:r>
@@ -5078,11 +4919,6 @@
               </a:rPr>
               <a:t>❖  Asymmetric Effects — Growth vs. Contraction periods (new)</a:t>
             </a:r>
-            <a:endParaRPr sz="2800" b="0" dirty="0">
-              <a:solidFill>
-                <a:srgbClr val="1A1A2E"/>
-              </a:solidFill>
-            </a:endParaRPr>
           </a:p>
           <a:p>
             <a:r>
@@ -5093,11 +4929,6 @@
               </a:rPr>
               <a:t>❖  Policy Implication — 13% threshold reframed</a:t>
             </a:r>
-            <a:endParaRPr sz="2800" b="0" dirty="0">
-              <a:solidFill>
-                <a:srgbClr val="1A1A2E"/>
-              </a:solidFill>
-            </a:endParaRPr>
           </a:p>
           <a:p>
             <a:r>
@@ -5108,11 +4939,6 @@
               </a:rPr>
               <a:t>❖  Conclusion</a:t>
             </a:r>
-            <a:endParaRPr sz="2800" b="0" dirty="0">
-              <a:solidFill>
-                <a:srgbClr val="1A1A2E"/>
-              </a:solidFill>
-            </a:endParaRPr>
           </a:p>
         </p:txBody>
       </p:sp>
@@ -5181,6 +5007,7 @@
           <a:lstStyle/>
           <a:p>
             <a:pPr algn="ctr"/>
+            <a:endParaRPr/>
           </a:p>
         </p:txBody>
       </p:sp>
@@ -5214,11 +5041,6 @@
               </a:rPr>
               <a:t>What The Literature Has Established — And Where It Stops</a:t>
             </a:r>
-            <a:endParaRPr lang="en-US" altLang="en-US" sz="2600" b="0">
-              <a:solidFill>
-                <a:srgbClr val="FFFFFF"/>
-              </a:solidFill>
-            </a:endParaRPr>
           </a:p>
         </p:txBody>
       </p:sp>
@@ -5262,11 +5084,6 @@
               </a:rPr>
               <a:t>Page 3</a:t>
             </a:r>
-            <a:endParaRPr sz="1000" b="0" dirty="0">
-              <a:solidFill>
-                <a:schemeClr val="bg1"/>
-              </a:solidFill>
-            </a:endParaRPr>
           </a:p>
         </p:txBody>
       </p:sp>
@@ -5348,11 +5165,6 @@
               </a:rPr>
               <a:t>Stablecoin inflows lower 3-month T-bill yields 2–2.5 basis points. Outflows raise yields 2–3x more. Effect is state-dependent on T-bill market supply.</a:t>
             </a:r>
-            <a:endParaRPr lang="en-US" altLang="en-US" sz="1600" b="0">
-              <a:solidFill>
-                <a:srgbClr val="1A7A4A"/>
-              </a:solidFill>
-            </a:endParaRPr>
           </a:p>
           <a:p>
             <a:pPr>
@@ -5377,11 +5189,6 @@
               </a:rPr>
               <a:t>Moderating variable is market-level T-bill supply — not issuer reserve composition. Uses yield levels, not OIS-Treasury spread. No reserve adequacy threshold identified.</a:t>
             </a:r>
-            <a:endParaRPr lang="en-US" altLang="en-US" sz="1600" b="0">
-              <a:solidFill>
-                <a:srgbClr val="C0392B"/>
-              </a:solidFill>
-            </a:endParaRPr>
           </a:p>
         </p:txBody>
       </p:sp>
@@ -5425,6 +5232,7 @@
           <a:lstStyle/>
           <a:p>
             <a:pPr algn="ctr"/>
+            <a:endParaRPr/>
           </a:p>
         </p:txBody>
       </p:sp>
@@ -5459,11 +5267,6 @@
               </a:rPr>
               <a:t>Existing Literature</a:t>
             </a:r>
-            <a:endParaRPr sz="1400" b="1">
-              <a:solidFill>
-                <a:srgbClr val="FFFFFF"/>
-              </a:solidFill>
-            </a:endParaRPr>
           </a:p>
         </p:txBody>
       </p:sp>
@@ -5511,7 +5314,6 @@
               <a:rPr lang="en-US" altLang="en-US"/>
               <a:t>Each paper answers one question and leaves the next one open. None jointly estimates how issuer reserve composition moderates the transmission from stablecoin activity to sovereign debt markets.</a:t>
             </a:r>
-            <a:endParaRPr lang="en-US" altLang="en-US"/>
           </a:p>
         </p:txBody>
       </p:sp>
@@ -5624,12 +5426,6 @@
               </a:rPr>
               <a:t>Identifies the run risk. Does not model how runs transmit to sovereign debt markets. No Treasury spread analysis. No threshold estimation.</a:t>
             </a:r>
-            <a:endParaRPr lang="en-US" altLang="en-US" sz="1600" b="0">
-              <a:solidFill>
-                <a:srgbClr val="C0392B"/>
-              </a:solidFill>
-              <a:sym typeface="+mn-ea"/>
-            </a:endParaRPr>
           </a:p>
         </p:txBody>
       </p:sp>
@@ -5711,11 +5507,6 @@
               </a:rPr>
               <a:t>Arbitrage mechanisms keep dollar-backed stablecoins pegged. Under-collateralised issuers face speculative attacks and devaluation risk.</a:t>
             </a:r>
-            <a:endParaRPr lang="en-US" altLang="en-US" sz="1600" b="0">
-              <a:solidFill>
-                <a:srgbClr val="1A7A4A"/>
-              </a:solidFill>
-            </a:endParaRPr>
           </a:p>
           <a:p>
             <a:pPr>
@@ -5741,12 +5532,6 @@
               </a:rPr>
               <a:t>Internal peg mechanics only. No connection to Treasury market outcomes. No reserve adequacy variable.</a:t>
             </a:r>
-            <a:endParaRPr lang="en-US" altLang="en-US" sz="1600" b="0">
-              <a:solidFill>
-                <a:srgbClr val="C0392B"/>
-              </a:solidFill>
-              <a:sym typeface="+mn-ea"/>
-            </a:endParaRPr>
           </a:p>
         </p:txBody>
       </p:sp>
@@ -5793,12 +5578,6 @@
               </a:rPr>
               <a:t> — theoretical foundations established in prior presentation.</a:t>
             </a:r>
-            <a:endParaRPr lang="en-US" altLang="en-US" sz="1300" b="0" dirty="0">
-              <a:solidFill>
-                <a:srgbClr val="555566"/>
-              </a:solidFill>
-              <a:sym typeface="+mn-ea"/>
-            </a:endParaRPr>
           </a:p>
         </p:txBody>
       </p:sp>
@@ -5867,6 +5646,7 @@
           <a:lstStyle/>
           <a:p>
             <a:pPr algn="ctr"/>
+            <a:endParaRPr/>
           </a:p>
         </p:txBody>
       </p:sp>
@@ -5900,11 +5680,6 @@
               </a:rPr>
               <a:t>What Our Paper Does That No Paper Has Done</a:t>
             </a:r>
-            <a:endParaRPr lang="en-US" altLang="en-US" sz="2600" b="0">
-              <a:solidFill>
-                <a:srgbClr val="FFFFFF"/>
-              </a:solidFill>
-            </a:endParaRPr>
           </a:p>
         </p:txBody>
       </p:sp>
@@ -6081,7 +5856,6 @@
               <a:rPr lang="en-US" altLang="en-US" sz="1700"/>
               <a:t>OIS–Treasury spread — not yield levels. Measures the privilege directly.</a:t>
             </a:r>
-            <a:endParaRPr lang="en-US" altLang="en-US" sz="1700"/>
           </a:p>
         </p:txBody>
       </p:sp>
@@ -6209,7 +5983,6 @@
               <a:rPr lang="en-US" altLang="en-US" sz="1700"/>
               <a:t>Issuer liquid buffer L — not market supply. Policy-actionable.</a:t>
             </a:r>
-            <a:endParaRPr lang="en-US" altLang="en-US" sz="1700"/>
           </a:p>
         </p:txBody>
       </p:sp>
@@ -6272,7 +6045,6 @@
               <a:rPr lang="en-US" altLang="en-US" sz="1700"/>
               <a:t> How L moderates stablecoin issuance effect on spreads. No antecedent.</a:t>
             </a:r>
-            <a:endParaRPr lang="en-US" altLang="en-US" sz="1700"/>
           </a:p>
         </p:txBody>
       </p:sp>
@@ -6335,7 +6107,6 @@
               <a:rPr lang="en-US" altLang="en-US" sz="1700"/>
               <a:t>Hansen (2000) structural break separating two distinct regimes.First empirical estimate of this kind.</a:t>
             </a:r>
-            <a:endParaRPr lang="en-US" altLang="en-US" sz="1700"/>
           </a:p>
         </p:txBody>
       </p:sp>
@@ -6391,7 +6162,6 @@
               <a:rPr lang="en-US" altLang="en-US" sz="1700" b="1"/>
               <a:t>5. Asymmetric effects: </a:t>
             </a:r>
-            <a:endParaRPr lang="en-US" altLang="en-US" sz="1700" b="1"/>
           </a:p>
           <a:p>
             <a:pPr algn="ctr"/>
@@ -6399,7 +6169,6 @@
               <a:rPr lang="en-US" altLang="en-US" sz="1700"/>
               <a:t>Growth vs. contraction periods separated. Consistent with Ahmed &amp; Aldasoro's own asymmetry finding.</a:t>
             </a:r>
-            <a:endParaRPr lang="en-US" altLang="en-US" sz="1700"/>
           </a:p>
         </p:txBody>
       </p:sp>
@@ -6529,12 +6298,6 @@
               </a:rPr>
               <a:t>Reserve adequacy methodology (Jeanne &amp; Rancière 2011)</a:t>
             </a:r>
-            <a:endParaRPr lang="en-US" altLang="en-US" sz="1600">
-              <a:solidFill>
-                <a:schemeClr val="tx1"/>
-              </a:solidFill>
-              <a:sym typeface="+mn-ea"/>
-            </a:endParaRPr>
           </a:p>
         </p:txBody>
       </p:sp>
@@ -6603,6 +6366,7 @@
           <a:lstStyle/>
           <a:p>
             <a:pPr algn="ctr"/>
+            <a:endParaRPr/>
           </a:p>
         </p:txBody>
       </p:sp>
@@ -6646,6 +6410,7 @@
           <a:lstStyle/>
           <a:p>
             <a:pPr algn="ctr"/>
+            <a:endParaRPr/>
           </a:p>
         </p:txBody>
       </p:sp>
@@ -6679,11 +6444,6 @@
               </a:rPr>
               <a:t>Result 3: Buffer-Conditioned Event Study</a:t>
             </a:r>
-            <a:endParaRPr sz="2600" b="0">
-              <a:solidFill>
-                <a:srgbClr val="FFFFFF"/>
-              </a:solidFill>
-            </a:endParaRPr>
           </a:p>
         </p:txBody>
       </p:sp>
@@ -6743,7 +6503,7 @@
           <p:nvPr/>
         </p:nvPicPr>
         <p:blipFill>
-          <a:blip r:embed="rId1"/>
+          <a:blip r:embed="rId3"/>
           <a:stretch>
             <a:fillRect/>
           </a:stretch>
@@ -6798,6 +6558,7 @@
           <a:lstStyle/>
           <a:p>
             <a:pPr algn="ctr"/>
+            <a:endParaRPr/>
           </a:p>
         </p:txBody>
       </p:sp>
@@ -6831,11 +6592,6 @@
               </a:rPr>
               <a:t>Event</a:t>
             </a:r>
-            <a:endParaRPr sz="1100" b="1">
-              <a:solidFill>
-                <a:srgbClr val="FFFFFF"/>
-              </a:solidFill>
-            </a:endParaRPr>
           </a:p>
         </p:txBody>
       </p:sp>
@@ -6869,11 +6625,6 @@
               </a:rPr>
               <a:t>Buffer</a:t>
             </a:r>
-            <a:endParaRPr sz="1100" b="1">
-              <a:solidFill>
-                <a:srgbClr val="FFFFFF"/>
-              </a:solidFill>
-            </a:endParaRPr>
           </a:p>
         </p:txBody>
       </p:sp>
@@ -6907,11 +6658,6 @@
               </a:rPr>
               <a:t>CAR</a:t>
             </a:r>
-            <a:endParaRPr sz="1100" b="1">
-              <a:solidFill>
-                <a:srgbClr val="FFFFFF"/>
-              </a:solidFill>
-            </a:endParaRPr>
           </a:p>
         </p:txBody>
       </p:sp>
@@ -6945,11 +6691,6 @@
               </a:rPr>
               <a:t>Sig.</a:t>
             </a:r>
-            <a:endParaRPr sz="1100" b="1">
-              <a:solidFill>
-                <a:srgbClr val="FFFFFF"/>
-              </a:solidFill>
-            </a:endParaRPr>
           </a:p>
         </p:txBody>
       </p:sp>
@@ -6993,6 +6734,7 @@
           <a:lstStyle/>
           <a:p>
             <a:pPr algn="ctr"/>
+            <a:endParaRPr/>
           </a:p>
         </p:txBody>
       </p:sp>
@@ -7026,11 +6768,6 @@
               </a:rPr>
               <a:t>LUNA/UST Collapse</a:t>
             </a:r>
-            <a:endParaRPr sz="1100" b="0" dirty="0">
-              <a:solidFill>
-                <a:srgbClr val="1A1A2E"/>
-              </a:solidFill>
-            </a:endParaRPr>
           </a:p>
         </p:txBody>
       </p:sp>
@@ -7064,11 +6801,6 @@
               </a:rPr>
               <a:t>LOW</a:t>
             </a:r>
-            <a:endParaRPr sz="1100" b="0">
-              <a:solidFill>
-                <a:srgbClr val="C0392B"/>
-              </a:solidFill>
-            </a:endParaRPr>
           </a:p>
         </p:txBody>
       </p:sp>
@@ -7102,11 +6834,6 @@
               </a:rPr>
               <a:t>+8.91 bp</a:t>
             </a:r>
-            <a:endParaRPr sz="1100" b="0">
-              <a:solidFill>
-                <a:srgbClr val="C0392B"/>
-              </a:solidFill>
-            </a:endParaRPr>
           </a:p>
         </p:txBody>
       </p:sp>
@@ -7140,11 +6867,6 @@
               </a:rPr>
               <a:t>***</a:t>
             </a:r>
-            <a:endParaRPr sz="1100" b="0">
-              <a:solidFill>
-                <a:srgbClr val="C0392B"/>
-              </a:solidFill>
-            </a:endParaRPr>
           </a:p>
         </p:txBody>
       </p:sp>
@@ -7188,6 +6910,7 @@
           <a:lstStyle/>
           <a:p>
             <a:pPr algn="ctr"/>
+            <a:endParaRPr/>
           </a:p>
         </p:txBody>
       </p:sp>
@@ -7267,11 +6990,6 @@
               </a:rPr>
               <a:t>LOW</a:t>
             </a:r>
-            <a:endParaRPr sz="1100" b="0">
-              <a:solidFill>
-                <a:srgbClr val="C0392B"/>
-              </a:solidFill>
-            </a:endParaRPr>
           </a:p>
         </p:txBody>
       </p:sp>
@@ -7305,11 +7023,6 @@
               </a:rPr>
               <a:t>+8.85 bp</a:t>
             </a:r>
-            <a:endParaRPr sz="1100" b="0">
-              <a:solidFill>
-                <a:srgbClr val="C0392B"/>
-              </a:solidFill>
-            </a:endParaRPr>
           </a:p>
         </p:txBody>
       </p:sp>
@@ -7343,11 +7056,6 @@
               </a:rPr>
               <a:t>***</a:t>
             </a:r>
-            <a:endParaRPr sz="1100" b="0">
-              <a:solidFill>
-                <a:srgbClr val="C0392B"/>
-              </a:solidFill>
-            </a:endParaRPr>
           </a:p>
         </p:txBody>
       </p:sp>
@@ -7391,6 +7099,7 @@
           <a:lstStyle/>
           <a:p>
             <a:pPr algn="ctr"/>
+            <a:endParaRPr/>
           </a:p>
         </p:txBody>
       </p:sp>
@@ -7424,11 +7133,6 @@
               </a:rPr>
               <a:t>USDC / SVB Failure</a:t>
             </a:r>
-            <a:endParaRPr sz="1100" b="0" dirty="0">
-              <a:solidFill>
-                <a:srgbClr val="1A1A2E"/>
-              </a:solidFill>
-            </a:endParaRPr>
           </a:p>
         </p:txBody>
       </p:sp>
@@ -7462,11 +7166,6 @@
               </a:rPr>
               <a:t>HIGH</a:t>
             </a:r>
-            <a:endParaRPr sz="1100" b="0">
-              <a:solidFill>
-                <a:srgbClr val="1A7A4A"/>
-              </a:solidFill>
-            </a:endParaRPr>
           </a:p>
         </p:txBody>
       </p:sp>
@@ -7516,11 +7215,6 @@
               </a:rPr>
               <a:t>bp</a:t>
             </a:r>
-            <a:endParaRPr sz="1100" b="0">
-              <a:solidFill>
-                <a:srgbClr val="1A7A4A"/>
-              </a:solidFill>
-            </a:endParaRPr>
           </a:p>
         </p:txBody>
       </p:sp>
@@ -7554,11 +7248,6 @@
               </a:rPr>
               <a:t>***</a:t>
             </a:r>
-            <a:endParaRPr sz="1100" b="0">
-              <a:solidFill>
-                <a:srgbClr val="1A7A4A"/>
-              </a:solidFill>
-            </a:endParaRPr>
           </a:p>
         </p:txBody>
       </p:sp>
@@ -7592,11 +7281,6 @@
               </a:rPr>
               <a:t>Low vs. High buffer diff-test: t = 15.22, p &lt; 0.001</a:t>
             </a:r>
-            <a:endParaRPr sz="1000" b="0">
-              <a:solidFill>
-                <a:srgbClr val="555566"/>
-              </a:solidFill>
-            </a:endParaRPr>
           </a:p>
         </p:txBody>
       </p:sp>
@@ -7640,6 +7324,7 @@
           <a:lstStyle/>
           <a:p>
             <a:pPr algn="ctr"/>
+            <a:endParaRPr/>
           </a:p>
         </p:txBody>
       </p:sp>
@@ -7674,11 +7359,6 @@
               </a:rPr>
               <a:t>What this shows:</a:t>
             </a:r>
-            <a:endParaRPr sz="1600" b="1" dirty="0">
-              <a:solidFill>
-                <a:srgbClr val="AAC4E8"/>
-              </a:solidFill>
-            </a:endParaRPr>
           </a:p>
           <a:p>
             <a:pPr>
@@ -7710,11 +7390,6 @@
               </a:rPr>
               <a:t>T-bill liquidation transmits to sovereign debt markets</a:t>
             </a:r>
-            <a:endParaRPr sz="1400" b="0" dirty="0">
-              <a:solidFill>
-                <a:srgbClr val="FFFFFF"/>
-              </a:solidFill>
-            </a:endParaRPr>
           </a:p>
           <a:p>
             <a:pPr>
@@ -7746,11 +7421,6 @@
               </a:rPr>
               <a:t>redemptions; market sees flight-to-safety instead</a:t>
             </a:r>
-            <a:endParaRPr sz="1400" b="0" dirty="0">
-              <a:solidFill>
-                <a:srgbClr val="FFFFFF"/>
-              </a:solidFill>
-            </a:endParaRPr>
           </a:p>
           <a:p>
             <a:pPr>
@@ -7766,11 +7436,6 @@
               </a:rPr>
               <a:t>❖  Difference is statistically significant (p &lt; 0.001)</a:t>
             </a:r>
-            <a:endParaRPr sz="1400" b="0" dirty="0">
-              <a:solidFill>
-                <a:srgbClr val="FFFFFF"/>
-              </a:solidFill>
-            </a:endParaRPr>
           </a:p>
         </p:txBody>
       </p:sp>
@@ -7814,6 +7479,7 @@
           <a:lstStyle/>
           <a:p>
             <a:pPr algn="ctr"/>
+            <a:endParaRPr/>
           </a:p>
         </p:txBody>
       </p:sp>
@@ -7848,11 +7514,6 @@
               </a:rPr>
               <a:t>Causal evidence: the buffer — not the event — determines whether a run stabilises or disrupts Treasury markets.</a:t>
             </a:r>
-            <a:endParaRPr sz="1800" b="1">
-              <a:solidFill>
-                <a:srgbClr val="FFFFFF"/>
-              </a:solidFill>
-            </a:endParaRPr>
           </a:p>
         </p:txBody>
       </p:sp>
@@ -7921,6 +7582,7 @@
           <a:lstStyle/>
           <a:p>
             <a:pPr algn="ctr"/>
+            <a:endParaRPr/>
           </a:p>
         </p:txBody>
       </p:sp>
@@ -7964,6 +7626,7 @@
           <a:lstStyle/>
           <a:p>
             <a:pPr algn="ctr"/>
+            <a:endParaRPr/>
           </a:p>
         </p:txBody>
       </p:sp>
@@ -7997,11 +7660,6 @@
               </a:rPr>
               <a:t>Asymmetric Effects: Growth vs. Contraction Periods</a:t>
             </a:r>
-            <a:endParaRPr sz="2600" b="0">
-              <a:solidFill>
-                <a:srgbClr val="FFFFFF"/>
-              </a:solidFill>
-            </a:endParaRPr>
           </a:p>
         </p:txBody>
       </p:sp>
@@ -8082,11 +7740,6 @@
               </a:rPr>
               <a:t>Buying T-bills is gradual and orderly. Selling is forced and immediate. The buffer only matters when supply contracts.</a:t>
             </a:r>
-            <a:endParaRPr sz="1300" b="0" dirty="0">
-              <a:solidFill>
-                <a:srgbClr val="555566"/>
-              </a:solidFill>
-            </a:endParaRPr>
           </a:p>
         </p:txBody>
       </p:sp>
@@ -8130,6 +7783,7 @@
           <a:lstStyle/>
           <a:p>
             <a:pPr algn="ctr"/>
+            <a:endParaRPr/>
           </a:p>
         </p:txBody>
       </p:sp>
@@ -8173,6 +7827,7 @@
           <a:lstStyle/>
           <a:p>
             <a:pPr algn="ctr"/>
+            <a:endParaRPr/>
           </a:p>
         </p:txBody>
       </p:sp>
@@ -8206,11 +7861,6 @@
               </a:rPr>
               <a:t>GROWTH PERIODS  (ΔlnS &gt; 0)   N = 32</a:t>
             </a:r>
-            <a:endParaRPr sz="1400" b="1">
-              <a:solidFill>
-                <a:srgbClr val="FFFFFF"/>
-              </a:solidFill>
-            </a:endParaRPr>
           </a:p>
         </p:txBody>
       </p:sp>
@@ -8261,11 +7911,6 @@
               </a:rPr>
               <a:t>.)</a:t>
             </a:r>
-            <a:endParaRPr sz="2800" b="1" dirty="0">
-              <a:solidFill>
-                <a:srgbClr val="C0392B"/>
-              </a:solidFill>
-            </a:endParaRPr>
           </a:p>
           <a:p>
             <a:pPr>
@@ -8313,11 +7958,6 @@
               </a:rPr>
               <a:t>.)</a:t>
             </a:r>
-            <a:endParaRPr sz="1600" b="0" dirty="0">
-              <a:solidFill>
-                <a:srgbClr val="1A1A2E"/>
-              </a:solidFill>
-            </a:endParaRPr>
           </a:p>
           <a:p>
             <a:pPr>
@@ -8333,11 +7973,6 @@
               </a:rPr>
               <a:t>R² = 0.335</a:t>
             </a:r>
-            <a:endParaRPr sz="1400" b="0" dirty="0">
-              <a:solidFill>
-                <a:srgbClr val="1A1A2E"/>
-              </a:solidFill>
-            </a:endParaRPr>
           </a:p>
           <a:p>
             <a:pPr>
@@ -8385,11 +8020,6 @@
               </a:rPr>
               <a:t>how issuers affect markets.</a:t>
             </a:r>
-            <a:endParaRPr sz="1600" b="0" dirty="0">
-              <a:solidFill>
-                <a:srgbClr val="1A1A2E"/>
-              </a:solidFill>
-            </a:endParaRPr>
           </a:p>
         </p:txBody>
       </p:sp>
@@ -8433,6 +8063,7 @@
           <a:lstStyle/>
           <a:p>
             <a:pPr algn="ctr"/>
+            <a:endParaRPr/>
           </a:p>
         </p:txBody>
       </p:sp>
@@ -8476,6 +8107,7 @@
           <a:lstStyle/>
           <a:p>
             <a:pPr algn="ctr"/>
+            <a:endParaRPr/>
           </a:p>
         </p:txBody>
       </p:sp>
@@ -8509,11 +8141,6 @@
               </a:rPr>
               <a:t>CONTRACTION PERIODS  (ΔlnS &lt; 0)   N = 19</a:t>
             </a:r>
-            <a:endParaRPr sz="1400" b="1">
-              <a:solidFill>
-                <a:srgbClr val="FFFFFF"/>
-              </a:solidFill>
-            </a:endParaRPr>
           </a:p>
         </p:txBody>
       </p:sp>
@@ -8548,11 +8175,6 @@
               </a:rPr>
               <a:t>β₁ = −12.68**   (p = 0.037)</a:t>
             </a:r>
-            <a:endParaRPr sz="2800" b="1">
-              <a:solidFill>
-                <a:srgbClr val="1A7A4A"/>
-              </a:solidFill>
-            </a:endParaRPr>
           </a:p>
           <a:p>
             <a:pPr>
@@ -8568,11 +8190,6 @@
               </a:rPr>
               <a:t>L × ΔlnS = +78.57   (p = 0.314, n.s.)</a:t>
             </a:r>
-            <a:endParaRPr sz="1600" b="0">
-              <a:solidFill>
-                <a:srgbClr val="1A1A2E"/>
-              </a:solidFill>
-            </a:endParaRPr>
           </a:p>
           <a:p>
             <a:pPr>
@@ -8588,11 +8205,6 @@
               </a:rPr>
               <a:t>R² = 0.728</a:t>
             </a:r>
-            <a:endParaRPr sz="1400" b="0">
-              <a:solidFill>
-                <a:srgbClr val="1A1A2E"/>
-              </a:solidFill>
-            </a:endParaRPr>
           </a:p>
           <a:p>
             <a:pPr>
@@ -8610,11 +8222,6 @@
 Forced liquidation drives sovereign spread.
 Model explains 73% of variation in stress.</a:t>
             </a:r>
-            <a:endParaRPr sz="1600" b="0">
-              <a:solidFill>
-                <a:srgbClr val="1A1A2E"/>
-              </a:solidFill>
-            </a:endParaRPr>
           </a:p>
         </p:txBody>
       </p:sp>
@@ -8658,6 +8265,7 @@
           <a:lstStyle/>
           <a:p>
             <a:pPr algn="ctr"/>
+            <a:endParaRPr/>
           </a:p>
         </p:txBody>
       </p:sp>
@@ -8692,11 +8300,6 @@
               </a:rPr>
               <a:t>The buffer matters precisely when supply is falling — confirming the fragility mechanism our theory predicts.</a:t>
             </a:r>
-            <a:endParaRPr sz="1800" b="1">
-              <a:solidFill>
-                <a:srgbClr val="FFFFFF"/>
-              </a:solidFill>
-            </a:endParaRPr>
           </a:p>
         </p:txBody>
       </p:sp>
@@ -8765,6 +8368,7 @@
           <a:lstStyle/>
           <a:p>
             <a:pPr algn="ctr"/>
+            <a:endParaRPr/>
           </a:p>
         </p:txBody>
       </p:sp>
@@ -8808,6 +8412,7 @@
           <a:lstStyle/>
           <a:p>
             <a:pPr algn="ctr"/>
+            <a:endParaRPr/>
           </a:p>
         </p:txBody>
       </p:sp>
@@ -8841,11 +8446,6 @@
               </a:rPr>
               <a:t>Policy Implication: The 13% Empirical Floor</a:t>
             </a:r>
-            <a:endParaRPr sz="2600" b="0">
-              <a:solidFill>
-                <a:srgbClr val="FFFFFF"/>
-              </a:solidFill>
-            </a:endParaRPr>
           </a:p>
         </p:txBody>
       </p:sp>
@@ -8936,6 +8536,7 @@
           <a:lstStyle/>
           <a:p>
             <a:pPr algn="ctr"/>
+            <a:endParaRPr/>
           </a:p>
         </p:txBody>
       </p:sp>
@@ -8969,11 +8570,6 @@
               </a:rPr>
               <a:t>What the threshold tells us:</a:t>
             </a:r>
-            <a:endParaRPr sz="1500" b="1">
-              <a:solidFill>
-                <a:srgbClr val="AAC4E8"/>
-              </a:solidFill>
-            </a:endParaRPr>
           </a:p>
         </p:txBody>
       </p:sp>
@@ -9008,11 +8604,6 @@
               </a:rPr>
               <a:t>q*  =  13%</a:t>
             </a:r>
-            <a:endParaRPr sz="4000" b="1" dirty="0">
-              <a:solidFill>
-                <a:srgbClr val="FFFFFF"/>
-              </a:solidFill>
-            </a:endParaRPr>
           </a:p>
           <a:p>
             <a:pPr>
@@ -9028,11 +8619,6 @@
               </a:rPr>
               <a:t>of supply held as liquid cash</a:t>
             </a:r>
-            <a:endParaRPr sz="1600" b="0" dirty="0">
-              <a:solidFill>
-                <a:srgbClr val="AAC4E8"/>
-              </a:solidFill>
-            </a:endParaRPr>
           </a:p>
           <a:p>
             <a:pPr>
@@ -9048,11 +8634,6 @@
               </a:rPr>
               <a:t>Below 13% (38 of 51 months):</a:t>
             </a:r>
-            <a:endParaRPr sz="1600" b="1" dirty="0">
-              <a:solidFill>
-                <a:srgbClr val="FFD700"/>
-              </a:solidFill>
-            </a:endParaRPr>
           </a:p>
           <a:p>
             <a:r>
@@ -9079,11 +8660,6 @@
               </a:rPr>
               <a:t>directions → sovereign spread disruption</a:t>
             </a:r>
-            <a:endParaRPr sz="1600" b="0" dirty="0">
-              <a:solidFill>
-                <a:srgbClr val="FFFFFF"/>
-              </a:solidFill>
-            </a:endParaRPr>
           </a:p>
           <a:p>
             <a:pPr>
@@ -9099,11 +8675,6 @@
               </a:rPr>
               <a:t>Above 13% (13 of 51 months):</a:t>
             </a:r>
-            <a:endParaRPr sz="1600" b="1" dirty="0">
-              <a:solidFill>
-                <a:srgbClr val="FFD700"/>
-              </a:solidFill>
-            </a:endParaRPr>
           </a:p>
           <a:p>
             <a:r>
@@ -9130,11 +8701,6 @@
               </a:rPr>
               <a:t>T-bill market undisturbed</a:t>
             </a:r>
-            <a:endParaRPr sz="1600" b="0" dirty="0">
-              <a:solidFill>
-                <a:srgbClr val="FFFFFF"/>
-              </a:solidFill>
-            </a:endParaRPr>
           </a:p>
         </p:txBody>
       </p:sp>
@@ -9178,6 +8744,7 @@
           <a:lstStyle/>
           <a:p>
             <a:pPr algn="ctr"/>
+            <a:endParaRPr/>
           </a:p>
         </p:txBody>
       </p:sp>
@@ -9211,11 +8778,6 @@
               </a:rPr>
               <a:t>Regulatory interpretation:</a:t>
             </a:r>
-            <a:endParaRPr b="1">
-              <a:solidFill>
-                <a:srgbClr val="1B3A72"/>
-              </a:solidFill>
-            </a:endParaRPr>
           </a:p>
         </p:txBody>
       </p:sp>
@@ -9249,11 +8811,6 @@
               </a:rPr>
               <a:t>What the data says</a:t>
             </a:r>
-            <a:endParaRPr sz="1500" b="1">
-              <a:solidFill>
-                <a:srgbClr val="1B3A72"/>
-              </a:solidFill>
-            </a:endParaRPr>
           </a:p>
         </p:txBody>
       </p:sp>
@@ -9303,11 +8860,6 @@
               </a:rPr>
               <a:t>separating two distinct regimes — not an optimal level</a:t>
             </a:r>
-            <a:endParaRPr sz="1400" b="0" dirty="0">
-              <a:solidFill>
-                <a:srgbClr val="1A1A2E"/>
-              </a:solidFill>
-            </a:endParaRPr>
           </a:p>
         </p:txBody>
       </p:sp>
@@ -9341,11 +8893,6 @@
               </a:rPr>
               <a:t>Proposed floor</a:t>
             </a:r>
-            <a:endParaRPr sz="1500" b="1">
-              <a:solidFill>
-                <a:srgbClr val="1B3A72"/>
-              </a:solidFill>
-            </a:endParaRPr>
           </a:p>
         </p:txBody>
       </p:sp>
@@ -9395,11 +8942,6 @@
               </a:rPr>
               <a:t>cash or near-cash instruments only)</a:t>
             </a:r>
-            <a:endParaRPr sz="1400" b="0">
-              <a:solidFill>
-                <a:srgbClr val="1A1A2E"/>
-              </a:solidFill>
-            </a:endParaRPr>
           </a:p>
         </p:txBody>
       </p:sp>
@@ -9433,11 +8975,6 @@
               </a:rPr>
               <a:t>Who this applies to</a:t>
             </a:r>
-            <a:endParaRPr sz="1500" b="1">
-              <a:solidFill>
-                <a:srgbClr val="1B3A72"/>
-              </a:solidFill>
-            </a:endParaRPr>
           </a:p>
         </p:txBody>
       </p:sp>
@@ -9503,11 +9040,6 @@
               </a:rPr>
               <a:t>operating above $10bn supply (systemic threshold)</a:t>
             </a:r>
-            <a:endParaRPr sz="1400" b="0" dirty="0">
-              <a:solidFill>
-                <a:srgbClr val="1A1A2E"/>
-              </a:solidFill>
-            </a:endParaRPr>
           </a:p>
         </p:txBody>
       </p:sp>
@@ -9541,11 +9073,6 @@
               </a:rPr>
               <a:t>Caveat — welfare optimum</a:t>
             </a:r>
-            <a:endParaRPr sz="1500" b="1">
-              <a:solidFill>
-                <a:srgbClr val="1B3A72"/>
-              </a:solidFill>
-            </a:endParaRPr>
           </a:p>
         </p:txBody>
       </p:sp>
@@ -9627,11 +9154,6 @@
               </a:rPr>
               <a:t>beyond this paper's scope</a:t>
             </a:r>
-            <a:endParaRPr sz="1400" b="0" dirty="0">
-              <a:solidFill>
-                <a:srgbClr val="1A1A2E"/>
-              </a:solidFill>
-            </a:endParaRPr>
           </a:p>
         </p:txBody>
       </p:sp>
@@ -9675,6 +9197,7 @@
           <a:lstStyle/>
           <a:p>
             <a:pPr algn="ctr"/>
+            <a:endParaRPr/>
           </a:p>
         </p:txBody>
       </p:sp>
@@ -9709,11 +9232,6 @@
               </a:rPr>
               <a:t>We identify where the break is — regulators determine where the requirement should be set.</a:t>
             </a:r>
-            <a:endParaRPr sz="1800" b="1">
-              <a:solidFill>
-                <a:srgbClr val="FFFFFF"/>
-              </a:solidFill>
-            </a:endParaRPr>
           </a:p>
         </p:txBody>
       </p:sp>
@@ -9782,6 +9300,7 @@
           <a:lstStyle/>
           <a:p>
             <a:pPr algn="ctr"/>
+            <a:endParaRPr/>
           </a:p>
         </p:txBody>
       </p:sp>
@@ -9825,6 +9344,7 @@
           <a:lstStyle/>
           <a:p>
             <a:pPr algn="ctr"/>
+            <a:endParaRPr/>
           </a:p>
         </p:txBody>
       </p:sp>
@@ -9858,11 +9378,6 @@
               </a:rPr>
               <a:t>Conclusion: Navigating the New Triffin Dilemma</a:t>
             </a:r>
-            <a:endParaRPr sz="2600" b="0">
-              <a:solidFill>
-                <a:srgbClr val="FFFFFF"/>
-              </a:solidFill>
-            </a:endParaRPr>
           </a:p>
         </p:txBody>
       </p:sp>
@@ -9953,6 +9468,7 @@
           <a:lstStyle/>
           <a:p>
             <a:pPr algn="ctr"/>
+            <a:endParaRPr/>
           </a:p>
         </p:txBody>
       </p:sp>
@@ -9996,6 +9512,7 @@
           <a:lstStyle/>
           <a:p>
             <a:pPr algn="ctr"/>
+            <a:endParaRPr/>
           </a:p>
         </p:txBody>
       </p:sp>
@@ -10029,11 +9546,6 @@
               </a:rPr>
               <a:t>Result 1 — Privilege Amplification</a:t>
             </a:r>
-            <a:endParaRPr sz="1300" b="1">
-              <a:solidFill>
-                <a:srgbClr val="FFFFFF"/>
-              </a:solidFill>
-            </a:endParaRPr>
           </a:p>
         </p:txBody>
       </p:sp>
@@ -10070,11 +9582,6 @@
 Stablecoins mechanically deepen US safe-asset
 demand — amplifying the exorbitant privilege.</a:t>
             </a:r>
-            <a:endParaRPr sz="1600" b="0">
-              <a:solidFill>
-                <a:srgbClr val="1A1A2E"/>
-              </a:solidFill>
-            </a:endParaRPr>
           </a:p>
         </p:txBody>
       </p:sp>
@@ -10118,6 +9625,7 @@
           <a:lstStyle/>
           <a:p>
             <a:pPr algn="ctr"/>
+            <a:endParaRPr/>
           </a:p>
         </p:txBody>
       </p:sp>
@@ -10161,6 +9669,7 @@
           <a:lstStyle/>
           <a:p>
             <a:pPr algn="ctr"/>
+            <a:endParaRPr/>
           </a:p>
         </p:txBody>
       </p:sp>
@@ -10194,11 +9703,6 @@
               </a:rPr>
               <a:t>Result 2 — Safety Threshold</a:t>
             </a:r>
-            <a:endParaRPr sz="1300" b="1">
-              <a:solidFill>
-                <a:srgbClr val="FFFFFF"/>
-              </a:solidFill>
-            </a:endParaRPr>
           </a:p>
         </p:txBody>
       </p:sp>
@@ -10235,11 +9739,6 @@
 Below 13%: forced liquidation disrupts sovereign debt.
 Above 13%: redemptions absorbed, markets undisturbed.</a:t>
             </a:r>
-            <a:endParaRPr sz="1600" b="0">
-              <a:solidFill>
-                <a:srgbClr val="1A1A2E"/>
-              </a:solidFill>
-            </a:endParaRPr>
           </a:p>
         </p:txBody>
       </p:sp>
@@ -10283,6 +9782,7 @@
           <a:lstStyle/>
           <a:p>
             <a:pPr algn="ctr"/>
+            <a:endParaRPr/>
           </a:p>
         </p:txBody>
       </p:sp>
@@ -10326,6 +9826,7 @@
           <a:lstStyle/>
           <a:p>
             <a:pPr algn="ctr"/>
+            <a:endParaRPr/>
           </a:p>
         </p:txBody>
       </p:sp>
@@ -10359,11 +9860,6 @@
               </a:rPr>
               <a:t>Result 3 — Causal Evidence</a:t>
             </a:r>
-            <a:endParaRPr sz="1300" b="1">
-              <a:solidFill>
-                <a:srgbClr val="FFFFFF"/>
-              </a:solidFill>
-            </a:endParaRPr>
           </a:p>
         </p:txBody>
       </p:sp>
@@ -10447,11 +9943,6 @@
               <a:t>spread spike.
 High-buffer stress → −18 bp flight-to-safety.</a:t>
             </a:r>
-            <a:endParaRPr sz="1600" b="0">
-              <a:solidFill>
-                <a:srgbClr val="1A1A2E"/>
-              </a:solidFill>
-            </a:endParaRPr>
           </a:p>
         </p:txBody>
       </p:sp>
@@ -10495,6 +9986,7 @@
           <a:lstStyle/>
           <a:p>
             <a:pPr algn="ctr"/>
+            <a:endParaRPr/>
           </a:p>
         </p:txBody>
       </p:sp>
@@ -10529,11 +10021,6 @@
               </a:rPr>
               <a:t>Stablecoins help the US in normal times — and threaten it in stress. L is what separates the two.</a:t>
             </a:r>
-            <a:endParaRPr sz="1800" b="1">
-              <a:solidFill>
-                <a:srgbClr val="FFFFFF"/>
-              </a:solidFill>
-            </a:endParaRPr>
           </a:p>
         </p:txBody>
       </p:sp>
@@ -10579,14 +10066,14 @@
           <p:nvPr/>
         </p:nvPicPr>
         <p:blipFill>
-          <a:blip r:embed="rId1">
+          <a:blip r:embed="rId3">
             <a:lum bright="70000" contrast="-70000"/>
             <a:extLst>
               <a:ext uri="{BEBA8EAE-BF5A-486C-A8C5-ECC9F3942E4B}">
                 <a14:imgProps xmlns:a14="http://schemas.microsoft.com/office/drawing/2010/main">
-                  <a14:imgLayer r:embed="rId2">
+                  <a14:imgLayer r:embed="rId4">
                     <a14:imgEffect>
-                      <a14:artisticPhotocopy trans="30000" detail="2"/>
+                      <a14:artisticPhotocopy detail="2"/>
                     </a14:imgEffect>
                   </a14:imgLayer>
                 </a14:imgProps>
@@ -10706,11 +10193,6 @@
               </a:rPr>
               <a:t>Yonsei GSIS 2026-1 </a:t>
             </a:r>
-            <a:endParaRPr lang="en-US" altLang="ko-KR" sz="1800" b="1" dirty="0">
-              <a:solidFill>
-                <a:schemeClr val="bg1"/>
-              </a:solidFill>
-            </a:endParaRPr>
           </a:p>
           <a:p>
             <a:r>
@@ -11083,6 +10565,7 @@
       </a:style>
     </a:lnDef>
   </a:objectDefaults>
+  <a:extraClrSchemeLst/>
   <a:extLst>
     <a:ext uri="{05A4C25C-085E-4340-85A3-A5531E510DB2}">
       <thm15:themeFamily xmlns:thm15="http://schemas.microsoft.com/office/thememl/2012/main" name="Office Theme" id="{62F939B6-93AF-4DB8-9C6B-D6C7DFDC589F}" vid="{4A3C46E8-61CC-4603-A589-7422A47A8E4A}"/>
@@ -11363,6 +10846,7 @@
       </a:style>
     </a:lnDef>
   </a:objectDefaults>
+  <a:extraClrSchemeLst/>
   <a:extLst>
     <a:ext uri="{05A4C25C-085E-4340-85A3-A5531E510DB2}">
       <thm15:themeFamily xmlns:thm15="http://schemas.microsoft.com/office/thememl/2012/main" name="Office Theme" id="{62F939B6-93AF-4DB8-9C6B-D6C7DFDC589F}" vid="{4A3C46E8-61CC-4603-A589-7422A47A8E4A}"/>

</xml_diff>